<commit_message>
Verify original evidence, recover storage faults and refresh contest materials
</commit_message>
<xml_diff>
--- a/delivery/05-anonymous-defense.pptx
+++ b/delivery/05-anonymous-defense.pptx
@@ -2,28 +2,28 @@
 <file path=ppt/presentation.xml><?xml version="1.0" encoding="utf-8"?>
 <p:presentation xmlns:p="http://schemas.openxmlformats.org/presentationml/2006/main">
   <p:sldMasterIdLst>
-    <p:sldMasterId xmlns:r="http://schemas.openxmlformats.org/officeDocument/2006/relationships" id="2147483648" r:id="R8628185ed5ef4e5d"/>
+    <p:sldMasterId xmlns:r="http://schemas.openxmlformats.org/officeDocument/2006/relationships" id="2147483648" r:id="Rb3e4cfbd2eeb495d"/>
   </p:sldMasterIdLst>
   <p:notesMasterIdLst>
-    <p:notesMasterId xmlns:r="http://schemas.openxmlformats.org/officeDocument/2006/relationships" r:id="Rb59756c2c12e4c90"/>
+    <p:notesMasterId xmlns:r="http://schemas.openxmlformats.org/officeDocument/2006/relationships" r:id="R8381a4412e3548d4"/>
   </p:notesMasterIdLst>
   <p:sldIdLst>
-    <p:sldId xmlns:r="http://schemas.openxmlformats.org/officeDocument/2006/relationships" id="256" r:id="Rdc6efae745044ab1"/>
-    <p:sldId xmlns:r="http://schemas.openxmlformats.org/officeDocument/2006/relationships" id="257" r:id="Rd87685ebc7b94cdf"/>
-    <p:sldId xmlns:r="http://schemas.openxmlformats.org/officeDocument/2006/relationships" id="258" r:id="R1ad4ae5eda344d92"/>
-    <p:sldId xmlns:r="http://schemas.openxmlformats.org/officeDocument/2006/relationships" id="259" r:id="Rb274033f79cb4bee"/>
-    <p:sldId xmlns:r="http://schemas.openxmlformats.org/officeDocument/2006/relationships" id="260" r:id="R36ebd594d58f48ea"/>
-    <p:sldId xmlns:r="http://schemas.openxmlformats.org/officeDocument/2006/relationships" id="261" r:id="R543cf9c891e84d3a"/>
-    <p:sldId xmlns:r="http://schemas.openxmlformats.org/officeDocument/2006/relationships" id="262" r:id="R0e291c6a72dd4f80"/>
-    <p:sldId xmlns:r="http://schemas.openxmlformats.org/officeDocument/2006/relationships" id="263" r:id="R4909f148be1441a2"/>
-    <p:sldId xmlns:r="http://schemas.openxmlformats.org/officeDocument/2006/relationships" id="264" r:id="R3a5021d5fc9940df"/>
-    <p:sldId xmlns:r="http://schemas.openxmlformats.org/officeDocument/2006/relationships" id="265" r:id="R2b7a4e604f5242b0"/>
-    <p:sldId xmlns:r="http://schemas.openxmlformats.org/officeDocument/2006/relationships" id="266" r:id="R3360144bdc324e56"/>
-    <p:sldId xmlns:r="http://schemas.openxmlformats.org/officeDocument/2006/relationships" id="267" r:id="R4a4c018315cb4cef"/>
-    <p:sldId xmlns:r="http://schemas.openxmlformats.org/officeDocument/2006/relationships" id="268" r:id="R6b54069424fe471a"/>
-    <p:sldId xmlns:r="http://schemas.openxmlformats.org/officeDocument/2006/relationships" id="269" r:id="R227bb8343e2d443e"/>
-    <p:sldId xmlns:r="http://schemas.openxmlformats.org/officeDocument/2006/relationships" id="270" r:id="R4db6cc00dc7449af"/>
-    <p:sldId xmlns:r="http://schemas.openxmlformats.org/officeDocument/2006/relationships" id="271" r:id="R060ae6fe02294c0c"/>
+    <p:sldId xmlns:r="http://schemas.openxmlformats.org/officeDocument/2006/relationships" id="256" r:id="R73e98b2e37414b93"/>
+    <p:sldId xmlns:r="http://schemas.openxmlformats.org/officeDocument/2006/relationships" id="257" r:id="R8e062f51b48c4326"/>
+    <p:sldId xmlns:r="http://schemas.openxmlformats.org/officeDocument/2006/relationships" id="258" r:id="R964a5fe2ba484359"/>
+    <p:sldId xmlns:r="http://schemas.openxmlformats.org/officeDocument/2006/relationships" id="259" r:id="Rd1a1ed1bae5642b0"/>
+    <p:sldId xmlns:r="http://schemas.openxmlformats.org/officeDocument/2006/relationships" id="260" r:id="R561e6b9986024375"/>
+    <p:sldId xmlns:r="http://schemas.openxmlformats.org/officeDocument/2006/relationships" id="261" r:id="R6e996001829e4a36"/>
+    <p:sldId xmlns:r="http://schemas.openxmlformats.org/officeDocument/2006/relationships" id="262" r:id="R07660059119b4419"/>
+    <p:sldId xmlns:r="http://schemas.openxmlformats.org/officeDocument/2006/relationships" id="263" r:id="Rc18846d14dfe4560"/>
+    <p:sldId xmlns:r="http://schemas.openxmlformats.org/officeDocument/2006/relationships" id="264" r:id="Rf714aef349c34fc8"/>
+    <p:sldId xmlns:r="http://schemas.openxmlformats.org/officeDocument/2006/relationships" id="265" r:id="R2993407665794f3f"/>
+    <p:sldId xmlns:r="http://schemas.openxmlformats.org/officeDocument/2006/relationships" id="266" r:id="R0f22b0cfa2f84254"/>
+    <p:sldId xmlns:r="http://schemas.openxmlformats.org/officeDocument/2006/relationships" id="267" r:id="R4167a830e3d648e8"/>
+    <p:sldId xmlns:r="http://schemas.openxmlformats.org/officeDocument/2006/relationships" id="268" r:id="Rd8694f3ae236495c"/>
+    <p:sldId xmlns:r="http://schemas.openxmlformats.org/officeDocument/2006/relationships" id="269" r:id="R319d7c690ab44b93"/>
+    <p:sldId xmlns:r="http://schemas.openxmlformats.org/officeDocument/2006/relationships" id="270" r:id="R233ae3101b8240f9"/>
+    <p:sldId xmlns:r="http://schemas.openxmlformats.org/officeDocument/2006/relationships" id="271" r:id="R7a336842c5ba441c"/>
   </p:sldIdLst>
   <p:sldSz cx="12192000" cy="6858000"/>
   <p:notesSz cx="6858000" cy="9144000"/>
@@ -807,7 +807,7 @@
           <a:lstStyle xmlns:a="http://schemas.openxmlformats.org/drawingml/2006/main"/>
           <a:p xmlns:a="http://schemas.openxmlformats.org/drawingml/2006/main">
             <a:r>
-              <a:t>依据：实际网页五轮验证；session.py、docs/DEMO_SCRIPT.md。</a:t>
+              <a:t>依据：FAULT_RECOVERY_FIRST_RUN.json、FAULT_RECOVERY_REPORT.json、LOCAL_REGRESSION_REPORT.json。</a:t>
             </a:r>
           </a:p>
         </p:txBody>
@@ -1554,7 +1554,7 @@
           <p:cNvPr id="3" name="Title">
             <a:extLst xmlns:a="http://schemas.openxmlformats.org/drawingml/2006/main">
               <a:ext uri="{FF2B5EF4-FFF2-40B4-BE49-F238E27FC236}">
-                <a16:creationId xmlns:a16="http://schemas.microsoft.com/office/drawing/2014/main" id="{F29D2D2E-05D6-48DC-ADF4-8F01603B4820}"/>
+                <a16:creationId xmlns:a16="http://schemas.microsoft.com/office/drawing/2014/main" id="{AE0F6B7C-2419-4826-835B-FEBA10F6B0C7}"/>
               </a:ext>
             </a:extLst>
           </p:cNvPr>
@@ -1701,7 +1701,7 @@
           <p:cNvPr id="2" name="Subtitle">
             <a:extLst xmlns:a="http://schemas.openxmlformats.org/drawingml/2006/main">
               <a:ext uri="{FF2B5EF4-FFF2-40B4-BE49-F238E27FC236}">
-                <a16:creationId xmlns:a16="http://schemas.microsoft.com/office/drawing/2014/main" id="{5DA6FC20-15EC-4608-AB7C-03C2208D86FB}"/>
+                <a16:creationId xmlns:a16="http://schemas.microsoft.com/office/drawing/2014/main" id="{56A1051E-BF43-4CCA-A743-999C5E620550}"/>
               </a:ext>
             </a:extLst>
           </p:cNvPr>
@@ -1865,7 +1865,7 @@
           <p:cNvPr id="2" name="Section title">
             <a:extLst xmlns:a="http://schemas.openxmlformats.org/drawingml/2006/main">
               <a:ext uri="{FF2B5EF4-FFF2-40B4-BE49-F238E27FC236}">
-                <a16:creationId xmlns:a16="http://schemas.microsoft.com/office/drawing/2014/main" id="{30485F87-0EF8-419E-A6A6-936CAB8BA54E}"/>
+                <a16:creationId xmlns:a16="http://schemas.microsoft.com/office/drawing/2014/main" id="{5EF7ECAB-E85B-47A4-8E3D-FA755BF3B8A1}"/>
               </a:ext>
             </a:extLst>
           </p:cNvPr>
@@ -2029,7 +2029,7 @@
           <p:cNvPr id="3" name="Title">
             <a:extLst xmlns:a="http://schemas.openxmlformats.org/drawingml/2006/main">
               <a:ext uri="{FF2B5EF4-FFF2-40B4-BE49-F238E27FC236}">
-                <a16:creationId xmlns:a16="http://schemas.microsoft.com/office/drawing/2014/main" id="{31148F8E-8ABF-4544-A917-6C3B46A9BB75}"/>
+                <a16:creationId xmlns:a16="http://schemas.microsoft.com/office/drawing/2014/main" id="{722865D6-8C0A-45B7-858A-45C523914510}"/>
               </a:ext>
             </a:extLst>
           </p:cNvPr>
@@ -2176,7 +2176,7 @@
           <p:cNvPr id="2" name="Body">
             <a:extLst xmlns:a="http://schemas.openxmlformats.org/drawingml/2006/main">
               <a:ext uri="{FF2B5EF4-FFF2-40B4-BE49-F238E27FC236}">
-                <a16:creationId xmlns:a16="http://schemas.microsoft.com/office/drawing/2014/main" id="{A7CCCB23-CD9D-4253-B307-EE03C3CE5349}"/>
+                <a16:creationId xmlns:a16="http://schemas.microsoft.com/office/drawing/2014/main" id="{C68061A5-F1A1-483F-8B79-30387F247CBE}"/>
               </a:ext>
             </a:extLst>
           </p:cNvPr>
@@ -2340,7 +2340,7 @@
           <p:cNvPr id="4" name="Title">
             <a:extLst xmlns:a="http://schemas.openxmlformats.org/drawingml/2006/main">
               <a:ext uri="{FF2B5EF4-FFF2-40B4-BE49-F238E27FC236}">
-                <a16:creationId xmlns:a16="http://schemas.microsoft.com/office/drawing/2014/main" id="{E2FF6A21-911F-49AD-859C-51F0ABEDFA25}"/>
+                <a16:creationId xmlns:a16="http://schemas.microsoft.com/office/drawing/2014/main" id="{037BEDA6-EC61-4B72-A776-E880BAB852CE}"/>
               </a:ext>
             </a:extLst>
           </p:cNvPr>
@@ -2487,7 +2487,7 @@
           <p:cNvPr id="2" name="Left column">
             <a:extLst xmlns:a="http://schemas.openxmlformats.org/drawingml/2006/main">
               <a:ext uri="{FF2B5EF4-FFF2-40B4-BE49-F238E27FC236}">
-                <a16:creationId xmlns:a16="http://schemas.microsoft.com/office/drawing/2014/main" id="{FF206CC6-48A8-4A99-B5E4-40673C2722D6}"/>
+                <a16:creationId xmlns:a16="http://schemas.microsoft.com/office/drawing/2014/main" id="{B06C0EDC-61F5-497E-90D3-4311EE71D087}"/>
               </a:ext>
             </a:extLst>
           </p:cNvPr>
@@ -2634,7 +2634,7 @@
           <p:cNvPr id="3" name="Right column">
             <a:extLst xmlns:a="http://schemas.openxmlformats.org/drawingml/2006/main">
               <a:ext uri="{FF2B5EF4-FFF2-40B4-BE49-F238E27FC236}">
-                <a16:creationId xmlns:a16="http://schemas.microsoft.com/office/drawing/2014/main" id="{70F839D1-B8E7-495F-B66E-739B878CF34E}"/>
+                <a16:creationId xmlns:a16="http://schemas.microsoft.com/office/drawing/2014/main" id="{10AE1147-142E-4A46-B86C-14350FE4C5E0}"/>
               </a:ext>
             </a:extLst>
           </p:cNvPr>
@@ -2798,7 +2798,7 @@
           <p:cNvPr id="3" name="Title">
             <a:extLst xmlns:a="http://schemas.openxmlformats.org/drawingml/2006/main">
               <a:ext uri="{FF2B5EF4-FFF2-40B4-BE49-F238E27FC236}">
-                <a16:creationId xmlns:a16="http://schemas.microsoft.com/office/drawing/2014/main" id="{97B7A80D-E6F8-43CB-8137-54A22B5BB31A}"/>
+                <a16:creationId xmlns:a16="http://schemas.microsoft.com/office/drawing/2014/main" id="{A8545B46-E007-4966-BC90-556A4280287D}"/>
               </a:ext>
             </a:extLst>
           </p:cNvPr>
@@ -2945,7 +2945,7 @@
           <p:cNvPr id="2" name="Left column">
             <a:extLst xmlns:a="http://schemas.openxmlformats.org/drawingml/2006/main">
               <a:ext uri="{FF2B5EF4-FFF2-40B4-BE49-F238E27FC236}">
-                <a16:creationId xmlns:a16="http://schemas.microsoft.com/office/drawing/2014/main" id="{1DC5BE03-9057-42AE-A42D-371FE10187B5}"/>
+                <a16:creationId xmlns:a16="http://schemas.microsoft.com/office/drawing/2014/main" id="{233F1279-0E6D-4B05-8E4B-FB0DE7E34922}"/>
               </a:ext>
             </a:extLst>
           </p:cNvPr>
@@ -3130,12 +3130,12 @@
   </p:cSld>
   <p:clrMap bg1="lt1" tx1="dk1" bg2="lt2" tx2="dk2" accent1="accent1" accent2="accent2" accent3="accent3" accent4="accent4" accent5="accent5" accent6="accent6" hlink="hlink" folHlink="folHlink"/>
   <p:sldLayoutIdLst>
-    <p:sldLayoutId xmlns:r="http://schemas.openxmlformats.org/officeDocument/2006/relationships" id="2147483649" r:id="R51f79ba16a0e4119"/>
-    <p:sldLayoutId xmlns:r="http://schemas.openxmlformats.org/officeDocument/2006/relationships" id="2147483650" r:id="R80656e87a8ca4176"/>
-    <p:sldLayoutId xmlns:r="http://schemas.openxmlformats.org/officeDocument/2006/relationships" id="2147483651" r:id="R9f780f328123400f"/>
-    <p:sldLayoutId xmlns:r="http://schemas.openxmlformats.org/officeDocument/2006/relationships" id="2147483652" r:id="Ra774fa23e040435b"/>
-    <p:sldLayoutId xmlns:r="http://schemas.openxmlformats.org/officeDocument/2006/relationships" id="2147483653" r:id="R5b7754fb7d7e4a8b"/>
-    <p:sldLayoutId xmlns:r="http://schemas.openxmlformats.org/officeDocument/2006/relationships" id="2147483654" r:id="R7df47dfa2d954b8d"/>
+    <p:sldLayoutId xmlns:r="http://schemas.openxmlformats.org/officeDocument/2006/relationships" id="2147483649" r:id="Rf02375ae7a07427b"/>
+    <p:sldLayoutId xmlns:r="http://schemas.openxmlformats.org/officeDocument/2006/relationships" id="2147483650" r:id="Rae0781bd4fbb43c3"/>
+    <p:sldLayoutId xmlns:r="http://schemas.openxmlformats.org/officeDocument/2006/relationships" id="2147483651" r:id="Rc3416471717d449d"/>
+    <p:sldLayoutId xmlns:r="http://schemas.openxmlformats.org/officeDocument/2006/relationships" id="2147483652" r:id="R5f645ec8d130476b"/>
+    <p:sldLayoutId xmlns:r="http://schemas.openxmlformats.org/officeDocument/2006/relationships" id="2147483653" r:id="R31929f195d73447a"/>
+    <p:sldLayoutId xmlns:r="http://schemas.openxmlformats.org/officeDocument/2006/relationships" id="2147483654" r:id="R8999fcee88e243fc"/>
   </p:sldLayoutIdLst>
   <p:txStyles>
     <p:titleStyle>
@@ -3847,7 +3847,7 @@
           <p:cNvPr id="4" name="">
             <a:extLst xmlns:a="http://schemas.openxmlformats.org/drawingml/2006/main">
               <a:ext uri="{FF2B5EF4-FFF2-40B4-BE49-F238E27FC236}">
-                <a16:creationId xmlns:a16="http://schemas.microsoft.com/office/drawing/2014/main" id="{869459CC-02E0-4212-9344-8D0769FFEAC8}"/>
+                <a16:creationId xmlns:a16="http://schemas.microsoft.com/office/drawing/2014/main" id="{9573D581-C1F5-415E-81A3-471B3A84DF3E}"/>
               </a:ext>
             </a:extLst>
           </p:cNvPr>
@@ -3904,7 +3904,7 @@
           <p:cNvPr id="2" name="">
             <a:extLst xmlns:a="http://schemas.openxmlformats.org/drawingml/2006/main">
               <a:ext uri="{FF2B5EF4-FFF2-40B4-BE49-F238E27FC236}">
-                <a16:creationId xmlns:a16="http://schemas.microsoft.com/office/drawing/2014/main" id="{7BD87883-DF22-474D-AA14-CBCB4DB53727}"/>
+                <a16:creationId xmlns:a16="http://schemas.microsoft.com/office/drawing/2014/main" id="{4BF3EB0D-7BA8-4E57-B52C-02EBF6C68637}"/>
               </a:ext>
             </a:extLst>
           </p:cNvPr>
@@ -3984,7 +3984,7 @@
           <p:cNvPr id="3" name="">
             <a:extLst xmlns:a="http://schemas.openxmlformats.org/drawingml/2006/main">
               <a:ext uri="{FF2B5EF4-FFF2-40B4-BE49-F238E27FC236}">
-                <a16:creationId xmlns:a16="http://schemas.microsoft.com/office/drawing/2014/main" id="{8394B8E8-D5B7-405C-A478-20CE3C85884E}"/>
+                <a16:creationId xmlns:a16="http://schemas.microsoft.com/office/drawing/2014/main" id="{8D7322A4-F83E-4363-AA70-A9EC2DA44EA4}"/>
               </a:ext>
             </a:extLst>
           </p:cNvPr>
@@ -4039,7 +4039,7 @@
     </p:spTree>
     <p:extLst>
       <p:ext uri="{BB962C8B-B14F-4D97-AF65-F5344CB8AC3E}">
-        <p14:creationId xmlns:p14="http://schemas.microsoft.com/office/powerpoint/2010/main" val="273384980"/>
+        <p14:creationId xmlns:p14="http://schemas.microsoft.com/office/powerpoint/2010/main" val="1566871"/>
       </p:ext>
     </p:extLst>
   </p:cSld>
@@ -4070,7 +4070,7 @@
           <p:cNvPr id="10" name="">
             <a:extLst xmlns:a="http://schemas.openxmlformats.org/drawingml/2006/main">
               <a:ext uri="{FF2B5EF4-FFF2-40B4-BE49-F238E27FC236}">
-                <a16:creationId xmlns:a16="http://schemas.microsoft.com/office/drawing/2014/main" id="{48F1EAA7-06E0-42D9-953E-6469D89A8A54}"/>
+                <a16:creationId xmlns:a16="http://schemas.microsoft.com/office/drawing/2014/main" id="{F7932547-1ECE-4CA9-A902-8771B7B7139A}"/>
               </a:ext>
             </a:extLst>
           </p:cNvPr>
@@ -4127,7 +4127,7 @@
           <p:cNvPr id="2" name="">
             <a:extLst xmlns:a="http://schemas.openxmlformats.org/drawingml/2006/main">
               <a:ext uri="{FF2B5EF4-FFF2-40B4-BE49-F238E27FC236}">
-                <a16:creationId xmlns:a16="http://schemas.microsoft.com/office/drawing/2014/main" id="{C6B50D6C-8987-464C-A7A2-300CBAF576F9}"/>
+                <a16:creationId xmlns:a16="http://schemas.microsoft.com/office/drawing/2014/main" id="{C1FF683A-AD93-41F5-B6E7-E794F15E6811}"/>
               </a:ext>
             </a:extLst>
           </p:cNvPr>
@@ -4184,7 +4184,7 @@
           <p:cNvPr id="3" name="">
             <a:extLst xmlns:a="http://schemas.openxmlformats.org/drawingml/2006/main">
               <a:ext uri="{FF2B5EF4-FFF2-40B4-BE49-F238E27FC236}">
-                <a16:creationId xmlns:a16="http://schemas.microsoft.com/office/drawing/2014/main" id="{1664BA9F-7A2A-41D0-A763-292C83182BF2}"/>
+                <a16:creationId xmlns:a16="http://schemas.microsoft.com/office/drawing/2014/main" id="{C0F72586-BCC6-421C-A575-37C7BA5E0564}"/>
               </a:ext>
             </a:extLst>
           </p:cNvPr>
@@ -4241,7 +4241,7 @@
           <p:cNvPr id="4" name="">
             <a:extLst xmlns:a="http://schemas.openxmlformats.org/drawingml/2006/main">
               <a:ext uri="{FF2B5EF4-FFF2-40B4-BE49-F238E27FC236}">
-                <a16:creationId xmlns:a16="http://schemas.microsoft.com/office/drawing/2014/main" id="{189C1093-878F-43AB-9531-EF51A2DF65CB}"/>
+                <a16:creationId xmlns:a16="http://schemas.microsoft.com/office/drawing/2014/main" id="{C4C4C21A-6EAD-4CE8-945E-6711F53D2B7B}"/>
               </a:ext>
             </a:extLst>
           </p:cNvPr>
@@ -4298,7 +4298,7 @@
           <p:cNvPr id="5" name="">
             <a:extLst xmlns:a="http://schemas.openxmlformats.org/drawingml/2006/main">
               <a:ext uri="{FF2B5EF4-FFF2-40B4-BE49-F238E27FC236}">
-                <a16:creationId xmlns:a16="http://schemas.microsoft.com/office/drawing/2014/main" id="{635D5F85-58EE-4071-91D1-488D67AF4458}"/>
+                <a16:creationId xmlns:a16="http://schemas.microsoft.com/office/drawing/2014/main" id="{A8E54153-9EB5-4DBB-99DA-718DDA6179BC}"/>
               </a:ext>
             </a:extLst>
           </p:cNvPr>
@@ -4355,7 +4355,7 @@
           <p:cNvPr id="6" name="">
             <a:extLst xmlns:a="http://schemas.openxmlformats.org/drawingml/2006/main">
               <a:ext uri="{FF2B5EF4-FFF2-40B4-BE49-F238E27FC236}">
-                <a16:creationId xmlns:a16="http://schemas.microsoft.com/office/drawing/2014/main" id="{9E472854-68E0-469D-9442-150D13283DFF}"/>
+                <a16:creationId xmlns:a16="http://schemas.microsoft.com/office/drawing/2014/main" id="{78123FCF-451A-47A7-A70C-0E5F8EF0A4E9}"/>
               </a:ext>
             </a:extLst>
           </p:cNvPr>
@@ -4412,7 +4412,7 @@
           <p:cNvPr id="7" name="">
             <a:extLst xmlns:a="http://schemas.openxmlformats.org/drawingml/2006/main">
               <a:ext uri="{FF2B5EF4-FFF2-40B4-BE49-F238E27FC236}">
-                <a16:creationId xmlns:a16="http://schemas.microsoft.com/office/drawing/2014/main" id="{1BE8F5CF-C101-4189-8742-984858FE87B4}"/>
+                <a16:creationId xmlns:a16="http://schemas.microsoft.com/office/drawing/2014/main" id="{4750DF89-DDA8-4668-834B-936A696BCD4F}"/>
               </a:ext>
             </a:extLst>
           </p:cNvPr>
@@ -4469,7 +4469,7 @@
           <p:cNvPr id="8" name="">
             <a:extLst xmlns:a="http://schemas.openxmlformats.org/drawingml/2006/main">
               <a:ext uri="{FF2B5EF4-FFF2-40B4-BE49-F238E27FC236}">
-                <a16:creationId xmlns:a16="http://schemas.microsoft.com/office/drawing/2014/main" id="{D14C61D3-B4FC-4880-9BB4-0663DC269D76}"/>
+                <a16:creationId xmlns:a16="http://schemas.microsoft.com/office/drawing/2014/main" id="{A4585684-5E0C-4EFB-B282-66EF67715EC8}"/>
               </a:ext>
             </a:extLst>
           </p:cNvPr>
@@ -4526,7 +4526,7 @@
           <p:cNvPr id="9" name="">
             <a:extLst xmlns:a="http://schemas.openxmlformats.org/drawingml/2006/main">
               <a:ext uri="{FF2B5EF4-FFF2-40B4-BE49-F238E27FC236}">
-                <a16:creationId xmlns:a16="http://schemas.microsoft.com/office/drawing/2014/main" id="{A56E609B-4B7A-4351-8787-CD894B06CBBB}"/>
+                <a16:creationId xmlns:a16="http://schemas.microsoft.com/office/drawing/2014/main" id="{38CD8600-BE26-437A-9238-995797DEBBE0}"/>
               </a:ext>
             </a:extLst>
           </p:cNvPr>
@@ -4581,7 +4581,7 @@
     </p:spTree>
     <p:extLst>
       <p:ext uri="{BB962C8B-B14F-4D97-AF65-F5344CB8AC3E}">
-        <p14:creationId xmlns:p14="http://schemas.microsoft.com/office/powerpoint/2010/main" val="1352224888"/>
+        <p14:creationId xmlns:p14="http://schemas.microsoft.com/office/powerpoint/2010/main" val="813912126"/>
       </p:ext>
     </p:extLst>
   </p:cSld>
@@ -4612,7 +4612,7 @@
           <p:cNvPr id="4" name="">
             <a:extLst xmlns:a="http://schemas.openxmlformats.org/drawingml/2006/main">
               <a:ext uri="{FF2B5EF4-FFF2-40B4-BE49-F238E27FC236}">
-                <a16:creationId xmlns:a16="http://schemas.microsoft.com/office/drawing/2014/main" id="{CC5EFE32-D459-4CD7-BD99-CFF695A05BEF}"/>
+                <a16:creationId xmlns:a16="http://schemas.microsoft.com/office/drawing/2014/main" id="{117F83EC-D6A3-4B18-8C1F-3E8811EA0B7F}"/>
               </a:ext>
             </a:extLst>
           </p:cNvPr>
@@ -5136,7 +5136,7 @@
           <p:cNvPr id="3" name="">
             <a:extLst xmlns:a="http://schemas.openxmlformats.org/drawingml/2006/main">
               <a:ext uri="{FF2B5EF4-FFF2-40B4-BE49-F238E27FC236}">
-                <a16:creationId xmlns:a16="http://schemas.microsoft.com/office/drawing/2014/main" id="{80405863-C351-488F-AD8B-07610A8E1FE4}"/>
+                <a16:creationId xmlns:a16="http://schemas.microsoft.com/office/drawing/2014/main" id="{29BB685C-5B72-4A92-BB88-15896C007CFD}"/>
               </a:ext>
             </a:extLst>
           </p:cNvPr>
@@ -5191,7 +5191,7 @@
     </p:spTree>
     <p:extLst>
       <p:ext uri="{BB962C8B-B14F-4D97-AF65-F5344CB8AC3E}">
-        <p14:creationId xmlns:p14="http://schemas.microsoft.com/office/powerpoint/2010/main" val="1605762279"/>
+        <p14:creationId xmlns:p14="http://schemas.microsoft.com/office/powerpoint/2010/main" val="49570744"/>
       </p:ext>
     </p:extLst>
   </p:cSld>
@@ -5222,7 +5222,7 @@
           <p:cNvPr id="4" name="">
             <a:extLst xmlns:a="http://schemas.openxmlformats.org/drawingml/2006/main">
               <a:ext uri="{FF2B5EF4-FFF2-40B4-BE49-F238E27FC236}">
-                <a16:creationId xmlns:a16="http://schemas.microsoft.com/office/drawing/2014/main" id="{B17B7094-4199-44F5-ACD1-5E00131BC0F9}"/>
+                <a16:creationId xmlns:a16="http://schemas.microsoft.com/office/drawing/2014/main" id="{F41A84B1-8D2B-41CA-8806-DEC9AB60CE2D}"/>
               </a:ext>
             </a:extLst>
           </p:cNvPr>
@@ -5286,7 +5286,7 @@
         </p:xfrm>
         <a:graphic xmlns:a="http://schemas.openxmlformats.org/drawingml/2006/main">
           <a:graphicData uri="http://schemas.openxmlformats.org/drawingml/2006/chart">
-            <c:chart xmlns:r="http://schemas.openxmlformats.org/officeDocument/2006/relationships" xmlns:c="http://schemas.openxmlformats.org/drawingml/2006/chart" r:id="Rfd32547e3b6e44b5"/>
+            <c:chart xmlns:r="http://schemas.openxmlformats.org/officeDocument/2006/relationships" xmlns:c="http://schemas.openxmlformats.org/drawingml/2006/chart" r:id="Rd1234f2219454977"/>
           </a:graphicData>
         </a:graphic>
       </p:graphicFrame>
@@ -5295,7 +5295,7 @@
           <p:cNvPr id="3" name="">
             <a:extLst xmlns:a="http://schemas.openxmlformats.org/drawingml/2006/main">
               <a:ext uri="{FF2B5EF4-FFF2-40B4-BE49-F238E27FC236}">
-                <a16:creationId xmlns:a16="http://schemas.microsoft.com/office/drawing/2014/main" id="{656ACAE7-A590-4F1F-9CA6-BAAE4B9A8CF0}"/>
+                <a16:creationId xmlns:a16="http://schemas.microsoft.com/office/drawing/2014/main" id="{626B806A-7200-4485-B10B-81C29D35DE65}"/>
               </a:ext>
             </a:extLst>
           </p:cNvPr>
@@ -5350,7 +5350,7 @@
     </p:spTree>
     <p:extLst>
       <p:ext uri="{BB962C8B-B14F-4D97-AF65-F5344CB8AC3E}">
-        <p14:creationId xmlns:p14="http://schemas.microsoft.com/office/powerpoint/2010/main" val="734974537"/>
+        <p14:creationId xmlns:p14="http://schemas.microsoft.com/office/powerpoint/2010/main" val="43592801"/>
       </p:ext>
     </p:extLst>
   </p:cSld>
@@ -5381,7 +5381,7 @@
           <p:cNvPr id="5" name="">
             <a:extLst xmlns:a="http://schemas.openxmlformats.org/drawingml/2006/main">
               <a:ext uri="{FF2B5EF4-FFF2-40B4-BE49-F238E27FC236}">
-                <a16:creationId xmlns:a16="http://schemas.microsoft.com/office/drawing/2014/main" id="{2525C28B-01B6-4DF5-9421-97CA0D0FCC8C}"/>
+                <a16:creationId xmlns:a16="http://schemas.microsoft.com/office/drawing/2014/main" id="{F7B44107-A0CA-4BEC-938F-7C4DB905523B}"/>
               </a:ext>
             </a:extLst>
           </p:cNvPr>
@@ -5614,7 +5614,7 @@
                           <a:ea typeface="Microsoft YaHei"/>
                           <a:cs typeface="Microsoft YaHei"/>
                         </a:rPr>
-                        <a:t>19.093</a:t>
+                        <a:t>21.154</a:t>
                       </a:r>
                     </a:p>
                   </a:txBody>
@@ -5638,7 +5638,7 @@
                           <a:ea typeface="Microsoft YaHei"/>
                           <a:cs typeface="Microsoft YaHei"/>
                         </a:rPr>
-                        <a:t>19.575</a:t>
+                        <a:t>21.897</a:t>
                       </a:r>
                     </a:p>
                   </a:txBody>
@@ -5712,7 +5712,7 @@
                           <a:ea typeface="Microsoft YaHei"/>
                           <a:cs typeface="Microsoft YaHei"/>
                         </a:rPr>
-                        <a:t>109.542</a:t>
+                        <a:t>113.635</a:t>
                       </a:r>
                     </a:p>
                   </a:txBody>
@@ -5736,7 +5736,7 @@
                           <a:ea typeface="Microsoft YaHei"/>
                           <a:cs typeface="Microsoft YaHei"/>
                         </a:rPr>
-                        <a:t>115.637</a:t>
+                        <a:t>134.712</a:t>
                       </a:r>
                     </a:p>
                   </a:txBody>
@@ -5810,7 +5810,7 @@
                           <a:ea typeface="Microsoft YaHei"/>
                           <a:cs typeface="Microsoft YaHei"/>
                         </a:rPr>
-                        <a:t>541.472</a:t>
+                        <a:t>523.822</a:t>
                       </a:r>
                     </a:p>
                   </a:txBody>
@@ -5834,7 +5834,7 @@
                           <a:ea typeface="Microsoft YaHei"/>
                           <a:cs typeface="Microsoft YaHei"/>
                         </a:rPr>
-                        <a:t>616.101</a:t>
+                        <a:t>618.806</a:t>
                       </a:r>
                     </a:p>
                   </a:txBody>
@@ -5854,7 +5854,7 @@
           <p:cNvPr id="3" name="">
             <a:extLst xmlns:a="http://schemas.openxmlformats.org/drawingml/2006/main">
               <a:ext uri="{FF2B5EF4-FFF2-40B4-BE49-F238E27FC236}">
-                <a16:creationId xmlns:a16="http://schemas.microsoft.com/office/drawing/2014/main" id="{1FC1AA01-90F6-414B-8684-A1FB59E876D0}"/>
+                <a16:creationId xmlns:a16="http://schemas.microsoft.com/office/drawing/2014/main" id="{9FCA9386-C7CE-4F03-9029-8B7CCA03F82A}"/>
               </a:ext>
             </a:extLst>
           </p:cNvPr>
@@ -5901,7 +5901,7 @@
                 <a:ea typeface="Microsoft YaHei"/>
                 <a:cs typeface="Microsoft YaHei"/>
               </a:rPr>
-              <a:t>500页首次全局回答约16.1秒</a:t>
+              <a:t>500页首次全局回答 5.390 秒</a:t>
             </a:r>
           </a:p>
         </p:txBody>
@@ -5911,7 +5911,7 @@
           <p:cNvPr id="4" name="">
             <a:extLst xmlns:a="http://schemas.openxmlformats.org/drawingml/2006/main">
               <a:ext uri="{FF2B5EF4-FFF2-40B4-BE49-F238E27FC236}">
-                <a16:creationId xmlns:a16="http://schemas.microsoft.com/office/drawing/2014/main" id="{D2BF434B-DB33-49BB-B1C9-CCCEB386C57E}"/>
+                <a16:creationId xmlns:a16="http://schemas.microsoft.com/office/drawing/2014/main" id="{349F24B4-7F1F-4476-8C74-3217C874BE6F}"/>
               </a:ext>
             </a:extLst>
           </p:cNvPr>
@@ -5958,7 +5958,7 @@
                 <a:ea typeface="Microsoft YaHei"/>
                 <a:cs typeface="Microsoft YaHei"/>
               </a:rPr>
-              <a:t>冷编码、热缓存、编号查询与全局语义分别报告</a:t>
+              <a:t>首次全局编码与热缓存单列，非新进程完整冷启动</a:t>
             </a:r>
           </a:p>
         </p:txBody>
@@ -5966,7 +5966,7 @@
     </p:spTree>
     <p:extLst>
       <p:ext uri="{BB962C8B-B14F-4D97-AF65-F5344CB8AC3E}">
-        <p14:creationId xmlns:p14="http://schemas.microsoft.com/office/powerpoint/2010/main" val="1536852831"/>
+        <p14:creationId xmlns:p14="http://schemas.microsoft.com/office/powerpoint/2010/main" val="872316774"/>
       </p:ext>
     </p:extLst>
   </p:cSld>
@@ -5994,10 +5994,10 @@
       </p:grpSpPr>
       <p:sp>
         <p:nvSpPr>
-          <p:cNvPr id="6" name="">
+          <p:cNvPr id="10" name="">
             <a:extLst xmlns:a="http://schemas.openxmlformats.org/drawingml/2006/main">
               <a:ext uri="{FF2B5EF4-FFF2-40B4-BE49-F238E27FC236}">
-                <a16:creationId xmlns:a16="http://schemas.microsoft.com/office/drawing/2014/main" id="{788B87A9-987F-48A8-97E8-C0E224834525}"/>
+                <a16:creationId xmlns:a16="http://schemas.microsoft.com/office/drawing/2014/main" id="{DA8330FC-4B9B-4C48-944B-3826ED403B71}"/>
               </a:ext>
             </a:extLst>
           </p:cNvPr>
@@ -6044,7 +6044,7 @@
                 <a:ea typeface="Microsoft YaHei"/>
                 <a:cs typeface="Microsoft YaHei"/>
               </a:rPr>
-              <a:t>五轮会话与失败恢复</a:t>
+              <a:t>五轮会话与实际故障恢复</a:t>
             </a:r>
           </a:p>
         </p:txBody>
@@ -6054,7 +6054,7 @@
           <p:cNvPr id="2" name="">
             <a:extLst xmlns:a="http://schemas.openxmlformats.org/drawingml/2006/main">
               <a:ext uri="{FF2B5EF4-FFF2-40B4-BE49-F238E27FC236}">
-                <a16:creationId xmlns:a16="http://schemas.microsoft.com/office/drawing/2014/main" id="{BA67A67D-2D01-4C8E-8C0B-97A6E7B0696E}"/>
+                <a16:creationId xmlns:a16="http://schemas.microsoft.com/office/drawing/2014/main" id="{70CCF2EB-A069-4568-A74E-81368BF6A35B}"/>
               </a:ext>
             </a:extLst>
           </p:cNvPr>
@@ -6065,8 +6065,8 @@
         </p:nvSpPr>
         <p:spPr>
           <a:xfrm xmlns:a="http://schemas.openxmlformats.org/drawingml/2006/main">
-            <a:off x="723900" y="1524000"/>
-            <a:ext cx="10744200" cy="742950"/>
+            <a:off x="723900" y="1600200"/>
+            <a:ext cx="2952750" cy="685800"/>
           </a:xfrm>
           <a:prstGeom xmlns:a="http://schemas.openxmlformats.org/drawingml/2006/main" prst="rect">
             <a:avLst/>
@@ -6083,7 +6083,7 @@
           <a:lstStyle xmlns:a="http://schemas.openxmlformats.org/drawingml/2006/main"/>
           <a:p xmlns:a="http://schemas.openxmlformats.org/drawingml/2006/main">
             <a:pPr>
-              <a:defRPr sz="2475" b="1">
+              <a:defRPr sz="2175" b="1">
                 <a:solidFill>
                   <a:srgbClr val="176B87"/>
                 </a:solidFill>
@@ -6093,7 +6093,7 @@
               </a:defRPr>
             </a:pPr>
             <a:r>
-              <a:rPr sz="2475" b="1">
+              <a:rPr sz="2175" b="1">
                 <a:solidFill>
                   <a:srgbClr val="176B87"/>
                 </a:solidFill>
@@ -6101,7 +6101,7 @@
                 <a:ea typeface="Microsoft YaHei"/>
                 <a:cs typeface="Microsoft YaHei"/>
               </a:rPr>
-              <a:t>2025华东 → 华南 → 2024 → 订单数 → 华北</a:t>
+              <a:t>五轮硬重启</a:t>
             </a:r>
           </a:p>
         </p:txBody>
@@ -6111,7 +6111,7 @@
           <p:cNvPr id="3" name="">
             <a:extLst xmlns:a="http://schemas.openxmlformats.org/drawingml/2006/main">
               <a:ext uri="{FF2B5EF4-FFF2-40B4-BE49-F238E27FC236}">
-                <a16:creationId xmlns:a16="http://schemas.microsoft.com/office/drawing/2014/main" id="{C542E6B2-F73C-403D-9CB2-15E3EE6E0047}"/>
+                <a16:creationId xmlns:a16="http://schemas.microsoft.com/office/drawing/2014/main" id="{7856278A-9479-44C5-81AF-93783077E62C}"/>
               </a:ext>
             </a:extLst>
           </p:cNvPr>
@@ -6122,8 +6122,8 @@
         </p:nvSpPr>
         <p:spPr>
           <a:xfrm xmlns:a="http://schemas.openxmlformats.org/drawingml/2006/main">
-            <a:off x="723900" y="2505075"/>
-            <a:ext cx="10744200" cy="781050"/>
+            <a:off x="3905250" y="1600200"/>
+            <a:ext cx="7524750" cy="762000"/>
           </a:xfrm>
           <a:prstGeom xmlns:a="http://schemas.openxmlformats.org/drawingml/2006/main" prst="rect">
             <a:avLst/>
@@ -6140,7 +6140,7 @@
           <a:lstStyle xmlns:a="http://schemas.openxmlformats.org/drawingml/2006/main"/>
           <a:p xmlns:a="http://schemas.openxmlformats.org/drawingml/2006/main">
             <a:pPr>
-              <a:defRPr sz="2925" b="1">
+              <a:defRPr sz="2100" b="0">
                 <a:solidFill>
                   <a:srgbClr val="162B3C"/>
                 </a:solidFill>
@@ -6150,7 +6150,7 @@
               </a:defRPr>
             </a:pPr>
             <a:r>
-              <a:rPr sz="2925" b="1">
+              <a:rPr sz="2100" b="0">
                 <a:solidFill>
                   <a:srgbClr val="162B3C"/>
                 </a:solidFill>
@@ -6158,7 +6158,7 @@
                 <a:ea typeface="Microsoft YaHei"/>
                 <a:cs typeface="Microsoft YaHei"/>
               </a:rPr>
-              <a:t>29584 → 22992 → 4998 → 1 → 1</a:t>
+              <a:t>kill子服务后恢复：29584 / 22992 / 4998 / 1 / 1</a:t>
             </a:r>
           </a:p>
         </p:txBody>
@@ -6168,7 +6168,7 @@
           <p:cNvPr id="4" name="">
             <a:extLst xmlns:a="http://schemas.openxmlformats.org/drawingml/2006/main">
               <a:ext uri="{FF2B5EF4-FFF2-40B4-BE49-F238E27FC236}">
-                <a16:creationId xmlns:a16="http://schemas.microsoft.com/office/drawing/2014/main" id="{ED8A3EF5-C4F3-43CA-8EAB-8B2F00A9A93D}"/>
+                <a16:creationId xmlns:a16="http://schemas.microsoft.com/office/drawing/2014/main" id="{C7444F94-4167-444C-BDA1-648409EE1E12}"/>
               </a:ext>
             </a:extLst>
           </p:cNvPr>
@@ -6179,8 +6179,8 @@
         </p:nvSpPr>
         <p:spPr>
           <a:xfrm xmlns:a="http://schemas.openxmlformats.org/drawingml/2006/main">
-            <a:off x="723900" y="3762375"/>
-            <a:ext cx="10744200" cy="904875"/>
+            <a:off x="723900" y="2590800"/>
+            <a:ext cx="2952750" cy="685800"/>
           </a:xfrm>
           <a:prstGeom xmlns:a="http://schemas.openxmlformats.org/drawingml/2006/main" prst="rect">
             <a:avLst/>
@@ -6197,9 +6197,9 @@
           <a:lstStyle xmlns:a="http://schemas.openxmlformats.org/drawingml/2006/main"/>
           <a:p xmlns:a="http://schemas.openxmlformats.org/drawingml/2006/main">
             <a:pPr>
-              <a:defRPr sz="2250" b="0">
-                <a:solidFill>
-                  <a:srgbClr val="162B3C"/>
+              <a:defRPr sz="2175" b="1">
+                <a:solidFill>
+                  <a:srgbClr val="176B87"/>
                 </a:solidFill>
                 <a:latin typeface="Microsoft YaHei"/>
                 <a:ea typeface="Microsoft YaHei"/>
@@ -6207,15 +6207,15 @@
               </a:defRPr>
             </a:pPr>
             <a:r>
-              <a:rPr sz="2250" b="0">
-                <a:solidFill>
-                  <a:srgbClr val="162B3C"/>
+              <a:rPr sz="2175" b="1">
+                <a:solidFill>
+                  <a:srgbClr val="176B87"/>
                 </a:solidFill>
                 <a:latin typeface="Microsoft YaHei"/>
                 <a:ea typeface="Microsoft YaHei"/>
                 <a:cs typeface="Microsoft YaHei"/>
               </a:rPr>
-              <a:t>SQLite保存结构化槽位；重启恢复，主题变化清空旧条件</a:t>
+              <a:t>澄清与会话锁</a:t>
             </a:r>
           </a:p>
         </p:txBody>
@@ -6225,7 +6225,7 @@
           <p:cNvPr id="5" name="">
             <a:extLst xmlns:a="http://schemas.openxmlformats.org/drawingml/2006/main">
               <a:ext uri="{FF2B5EF4-FFF2-40B4-BE49-F238E27FC236}">
-                <a16:creationId xmlns:a16="http://schemas.microsoft.com/office/drawing/2014/main" id="{BE37FFFA-7FD7-4C0A-8C41-B5BF922DB2A0}"/>
+                <a16:creationId xmlns:a16="http://schemas.microsoft.com/office/drawing/2014/main" id="{FF04AD1D-79DD-4860-B4B8-0200DC0604EF}"/>
               </a:ext>
             </a:extLst>
           </p:cNvPr>
@@ -6236,8 +6236,8 @@
         </p:nvSpPr>
         <p:spPr>
           <a:xfrm xmlns:a="http://schemas.openxmlformats.org/drawingml/2006/main">
-            <a:off x="723900" y="5048250"/>
-            <a:ext cx="10744200" cy="914400"/>
+            <a:off x="3905250" y="2590800"/>
+            <a:ext cx="7524750" cy="762000"/>
           </a:xfrm>
           <a:prstGeom xmlns:a="http://schemas.openxmlformats.org/drawingml/2006/main" prst="rect">
             <a:avLst/>
@@ -6254,9 +6254,9 @@
           <a:lstStyle xmlns:a="http://schemas.openxmlformats.org/drawingml/2006/main"/>
           <a:p xmlns:a="http://schemas.openxmlformats.org/drawingml/2006/main">
             <a:pPr>
-              <a:defRPr sz="2175" b="0">
-                <a:solidFill>
-                  <a:srgbClr val="526371"/>
+              <a:defRPr sz="2100" b="0">
+                <a:solidFill>
+                  <a:srgbClr val="162B3C"/>
                 </a:solidFill>
                 <a:latin typeface="Microsoft YaHei"/>
                 <a:ea typeface="Microsoft YaHei"/>
@@ -6264,15 +6264,243 @@
               </a:defRPr>
             </a:pPr>
             <a:r>
-              <a:rPr sz="2175" b="0">
-                <a:solidFill>
-                  <a:srgbClr val="526371"/>
+              <a:rPr sz="2100" b="0">
+                <a:solidFill>
+                  <a:srgbClr val="162B3C"/>
                 </a:solidFill>
                 <a:latin typeface="Microsoft YaHei"/>
                 <a:ea typeface="Microsoft YaHei"/>
                 <a:cs typeface="Microsoft YaHei"/>
               </a:rPr>
-              <a:t>错年份、缺参数、零分母或冲突币种：保留trace并停止结论</a:t>
+              <a:t>pending选项跨重启；锁定503，解锁保留历史</a:t>
+            </a:r>
+          </a:p>
+        </p:txBody>
+      </p:sp>
+      <p:sp>
+        <p:nvSpPr>
+          <p:cNvPr id="6" name="">
+            <a:extLst xmlns:a="http://schemas.openxmlformats.org/drawingml/2006/main">
+              <a:ext uri="{FF2B5EF4-FFF2-40B4-BE49-F238E27FC236}">
+                <a16:creationId xmlns:a16="http://schemas.microsoft.com/office/drawing/2014/main" id="{327403A7-602D-44F1-8EA8-FCB2247D8226}"/>
+              </a:ext>
+            </a:extLst>
+          </p:cNvPr>
+          <p:cNvSpPr>
+            <a:spLocks xmlns:a="http://schemas.openxmlformats.org/drawingml/2006/main" noGrp="1"/>
+          </p:cNvSpPr>
+          <p:nvPr/>
+        </p:nvSpPr>
+        <p:spPr>
+          <a:xfrm xmlns:a="http://schemas.openxmlformats.org/drawingml/2006/main">
+            <a:off x="723900" y="3581400"/>
+            <a:ext cx="2952750" cy="685800"/>
+          </a:xfrm>
+          <a:prstGeom xmlns:a="http://schemas.openxmlformats.org/drawingml/2006/main" prst="rect">
+            <a:avLst/>
+          </a:prstGeom>
+          <a:noFill xmlns:a="http://schemas.openxmlformats.org/drawingml/2006/main"/>
+          <a:ln xmlns:a="http://schemas.openxmlformats.org/drawingml/2006/main" w="0">
+            <a:noFill/>
+          </a:ln>
+        </p:spPr>
+        <p:txBody>
+          <a:bodyPr xmlns:a="http://schemas.openxmlformats.org/drawingml/2006/main">
+            <a:noAutofit/>
+          </a:bodyPr>
+          <a:lstStyle xmlns:a="http://schemas.openxmlformats.org/drawingml/2006/main"/>
+          <a:p xmlns:a="http://schemas.openxmlformats.org/drawingml/2006/main">
+            <a:pPr>
+              <a:defRPr sz="2175" b="1">
+                <a:solidFill>
+                  <a:srgbClr val="176B87"/>
+                </a:solidFill>
+                <a:latin typeface="Microsoft YaHei"/>
+                <a:ea typeface="Microsoft YaHei"/>
+                <a:cs typeface="Microsoft YaHei"/>
+              </a:defRPr>
+            </a:pPr>
+            <a:r>
+              <a:rPr sz="2175" b="1">
+                <a:solidFill>
+                  <a:srgbClr val="176B87"/>
+                </a:solidFill>
+                <a:latin typeface="Microsoft YaHei"/>
+                <a:ea typeface="Microsoft YaHei"/>
+                <a:cs typeface="Microsoft YaHei"/>
+              </a:rPr>
+              <a:t>故障实际审计</a:t>
+            </a:r>
+          </a:p>
+        </p:txBody>
+      </p:sp>
+      <p:sp>
+        <p:nvSpPr>
+          <p:cNvPr id="7" name="">
+            <a:extLst xmlns:a="http://schemas.openxmlformats.org/drawingml/2006/main">
+              <a:ext uri="{FF2B5EF4-FFF2-40B4-BE49-F238E27FC236}">
+                <a16:creationId xmlns:a16="http://schemas.microsoft.com/office/drawing/2014/main" id="{49599C2D-D782-416D-BA68-83F1CC19B695}"/>
+              </a:ext>
+            </a:extLst>
+          </p:cNvPr>
+          <p:cNvSpPr>
+            <a:spLocks xmlns:a="http://schemas.openxmlformats.org/drawingml/2006/main" noGrp="1"/>
+          </p:cNvSpPr>
+          <p:nvPr/>
+        </p:nvSpPr>
+        <p:spPr>
+          <a:xfrm xmlns:a="http://schemas.openxmlformats.org/drawingml/2006/main">
+            <a:off x="3905250" y="3581400"/>
+            <a:ext cx="7524750" cy="762000"/>
+          </a:xfrm>
+          <a:prstGeom xmlns:a="http://schemas.openxmlformats.org/drawingml/2006/main" prst="rect">
+            <a:avLst/>
+          </a:prstGeom>
+          <a:noFill xmlns:a="http://schemas.openxmlformats.org/drawingml/2006/main"/>
+          <a:ln xmlns:a="http://schemas.openxmlformats.org/drawingml/2006/main" w="0">
+            <a:noFill/>
+          </a:ln>
+        </p:spPr>
+        <p:txBody>
+          <a:bodyPr xmlns:a="http://schemas.openxmlformats.org/drawingml/2006/main">
+            <a:noAutofit/>
+          </a:bodyPr>
+          <a:lstStyle xmlns:a="http://schemas.openxmlformats.org/drawingml/2006/main"/>
+          <a:p xmlns:a="http://schemas.openxmlformats.org/drawingml/2006/main">
+            <a:pPr>
+              <a:defRPr sz="2100" b="0">
+                <a:solidFill>
+                  <a:srgbClr val="162B3C"/>
+                </a:solidFill>
+                <a:latin typeface="Microsoft YaHei"/>
+                <a:ea typeface="Microsoft YaHei"/>
+                <a:cs typeface="Microsoft YaHei"/>
+              </a:defRPr>
+            </a:pPr>
+            <a:r>
+              <a:rPr sz="2100" b="0">
+                <a:solidFill>
+                  <a:srgbClr val="162B3C"/>
+                </a:solidFill>
+                <a:latin typeface="Microsoft YaHei"/>
+                <a:ea typeface="Microsoft YaHei"/>
+                <a:cs typeface="Microsoft YaHei"/>
+              </a:rPr>
+              <a:t>相同十项首次4/10，修复后10/10；不改主服务</a:t>
+            </a:r>
+          </a:p>
+        </p:txBody>
+      </p:sp>
+      <p:sp>
+        <p:nvSpPr>
+          <p:cNvPr id="8" name="">
+            <a:extLst xmlns:a="http://schemas.openxmlformats.org/drawingml/2006/main">
+              <a:ext uri="{FF2B5EF4-FFF2-40B4-BE49-F238E27FC236}">
+                <a16:creationId xmlns:a16="http://schemas.microsoft.com/office/drawing/2014/main" id="{51690B43-A0FF-4648-9CC3-52000E41BC71}"/>
+              </a:ext>
+            </a:extLst>
+          </p:cNvPr>
+          <p:cNvSpPr>
+            <a:spLocks xmlns:a="http://schemas.openxmlformats.org/drawingml/2006/main" noGrp="1"/>
+          </p:cNvSpPr>
+          <p:nvPr/>
+        </p:nvSpPr>
+        <p:spPr>
+          <a:xfrm xmlns:a="http://schemas.openxmlformats.org/drawingml/2006/main">
+            <a:off x="723900" y="4572000"/>
+            <a:ext cx="2952750" cy="685800"/>
+          </a:xfrm>
+          <a:prstGeom xmlns:a="http://schemas.openxmlformats.org/drawingml/2006/main" prst="rect">
+            <a:avLst/>
+          </a:prstGeom>
+          <a:noFill xmlns:a="http://schemas.openxmlformats.org/drawingml/2006/main"/>
+          <a:ln xmlns:a="http://schemas.openxmlformats.org/drawingml/2006/main" w="0">
+            <a:noFill/>
+          </a:ln>
+        </p:spPr>
+        <p:txBody>
+          <a:bodyPr xmlns:a="http://schemas.openxmlformats.org/drawingml/2006/main">
+            <a:noAutofit/>
+          </a:bodyPr>
+          <a:lstStyle xmlns:a="http://schemas.openxmlformats.org/drawingml/2006/main"/>
+          <a:p xmlns:a="http://schemas.openxmlformats.org/drawingml/2006/main">
+            <a:pPr>
+              <a:defRPr sz="2175" b="1">
+                <a:solidFill>
+                  <a:srgbClr val="176B87"/>
+                </a:solidFill>
+                <a:latin typeface="Microsoft YaHei"/>
+                <a:ea typeface="Microsoft YaHei"/>
+                <a:cs typeface="Microsoft YaHei"/>
+              </a:defRPr>
+            </a:pPr>
+            <a:r>
+              <a:rPr sz="2175" b="1">
+                <a:solidFill>
+                  <a:srgbClr val="176B87"/>
+                </a:solidFill>
+                <a:latin typeface="Microsoft YaHei"/>
+                <a:ea typeface="Microsoft YaHei"/>
+                <a:cs typeface="Microsoft YaHei"/>
+              </a:rPr>
+              <a:t>完整本地回归</a:t>
+            </a:r>
+          </a:p>
+        </p:txBody>
+      </p:sp>
+      <p:sp>
+        <p:nvSpPr>
+          <p:cNvPr id="9" name="">
+            <a:extLst xmlns:a="http://schemas.openxmlformats.org/drawingml/2006/main">
+              <a:ext uri="{FF2B5EF4-FFF2-40B4-BE49-F238E27FC236}">
+                <a16:creationId xmlns:a16="http://schemas.microsoft.com/office/drawing/2014/main" id="{B2236128-51A7-4155-8A0E-F91E26833308}"/>
+              </a:ext>
+            </a:extLst>
+          </p:cNvPr>
+          <p:cNvSpPr>
+            <a:spLocks xmlns:a="http://schemas.openxmlformats.org/drawingml/2006/main" noGrp="1"/>
+          </p:cNvSpPr>
+          <p:nvPr/>
+        </p:nvSpPr>
+        <p:spPr>
+          <a:xfrm xmlns:a="http://schemas.openxmlformats.org/drawingml/2006/main">
+            <a:off x="3905250" y="4572000"/>
+            <a:ext cx="7524750" cy="762000"/>
+          </a:xfrm>
+          <a:prstGeom xmlns:a="http://schemas.openxmlformats.org/drawingml/2006/main" prst="rect">
+            <a:avLst/>
+          </a:prstGeom>
+          <a:noFill xmlns:a="http://schemas.openxmlformats.org/drawingml/2006/main"/>
+          <a:ln xmlns:a="http://schemas.openxmlformats.org/drawingml/2006/main" w="0">
+            <a:noFill/>
+          </a:ln>
+        </p:spPr>
+        <p:txBody>
+          <a:bodyPr xmlns:a="http://schemas.openxmlformats.org/drawingml/2006/main">
+            <a:noAutofit/>
+          </a:bodyPr>
+          <a:lstStyle xmlns:a="http://schemas.openxmlformats.org/drawingml/2006/main"/>
+          <a:p xmlns:a="http://schemas.openxmlformats.org/drawingml/2006/main">
+            <a:pPr>
+              <a:defRPr sz="2100" b="0">
+                <a:solidFill>
+                  <a:srgbClr val="162B3C"/>
+                </a:solidFill>
+                <a:latin typeface="Microsoft YaHei"/>
+                <a:ea typeface="Microsoft YaHei"/>
+                <a:cs typeface="Microsoft YaHei"/>
+              </a:defRPr>
+            </a:pPr>
+            <a:r>
+              <a:rPr sz="2100" b="0">
+                <a:solidFill>
+                  <a:srgbClr val="162B3C"/>
+                </a:solidFill>
+                <a:latin typeface="Microsoft YaHei"/>
+                <a:ea typeface="Microsoft YaHei"/>
+                <a:cs typeface="Microsoft YaHei"/>
+              </a:rPr>
+              <a:t>468项通过；源文件、缺库、锁定失败均停止后步</a:t>
             </a:r>
           </a:p>
         </p:txBody>
@@ -6280,7 +6508,7 @@
     </p:spTree>
     <p:extLst>
       <p:ext uri="{BB962C8B-B14F-4D97-AF65-F5344CB8AC3E}">
-        <p14:creationId xmlns:p14="http://schemas.microsoft.com/office/powerpoint/2010/main" val="1116962149"/>
+        <p14:creationId xmlns:p14="http://schemas.microsoft.com/office/powerpoint/2010/main" val="100244585"/>
       </p:ext>
     </p:extLst>
   </p:cSld>
@@ -6311,7 +6539,7 @@
           <p:cNvPr id="10" name="">
             <a:extLst xmlns:a="http://schemas.openxmlformats.org/drawingml/2006/main">
               <a:ext uri="{FF2B5EF4-FFF2-40B4-BE49-F238E27FC236}">
-                <a16:creationId xmlns:a16="http://schemas.microsoft.com/office/drawing/2014/main" id="{BC49FBD2-07DF-44D5-B69F-97C6066E7369}"/>
+                <a16:creationId xmlns:a16="http://schemas.microsoft.com/office/drawing/2014/main" id="{E0E6573E-8F6E-40F4-8B06-C578FBB9AF6E}"/>
               </a:ext>
             </a:extLst>
           </p:cNvPr>
@@ -6368,7 +6596,7 @@
           <p:cNvPr id="2" name="">
             <a:extLst xmlns:a="http://schemas.openxmlformats.org/drawingml/2006/main">
               <a:ext uri="{FF2B5EF4-FFF2-40B4-BE49-F238E27FC236}">
-                <a16:creationId xmlns:a16="http://schemas.microsoft.com/office/drawing/2014/main" id="{22DD04C6-EAC9-4B72-A239-BDB4C3D64CA1}"/>
+                <a16:creationId xmlns:a16="http://schemas.microsoft.com/office/drawing/2014/main" id="{0EC1CDD2-BAB1-4F61-8FE1-374645A4D68A}"/>
               </a:ext>
             </a:extLst>
           </p:cNvPr>
@@ -6425,7 +6653,7 @@
           <p:cNvPr id="3" name="">
             <a:extLst xmlns:a="http://schemas.openxmlformats.org/drawingml/2006/main">
               <a:ext uri="{FF2B5EF4-FFF2-40B4-BE49-F238E27FC236}">
-                <a16:creationId xmlns:a16="http://schemas.microsoft.com/office/drawing/2014/main" id="{2747422E-39B5-4EF3-97F9-07AF785ECC9E}"/>
+                <a16:creationId xmlns:a16="http://schemas.microsoft.com/office/drawing/2014/main" id="{7F1BE018-1AD1-4BF0-9386-27C6394965E5}"/>
               </a:ext>
             </a:extLst>
           </p:cNvPr>
@@ -6482,7 +6710,7 @@
           <p:cNvPr id="4" name="">
             <a:extLst xmlns:a="http://schemas.openxmlformats.org/drawingml/2006/main">
               <a:ext uri="{FF2B5EF4-FFF2-40B4-BE49-F238E27FC236}">
-                <a16:creationId xmlns:a16="http://schemas.microsoft.com/office/drawing/2014/main" id="{15405695-6B61-4467-91BD-FFA2080490EC}"/>
+                <a16:creationId xmlns:a16="http://schemas.microsoft.com/office/drawing/2014/main" id="{47912D17-25F3-4F35-8066-197E18BBC82F}"/>
               </a:ext>
             </a:extLst>
           </p:cNvPr>
@@ -6539,7 +6767,7 @@
           <p:cNvPr id="5" name="">
             <a:extLst xmlns:a="http://schemas.openxmlformats.org/drawingml/2006/main">
               <a:ext uri="{FF2B5EF4-FFF2-40B4-BE49-F238E27FC236}">
-                <a16:creationId xmlns:a16="http://schemas.microsoft.com/office/drawing/2014/main" id="{ACCD29D9-56F2-40F8-BC90-024C3F5B3CC0}"/>
+                <a16:creationId xmlns:a16="http://schemas.microsoft.com/office/drawing/2014/main" id="{2B96649B-B4FC-4344-9003-C686CB45E2EA}"/>
               </a:ext>
             </a:extLst>
           </p:cNvPr>
@@ -6596,7 +6824,7 @@
           <p:cNvPr id="6" name="">
             <a:extLst xmlns:a="http://schemas.openxmlformats.org/drawingml/2006/main">
               <a:ext uri="{FF2B5EF4-FFF2-40B4-BE49-F238E27FC236}">
-                <a16:creationId xmlns:a16="http://schemas.microsoft.com/office/drawing/2014/main" id="{BA54C693-43D2-491C-9973-44A9ADBEF662}"/>
+                <a16:creationId xmlns:a16="http://schemas.microsoft.com/office/drawing/2014/main" id="{B52EE3CB-9EFD-4FC0-B643-61678724334E}"/>
               </a:ext>
             </a:extLst>
           </p:cNvPr>
@@ -6653,7 +6881,7 @@
           <p:cNvPr id="7" name="">
             <a:extLst xmlns:a="http://schemas.openxmlformats.org/drawingml/2006/main">
               <a:ext uri="{FF2B5EF4-FFF2-40B4-BE49-F238E27FC236}">
-                <a16:creationId xmlns:a16="http://schemas.microsoft.com/office/drawing/2014/main" id="{0F64F58C-22C4-475A-AAE4-436DB24C15A2}"/>
+                <a16:creationId xmlns:a16="http://schemas.microsoft.com/office/drawing/2014/main" id="{E9DE2135-B082-41C8-A6FA-C7473583E0E4}"/>
               </a:ext>
             </a:extLst>
           </p:cNvPr>
@@ -6710,7 +6938,7 @@
           <p:cNvPr id="8" name="">
             <a:extLst xmlns:a="http://schemas.openxmlformats.org/drawingml/2006/main">
               <a:ext uri="{FF2B5EF4-FFF2-40B4-BE49-F238E27FC236}">
-                <a16:creationId xmlns:a16="http://schemas.microsoft.com/office/drawing/2014/main" id="{A36EC3F0-2D0B-4321-83BC-F9ADE6A2515C}"/>
+                <a16:creationId xmlns:a16="http://schemas.microsoft.com/office/drawing/2014/main" id="{8EB2FB1F-5714-4E7A-8CE1-04F04E4DD9E6}"/>
               </a:ext>
             </a:extLst>
           </p:cNvPr>
@@ -6767,7 +6995,7 @@
           <p:cNvPr id="9" name="">
             <a:extLst xmlns:a="http://schemas.openxmlformats.org/drawingml/2006/main">
               <a:ext uri="{FF2B5EF4-FFF2-40B4-BE49-F238E27FC236}">
-                <a16:creationId xmlns:a16="http://schemas.microsoft.com/office/drawing/2014/main" id="{DFAF7F89-D0AC-4ED6-9FD8-B5732E74316E}"/>
+                <a16:creationId xmlns:a16="http://schemas.microsoft.com/office/drawing/2014/main" id="{82876281-7048-4D05-AF2C-B9B2C8AD5DAC}"/>
               </a:ext>
             </a:extLst>
           </p:cNvPr>
@@ -6822,7 +7050,7 @@
     </p:spTree>
     <p:extLst>
       <p:ext uri="{BB962C8B-B14F-4D97-AF65-F5344CB8AC3E}">
-        <p14:creationId xmlns:p14="http://schemas.microsoft.com/office/powerpoint/2010/main" val="427390208"/>
+        <p14:creationId xmlns:p14="http://schemas.microsoft.com/office/powerpoint/2010/main" val="1237987327"/>
       </p:ext>
     </p:extLst>
   </p:cSld>
@@ -6853,7 +7081,7 @@
           <p:cNvPr id="10" name="">
             <a:extLst xmlns:a="http://schemas.openxmlformats.org/drawingml/2006/main">
               <a:ext uri="{FF2B5EF4-FFF2-40B4-BE49-F238E27FC236}">
-                <a16:creationId xmlns:a16="http://schemas.microsoft.com/office/drawing/2014/main" id="{1C026FA7-8A42-4CE2-B53C-D279B5D7C624}"/>
+                <a16:creationId xmlns:a16="http://schemas.microsoft.com/office/drawing/2014/main" id="{06F1653F-24F8-4D96-A27E-6F4F29DBC47E}"/>
               </a:ext>
             </a:extLst>
           </p:cNvPr>
@@ -6910,7 +7138,7 @@
           <p:cNvPr id="2" name="">
             <a:extLst xmlns:a="http://schemas.openxmlformats.org/drawingml/2006/main">
               <a:ext uri="{FF2B5EF4-FFF2-40B4-BE49-F238E27FC236}">
-                <a16:creationId xmlns:a16="http://schemas.microsoft.com/office/drawing/2014/main" id="{7C1E08B5-844B-4B51-965A-FDC9EE48B6E6}"/>
+                <a16:creationId xmlns:a16="http://schemas.microsoft.com/office/drawing/2014/main" id="{932B69E1-9AC4-4595-B449-47D694D6412F}"/>
               </a:ext>
             </a:extLst>
           </p:cNvPr>
@@ -6967,7 +7195,7 @@
           <p:cNvPr id="3" name="">
             <a:extLst xmlns:a="http://schemas.openxmlformats.org/drawingml/2006/main">
               <a:ext uri="{FF2B5EF4-FFF2-40B4-BE49-F238E27FC236}">
-                <a16:creationId xmlns:a16="http://schemas.microsoft.com/office/drawing/2014/main" id="{D3FC4015-F246-4F92-ABDF-CD86D237F5E9}"/>
+                <a16:creationId xmlns:a16="http://schemas.microsoft.com/office/drawing/2014/main" id="{7FF78EF6-086E-4C7E-ABE0-244C0C7D1EBA}"/>
               </a:ext>
             </a:extLst>
           </p:cNvPr>
@@ -7024,7 +7252,7 @@
           <p:cNvPr id="4" name="">
             <a:extLst xmlns:a="http://schemas.openxmlformats.org/drawingml/2006/main">
               <a:ext uri="{FF2B5EF4-FFF2-40B4-BE49-F238E27FC236}">
-                <a16:creationId xmlns:a16="http://schemas.microsoft.com/office/drawing/2014/main" id="{50C1E214-8139-4A42-A70B-E73E60D37521}"/>
+                <a16:creationId xmlns:a16="http://schemas.microsoft.com/office/drawing/2014/main" id="{AAA33650-4400-4BC1-BEEE-EDDD31AC001A}"/>
               </a:ext>
             </a:extLst>
           </p:cNvPr>
@@ -7081,7 +7309,7 @@
           <p:cNvPr id="5" name="">
             <a:extLst xmlns:a="http://schemas.openxmlformats.org/drawingml/2006/main">
               <a:ext uri="{FF2B5EF4-FFF2-40B4-BE49-F238E27FC236}">
-                <a16:creationId xmlns:a16="http://schemas.microsoft.com/office/drawing/2014/main" id="{221F6CD0-F164-4D60-BE2A-E7179EAFEC13}"/>
+                <a16:creationId xmlns:a16="http://schemas.microsoft.com/office/drawing/2014/main" id="{365D017E-0B2C-411C-AC86-6277C3989B8D}"/>
               </a:ext>
             </a:extLst>
           </p:cNvPr>
@@ -7138,7 +7366,7 @@
           <p:cNvPr id="6" name="">
             <a:extLst xmlns:a="http://schemas.openxmlformats.org/drawingml/2006/main">
               <a:ext uri="{FF2B5EF4-FFF2-40B4-BE49-F238E27FC236}">
-                <a16:creationId xmlns:a16="http://schemas.microsoft.com/office/drawing/2014/main" id="{40F27D42-A682-4DC9-9ED3-9EC969436F84}"/>
+                <a16:creationId xmlns:a16="http://schemas.microsoft.com/office/drawing/2014/main" id="{BC4A5092-A080-4327-B859-75C6B1EA8BE4}"/>
               </a:ext>
             </a:extLst>
           </p:cNvPr>
@@ -7195,7 +7423,7 @@
           <p:cNvPr id="7" name="">
             <a:extLst xmlns:a="http://schemas.openxmlformats.org/drawingml/2006/main">
               <a:ext uri="{FF2B5EF4-FFF2-40B4-BE49-F238E27FC236}">
-                <a16:creationId xmlns:a16="http://schemas.microsoft.com/office/drawing/2014/main" id="{046BC387-7810-4A8B-906F-B4737DAF5680}"/>
+                <a16:creationId xmlns:a16="http://schemas.microsoft.com/office/drawing/2014/main" id="{4331D2CE-4AF4-470D-AF0E-0F9A47AA9E35}"/>
               </a:ext>
             </a:extLst>
           </p:cNvPr>
@@ -7252,7 +7480,7 @@
           <p:cNvPr id="8" name="">
             <a:extLst xmlns:a="http://schemas.openxmlformats.org/drawingml/2006/main">
               <a:ext uri="{FF2B5EF4-FFF2-40B4-BE49-F238E27FC236}">
-                <a16:creationId xmlns:a16="http://schemas.microsoft.com/office/drawing/2014/main" id="{0CF8259F-9C02-422D-BBCD-9A85B1541176}"/>
+                <a16:creationId xmlns:a16="http://schemas.microsoft.com/office/drawing/2014/main" id="{4BD38A0E-1B51-43B8-AA55-B12FE14BED33}"/>
               </a:ext>
             </a:extLst>
           </p:cNvPr>
@@ -7309,7 +7537,7 @@
           <p:cNvPr id="9" name="">
             <a:extLst xmlns:a="http://schemas.openxmlformats.org/drawingml/2006/main">
               <a:ext uri="{FF2B5EF4-FFF2-40B4-BE49-F238E27FC236}">
-                <a16:creationId xmlns:a16="http://schemas.microsoft.com/office/drawing/2014/main" id="{8F9A9544-8574-4126-87A3-B09D2BF9AA28}"/>
+                <a16:creationId xmlns:a16="http://schemas.microsoft.com/office/drawing/2014/main" id="{4AF5C3C4-E7F3-48DB-AF74-64B58FF135F0}"/>
               </a:ext>
             </a:extLst>
           </p:cNvPr>
@@ -7364,7 +7592,7 @@
     </p:spTree>
     <p:extLst>
       <p:ext uri="{BB962C8B-B14F-4D97-AF65-F5344CB8AC3E}">
-        <p14:creationId xmlns:p14="http://schemas.microsoft.com/office/powerpoint/2010/main" val="869957331"/>
+        <p14:creationId xmlns:p14="http://schemas.microsoft.com/office/powerpoint/2010/main" val="572966016"/>
       </p:ext>
     </p:extLst>
   </p:cSld>
@@ -7395,7 +7623,7 @@
           <p:cNvPr id="10" name="">
             <a:extLst xmlns:a="http://schemas.openxmlformats.org/drawingml/2006/main">
               <a:ext uri="{FF2B5EF4-FFF2-40B4-BE49-F238E27FC236}">
-                <a16:creationId xmlns:a16="http://schemas.microsoft.com/office/drawing/2014/main" id="{55976A69-7ACD-43FF-BDBD-D1A9F536A644}"/>
+                <a16:creationId xmlns:a16="http://schemas.microsoft.com/office/drawing/2014/main" id="{12093F8B-30A9-4E79-9B3B-BD082B316478}"/>
               </a:ext>
             </a:extLst>
           </p:cNvPr>
@@ -7452,7 +7680,7 @@
           <p:cNvPr id="2" name="">
             <a:extLst xmlns:a="http://schemas.openxmlformats.org/drawingml/2006/main">
               <a:ext uri="{FF2B5EF4-FFF2-40B4-BE49-F238E27FC236}">
-                <a16:creationId xmlns:a16="http://schemas.microsoft.com/office/drawing/2014/main" id="{69C0006C-FE5C-47E6-AF66-6D2B9F90E31C}"/>
+                <a16:creationId xmlns:a16="http://schemas.microsoft.com/office/drawing/2014/main" id="{0BFF26CB-00AE-4750-9D14-6448307AB1BC}"/>
               </a:ext>
             </a:extLst>
           </p:cNvPr>
@@ -7509,7 +7737,7 @@
           <p:cNvPr id="3" name="">
             <a:extLst xmlns:a="http://schemas.openxmlformats.org/drawingml/2006/main">
               <a:ext uri="{FF2B5EF4-FFF2-40B4-BE49-F238E27FC236}">
-                <a16:creationId xmlns:a16="http://schemas.microsoft.com/office/drawing/2014/main" id="{EC4945A8-C38D-4E17-8443-5B6F78A4E741}"/>
+                <a16:creationId xmlns:a16="http://schemas.microsoft.com/office/drawing/2014/main" id="{D50C6B1C-9042-438B-834C-1AF8E3B974D1}"/>
               </a:ext>
             </a:extLst>
           </p:cNvPr>
@@ -7566,7 +7794,7 @@
           <p:cNvPr id="4" name="">
             <a:extLst xmlns:a="http://schemas.openxmlformats.org/drawingml/2006/main">
               <a:ext uri="{FF2B5EF4-FFF2-40B4-BE49-F238E27FC236}">
-                <a16:creationId xmlns:a16="http://schemas.microsoft.com/office/drawing/2014/main" id="{B7482DD7-1C5A-4EB6-B214-27E256102B9D}"/>
+                <a16:creationId xmlns:a16="http://schemas.microsoft.com/office/drawing/2014/main" id="{58993E4A-A4DA-4578-85B0-46C22CFB916F}"/>
               </a:ext>
             </a:extLst>
           </p:cNvPr>
@@ -7623,7 +7851,7 @@
           <p:cNvPr id="5" name="">
             <a:extLst xmlns:a="http://schemas.openxmlformats.org/drawingml/2006/main">
               <a:ext uri="{FF2B5EF4-FFF2-40B4-BE49-F238E27FC236}">
-                <a16:creationId xmlns:a16="http://schemas.microsoft.com/office/drawing/2014/main" id="{7BD68A23-6A34-4787-BBCE-1964AEACCA62}"/>
+                <a16:creationId xmlns:a16="http://schemas.microsoft.com/office/drawing/2014/main" id="{DC633AE7-9819-4C5A-91A3-3E230E3C6F18}"/>
               </a:ext>
             </a:extLst>
           </p:cNvPr>
@@ -7680,7 +7908,7 @@
           <p:cNvPr id="6" name="">
             <a:extLst xmlns:a="http://schemas.openxmlformats.org/drawingml/2006/main">
               <a:ext uri="{FF2B5EF4-FFF2-40B4-BE49-F238E27FC236}">
-                <a16:creationId xmlns:a16="http://schemas.microsoft.com/office/drawing/2014/main" id="{06156ABD-0320-4EBA-ACA1-D12A1FC2B7AE}"/>
+                <a16:creationId xmlns:a16="http://schemas.microsoft.com/office/drawing/2014/main" id="{D98642C1-8663-4D78-B88F-4E27ED7EFA60}"/>
               </a:ext>
             </a:extLst>
           </p:cNvPr>
@@ -7737,7 +7965,7 @@
           <p:cNvPr id="7" name="">
             <a:extLst xmlns:a="http://schemas.openxmlformats.org/drawingml/2006/main">
               <a:ext uri="{FF2B5EF4-FFF2-40B4-BE49-F238E27FC236}">
-                <a16:creationId xmlns:a16="http://schemas.microsoft.com/office/drawing/2014/main" id="{48238AE8-8F18-4F6B-80A7-D11B2D756F93}"/>
+                <a16:creationId xmlns:a16="http://schemas.microsoft.com/office/drawing/2014/main" id="{7E20A79C-C714-4724-9121-CC1DACD7F7F6}"/>
               </a:ext>
             </a:extLst>
           </p:cNvPr>
@@ -7794,7 +8022,7 @@
           <p:cNvPr id="8" name="">
             <a:extLst xmlns:a="http://schemas.openxmlformats.org/drawingml/2006/main">
               <a:ext uri="{FF2B5EF4-FFF2-40B4-BE49-F238E27FC236}">
-                <a16:creationId xmlns:a16="http://schemas.microsoft.com/office/drawing/2014/main" id="{C5307A19-534F-40B9-B9B3-61DF04066D87}"/>
+                <a16:creationId xmlns:a16="http://schemas.microsoft.com/office/drawing/2014/main" id="{1B21E8AF-B40B-4390-9771-AF36D936B191}"/>
               </a:ext>
             </a:extLst>
           </p:cNvPr>
@@ -7851,7 +8079,7 @@
           <p:cNvPr id="9" name="">
             <a:extLst xmlns:a="http://schemas.openxmlformats.org/drawingml/2006/main">
               <a:ext uri="{FF2B5EF4-FFF2-40B4-BE49-F238E27FC236}">
-                <a16:creationId xmlns:a16="http://schemas.microsoft.com/office/drawing/2014/main" id="{E6816F3A-4AC5-4DE5-A370-1DD20F37BC9E}"/>
+                <a16:creationId xmlns:a16="http://schemas.microsoft.com/office/drawing/2014/main" id="{64FA4EF8-EBE0-409E-8D86-1C70D5B73512}"/>
               </a:ext>
             </a:extLst>
           </p:cNvPr>
@@ -7906,7 +8134,7 @@
     </p:spTree>
     <p:extLst>
       <p:ext uri="{BB962C8B-B14F-4D97-AF65-F5344CB8AC3E}">
-        <p14:creationId xmlns:p14="http://schemas.microsoft.com/office/powerpoint/2010/main" val="40152363"/>
+        <p14:creationId xmlns:p14="http://schemas.microsoft.com/office/powerpoint/2010/main" val="1547659709"/>
       </p:ext>
     </p:extLst>
   </p:cSld>
@@ -8099,7 +8327,7 @@
           <p:cNvPr id="19" name="">
             <a:extLst xmlns:a="http://schemas.openxmlformats.org/drawingml/2006/main">
               <a:ext uri="{FF2B5EF4-FFF2-40B4-BE49-F238E27FC236}">
-                <a16:creationId xmlns:a16="http://schemas.microsoft.com/office/drawing/2014/main" id="{4BD8044B-EF20-423A-8236-5CD4579DD8E8}"/>
+                <a16:creationId xmlns:a16="http://schemas.microsoft.com/office/drawing/2014/main" id="{5D437A50-4A01-4FD8-9486-256535CEA04C}"/>
               </a:ext>
             </a:extLst>
           </p:cNvPr>
@@ -8156,7 +8384,7 @@
           <p:cNvPr id="2" name="">
             <a:extLst xmlns:a="http://schemas.openxmlformats.org/drawingml/2006/main">
               <a:ext uri="{FF2B5EF4-FFF2-40B4-BE49-F238E27FC236}">
-                <a16:creationId xmlns:a16="http://schemas.microsoft.com/office/drawing/2014/main" id="{BEF433FB-77D1-4EB4-A8CD-1A9BE25EE909}"/>
+                <a16:creationId xmlns:a16="http://schemas.microsoft.com/office/drawing/2014/main" id="{9620C640-55B7-4E48-B82F-AAAA944128A7}"/>
               </a:ext>
             </a:extLst>
           </p:cNvPr>
@@ -8217,7 +8445,7 @@
           <p:cNvPr id="3" name="">
             <a:extLst xmlns:a="http://schemas.openxmlformats.org/drawingml/2006/main">
               <a:ext uri="{FF2B5EF4-FFF2-40B4-BE49-F238E27FC236}">
-                <a16:creationId xmlns:a16="http://schemas.microsoft.com/office/drawing/2014/main" id="{42C5ADAF-0EC3-4A2E-B8E8-BAAC1F905B53}"/>
+                <a16:creationId xmlns:a16="http://schemas.microsoft.com/office/drawing/2014/main" id="{4368CB8D-B4B9-4F9D-82D1-188C2D48B7F2}"/>
               </a:ext>
             </a:extLst>
           </p:cNvPr>
@@ -8324,7 +8552,7 @@
           <p:cNvPr id="4" name="">
             <a:extLst xmlns:a="http://schemas.openxmlformats.org/drawingml/2006/main">
               <a:ext uri="{FF2B5EF4-FFF2-40B4-BE49-F238E27FC236}">
-                <a16:creationId xmlns:a16="http://schemas.microsoft.com/office/drawing/2014/main" id="{BC6D33FE-E6BD-43FB-BAF2-448C46252A33}"/>
+                <a16:creationId xmlns:a16="http://schemas.microsoft.com/office/drawing/2014/main" id="{B985673E-3218-4524-9017-75FB4FF474B2}"/>
               </a:ext>
             </a:extLst>
           </p:cNvPr>
@@ -8431,7 +8659,7 @@
           <p:cNvPr id="5" name="">
             <a:extLst xmlns:a="http://schemas.openxmlformats.org/drawingml/2006/main">
               <a:ext uri="{FF2B5EF4-FFF2-40B4-BE49-F238E27FC236}">
-                <a16:creationId xmlns:a16="http://schemas.microsoft.com/office/drawing/2014/main" id="{AA60466C-3995-49CE-81AF-F9869BBAEB6B}"/>
+                <a16:creationId xmlns:a16="http://schemas.microsoft.com/office/drawing/2014/main" id="{A971AF27-8D86-42C6-9920-D98A4692CA02}"/>
               </a:ext>
             </a:extLst>
           </p:cNvPr>
@@ -8538,7 +8766,7 @@
           <p:cNvPr id="6" name="">
             <a:extLst xmlns:a="http://schemas.openxmlformats.org/drawingml/2006/main">
               <a:ext uri="{FF2B5EF4-FFF2-40B4-BE49-F238E27FC236}">
-                <a16:creationId xmlns:a16="http://schemas.microsoft.com/office/drawing/2014/main" id="{08515CD8-361F-46A6-914B-CFBB9F744239}"/>
+                <a16:creationId xmlns:a16="http://schemas.microsoft.com/office/drawing/2014/main" id="{79AAB113-A70A-4C59-951F-F06455895A42}"/>
               </a:ext>
             </a:extLst>
           </p:cNvPr>
@@ -8597,7 +8825,7 @@
     </p:spTree>
     <p:extLst>
       <p:ext uri="{BB962C8B-B14F-4D97-AF65-F5344CB8AC3E}">
-        <p14:creationId xmlns:p14="http://schemas.microsoft.com/office/powerpoint/2010/main" val="1946817995"/>
+        <p14:creationId xmlns:p14="http://schemas.microsoft.com/office/powerpoint/2010/main" val="2074214734"/>
       </p:ext>
     </p:extLst>
   </p:cSld>
@@ -8628,7 +8856,7 @@
           <p:cNvPr id="10" name="">
             <a:extLst xmlns:a="http://schemas.openxmlformats.org/drawingml/2006/main">
               <a:ext uri="{FF2B5EF4-FFF2-40B4-BE49-F238E27FC236}">
-                <a16:creationId xmlns:a16="http://schemas.microsoft.com/office/drawing/2014/main" id="{E1CEEBD7-4D4B-4E63-BF9E-8CE7E2EB7C12}"/>
+                <a16:creationId xmlns:a16="http://schemas.microsoft.com/office/drawing/2014/main" id="{4395C172-2731-4B66-900F-B1F4395381EA}"/>
               </a:ext>
             </a:extLst>
           </p:cNvPr>
@@ -8685,7 +8913,7 @@
           <p:cNvPr id="2" name="">
             <a:extLst xmlns:a="http://schemas.openxmlformats.org/drawingml/2006/main">
               <a:ext uri="{FF2B5EF4-FFF2-40B4-BE49-F238E27FC236}">
-                <a16:creationId xmlns:a16="http://schemas.microsoft.com/office/drawing/2014/main" id="{48DDA675-8A3C-45AB-BFD8-85D00CE43D24}"/>
+                <a16:creationId xmlns:a16="http://schemas.microsoft.com/office/drawing/2014/main" id="{62461F44-080E-4E2C-B0D1-004A33BAEEBE}"/>
               </a:ext>
             </a:extLst>
           </p:cNvPr>
@@ -8742,7 +8970,7 @@
           <p:cNvPr id="3" name="">
             <a:extLst xmlns:a="http://schemas.openxmlformats.org/drawingml/2006/main">
               <a:ext uri="{FF2B5EF4-FFF2-40B4-BE49-F238E27FC236}">
-                <a16:creationId xmlns:a16="http://schemas.microsoft.com/office/drawing/2014/main" id="{85716A10-9B56-4F7A-A3D9-3105295CB9C2}"/>
+                <a16:creationId xmlns:a16="http://schemas.microsoft.com/office/drawing/2014/main" id="{595EA3AD-A3D3-4658-AEB5-29164B3E67AD}"/>
               </a:ext>
             </a:extLst>
           </p:cNvPr>
@@ -8799,7 +9027,7 @@
           <p:cNvPr id="4" name="">
             <a:extLst xmlns:a="http://schemas.openxmlformats.org/drawingml/2006/main">
               <a:ext uri="{FF2B5EF4-FFF2-40B4-BE49-F238E27FC236}">
-                <a16:creationId xmlns:a16="http://schemas.microsoft.com/office/drawing/2014/main" id="{EA790665-AB08-4BBC-A4BF-D34AB4A0CF55}"/>
+                <a16:creationId xmlns:a16="http://schemas.microsoft.com/office/drawing/2014/main" id="{F8A68E33-372D-4AC6-857A-C2594458178A}"/>
               </a:ext>
             </a:extLst>
           </p:cNvPr>
@@ -8856,7 +9084,7 @@
           <p:cNvPr id="5" name="">
             <a:extLst xmlns:a="http://schemas.openxmlformats.org/drawingml/2006/main">
               <a:ext uri="{FF2B5EF4-FFF2-40B4-BE49-F238E27FC236}">
-                <a16:creationId xmlns:a16="http://schemas.microsoft.com/office/drawing/2014/main" id="{4432BBD0-471D-4F67-91D6-0D725A452D59}"/>
+                <a16:creationId xmlns:a16="http://schemas.microsoft.com/office/drawing/2014/main" id="{FE345AB0-F0FB-4C0E-89D1-35974786FE80}"/>
               </a:ext>
             </a:extLst>
           </p:cNvPr>
@@ -8913,7 +9141,7 @@
           <p:cNvPr id="6" name="">
             <a:extLst xmlns:a="http://schemas.openxmlformats.org/drawingml/2006/main">
               <a:ext uri="{FF2B5EF4-FFF2-40B4-BE49-F238E27FC236}">
-                <a16:creationId xmlns:a16="http://schemas.microsoft.com/office/drawing/2014/main" id="{5BFC9BF2-1865-4935-830C-91976BC032DB}"/>
+                <a16:creationId xmlns:a16="http://schemas.microsoft.com/office/drawing/2014/main" id="{E86F120C-2034-461A-BE74-296C06FF34F9}"/>
               </a:ext>
             </a:extLst>
           </p:cNvPr>
@@ -8970,7 +9198,7 @@
           <p:cNvPr id="7" name="">
             <a:extLst xmlns:a="http://schemas.openxmlformats.org/drawingml/2006/main">
               <a:ext uri="{FF2B5EF4-FFF2-40B4-BE49-F238E27FC236}">
-                <a16:creationId xmlns:a16="http://schemas.microsoft.com/office/drawing/2014/main" id="{DB9AA093-3D52-4966-94FA-98EDCF3676DD}"/>
+                <a16:creationId xmlns:a16="http://schemas.microsoft.com/office/drawing/2014/main" id="{0F713359-61C3-4DA7-AF0A-D03C922D03BE}"/>
               </a:ext>
             </a:extLst>
           </p:cNvPr>
@@ -9027,7 +9255,7 @@
           <p:cNvPr id="8" name="">
             <a:extLst xmlns:a="http://schemas.openxmlformats.org/drawingml/2006/main">
               <a:ext uri="{FF2B5EF4-FFF2-40B4-BE49-F238E27FC236}">
-                <a16:creationId xmlns:a16="http://schemas.microsoft.com/office/drawing/2014/main" id="{CF8C4765-1C8A-458D-AAB2-12982501A8B2}"/>
+                <a16:creationId xmlns:a16="http://schemas.microsoft.com/office/drawing/2014/main" id="{059E49EC-4FEA-4388-9CFF-BFDF097563CE}"/>
               </a:ext>
             </a:extLst>
           </p:cNvPr>
@@ -9084,7 +9312,7 @@
           <p:cNvPr id="9" name="">
             <a:extLst xmlns:a="http://schemas.openxmlformats.org/drawingml/2006/main">
               <a:ext uri="{FF2B5EF4-FFF2-40B4-BE49-F238E27FC236}">
-                <a16:creationId xmlns:a16="http://schemas.microsoft.com/office/drawing/2014/main" id="{55321CAB-9A1E-40A1-B413-C151926AA14D}"/>
+                <a16:creationId xmlns:a16="http://schemas.microsoft.com/office/drawing/2014/main" id="{E43A515D-2226-413B-9B4D-C4D24B802E49}"/>
               </a:ext>
             </a:extLst>
           </p:cNvPr>
@@ -9139,7 +9367,7 @@
     </p:spTree>
     <p:extLst>
       <p:ext uri="{BB962C8B-B14F-4D97-AF65-F5344CB8AC3E}">
-        <p14:creationId xmlns:p14="http://schemas.microsoft.com/office/powerpoint/2010/main" val="863320969"/>
+        <p14:creationId xmlns:p14="http://schemas.microsoft.com/office/powerpoint/2010/main" val="2049076154"/>
       </p:ext>
     </p:extLst>
   </p:cSld>
@@ -9170,7 +9398,7 @@
           <p:cNvPr id="10" name="">
             <a:extLst xmlns:a="http://schemas.openxmlformats.org/drawingml/2006/main">
               <a:ext uri="{FF2B5EF4-FFF2-40B4-BE49-F238E27FC236}">
-                <a16:creationId xmlns:a16="http://schemas.microsoft.com/office/drawing/2014/main" id="{963873C0-FEDB-487E-9F9D-C195603A991C}"/>
+                <a16:creationId xmlns:a16="http://schemas.microsoft.com/office/drawing/2014/main" id="{2E8AD7BA-CA47-442F-AEB3-23945FD53646}"/>
               </a:ext>
             </a:extLst>
           </p:cNvPr>
@@ -9227,7 +9455,7 @@
           <p:cNvPr id="2" name="">
             <a:extLst xmlns:a="http://schemas.openxmlformats.org/drawingml/2006/main">
               <a:ext uri="{FF2B5EF4-FFF2-40B4-BE49-F238E27FC236}">
-                <a16:creationId xmlns:a16="http://schemas.microsoft.com/office/drawing/2014/main" id="{FE01982F-6BC9-4D72-A55E-CF7D9E72293A}"/>
+                <a16:creationId xmlns:a16="http://schemas.microsoft.com/office/drawing/2014/main" id="{0A09AECF-0DC5-4450-B49F-4DF7E5ACBA99}"/>
               </a:ext>
             </a:extLst>
           </p:cNvPr>
@@ -9284,7 +9512,7 @@
           <p:cNvPr id="3" name="">
             <a:extLst xmlns:a="http://schemas.openxmlformats.org/drawingml/2006/main">
               <a:ext uri="{FF2B5EF4-FFF2-40B4-BE49-F238E27FC236}">
-                <a16:creationId xmlns:a16="http://schemas.microsoft.com/office/drawing/2014/main" id="{E8E08863-20E8-42FF-BCAA-AC57EF5A6249}"/>
+                <a16:creationId xmlns:a16="http://schemas.microsoft.com/office/drawing/2014/main" id="{5621C4E9-9CD1-469D-BE8C-E7BC00A90936}"/>
               </a:ext>
             </a:extLst>
           </p:cNvPr>
@@ -9341,7 +9569,7 @@
           <p:cNvPr id="4" name="">
             <a:extLst xmlns:a="http://schemas.openxmlformats.org/drawingml/2006/main">
               <a:ext uri="{FF2B5EF4-FFF2-40B4-BE49-F238E27FC236}">
-                <a16:creationId xmlns:a16="http://schemas.microsoft.com/office/drawing/2014/main" id="{39B7AB7E-D452-46BC-84D6-7F041997E02B}"/>
+                <a16:creationId xmlns:a16="http://schemas.microsoft.com/office/drawing/2014/main" id="{AF471492-DBC3-4A32-8A48-899B2F11E9C9}"/>
               </a:ext>
             </a:extLst>
           </p:cNvPr>
@@ -9398,7 +9626,7 @@
           <p:cNvPr id="5" name="">
             <a:extLst xmlns:a="http://schemas.openxmlformats.org/drawingml/2006/main">
               <a:ext uri="{FF2B5EF4-FFF2-40B4-BE49-F238E27FC236}">
-                <a16:creationId xmlns:a16="http://schemas.microsoft.com/office/drawing/2014/main" id="{4FA0855B-9269-4435-A68D-F811418D5627}"/>
+                <a16:creationId xmlns:a16="http://schemas.microsoft.com/office/drawing/2014/main" id="{021CE93C-EC7A-426A-95B2-DD9DBF925C4E}"/>
               </a:ext>
             </a:extLst>
           </p:cNvPr>
@@ -9445,7 +9673,7 @@
                 <a:ea typeface="Microsoft YaHei"/>
                 <a:cs typeface="Microsoft YaHei"/>
               </a:rPr>
-              <a:t>保留页、行、单元格、标题路径与OCR区域</a:t>
+              <a:t>页、行、单元格、OCR区域；PDF目录首次2/8修复后8/8</a:t>
             </a:r>
           </a:p>
         </p:txBody>
@@ -9455,7 +9683,7 @@
           <p:cNvPr id="6" name="">
             <a:extLst xmlns:a="http://schemas.openxmlformats.org/drawingml/2006/main">
               <a:ext uri="{FF2B5EF4-FFF2-40B4-BE49-F238E27FC236}">
-                <a16:creationId xmlns:a16="http://schemas.microsoft.com/office/drawing/2014/main" id="{E8952423-3300-46C6-BDB8-54C48FEA7141}"/>
+                <a16:creationId xmlns:a16="http://schemas.microsoft.com/office/drawing/2014/main" id="{4D5BBD28-D314-435B-B7EA-A7B83993490E}"/>
               </a:ext>
             </a:extLst>
           </p:cNvPr>
@@ -9512,7 +9740,7 @@
           <p:cNvPr id="7" name="">
             <a:extLst xmlns:a="http://schemas.openxmlformats.org/drawingml/2006/main">
               <a:ext uri="{FF2B5EF4-FFF2-40B4-BE49-F238E27FC236}">
-                <a16:creationId xmlns:a16="http://schemas.microsoft.com/office/drawing/2014/main" id="{7C31B751-1D05-4B80-997C-61EB769685DE}"/>
+                <a16:creationId xmlns:a16="http://schemas.microsoft.com/office/drawing/2014/main" id="{592097ED-B4C6-427E-AE7E-EAC7E243ABA8}"/>
               </a:ext>
             </a:extLst>
           </p:cNvPr>
@@ -9569,7 +9797,7 @@
           <p:cNvPr id="8" name="">
             <a:extLst xmlns:a="http://schemas.openxmlformats.org/drawingml/2006/main">
               <a:ext uri="{FF2B5EF4-FFF2-40B4-BE49-F238E27FC236}">
-                <a16:creationId xmlns:a16="http://schemas.microsoft.com/office/drawing/2014/main" id="{44EF32E2-F669-481E-BBA8-FC87DEED0381}"/>
+                <a16:creationId xmlns:a16="http://schemas.microsoft.com/office/drawing/2014/main" id="{F748C8A8-9D9B-48A9-91D3-E0208BD2BDD0}"/>
               </a:ext>
             </a:extLst>
           </p:cNvPr>
@@ -9616,7 +9844,7 @@
                 <a:ea typeface="Microsoft YaHei"/>
                 <a:cs typeface="Microsoft YaHei"/>
               </a:rPr>
-              <a:t>原文件回看</a:t>
+              <a:t>原文件核验</a:t>
             </a:r>
           </a:p>
         </p:txBody>
@@ -9626,7 +9854,7 @@
           <p:cNvPr id="9" name="">
             <a:extLst xmlns:a="http://schemas.openxmlformats.org/drawingml/2006/main">
               <a:ext uri="{FF2B5EF4-FFF2-40B4-BE49-F238E27FC236}">
-                <a16:creationId xmlns:a16="http://schemas.microsoft.com/office/drawing/2014/main" id="{D7193230-B1A4-45DA-AF39-3C11DDD374FE}"/>
+                <a16:creationId xmlns:a16="http://schemas.microsoft.com/office/drawing/2014/main" id="{A7C1E800-21CE-4C25-8024-EAD393F0EE0B}"/>
               </a:ext>
             </a:extLst>
           </p:cNvPr>
@@ -9673,7 +9901,7 @@
                 <a:ea typeface="Microsoft YaHei"/>
                 <a:cs typeface="Microsoft YaHei"/>
               </a:rPr>
-              <a:t>内容寻址与SHA核验；文档来源属于独立项目</a:t>
+              <a:t>检索/公式命中后重查SHA；篡改或缺失停止</a:t>
             </a:r>
           </a:p>
         </p:txBody>
@@ -9681,7 +9909,7 @@
     </p:spTree>
     <p:extLst>
       <p:ext uri="{BB962C8B-B14F-4D97-AF65-F5344CB8AC3E}">
-        <p14:creationId xmlns:p14="http://schemas.microsoft.com/office/powerpoint/2010/main" val="1890351214"/>
+        <p14:creationId xmlns:p14="http://schemas.microsoft.com/office/powerpoint/2010/main" val="168612631"/>
       </p:ext>
     </p:extLst>
   </p:cSld>
@@ -9712,7 +9940,7 @@
           <p:cNvPr id="10" name="">
             <a:extLst xmlns:a="http://schemas.openxmlformats.org/drawingml/2006/main">
               <a:ext uri="{FF2B5EF4-FFF2-40B4-BE49-F238E27FC236}">
-                <a16:creationId xmlns:a16="http://schemas.microsoft.com/office/drawing/2014/main" id="{F15DC09D-F258-4B2F-B242-E146F576F8BF}"/>
+                <a16:creationId xmlns:a16="http://schemas.microsoft.com/office/drawing/2014/main" id="{EE265891-B2AD-4231-BCDD-02DD5908A9E6}"/>
               </a:ext>
             </a:extLst>
           </p:cNvPr>
@@ -9769,7 +9997,7 @@
           <p:cNvPr id="2" name="">
             <a:extLst xmlns:a="http://schemas.openxmlformats.org/drawingml/2006/main">
               <a:ext uri="{FF2B5EF4-FFF2-40B4-BE49-F238E27FC236}">
-                <a16:creationId xmlns:a16="http://schemas.microsoft.com/office/drawing/2014/main" id="{5EBBADDD-FB5C-4476-8B24-EB9B7501088F}"/>
+                <a16:creationId xmlns:a16="http://schemas.microsoft.com/office/drawing/2014/main" id="{998D7705-B844-44C6-9B37-A3F3C696E13C}"/>
               </a:ext>
             </a:extLst>
           </p:cNvPr>
@@ -9826,7 +10054,7 @@
           <p:cNvPr id="3" name="">
             <a:extLst xmlns:a="http://schemas.openxmlformats.org/drawingml/2006/main">
               <a:ext uri="{FF2B5EF4-FFF2-40B4-BE49-F238E27FC236}">
-                <a16:creationId xmlns:a16="http://schemas.microsoft.com/office/drawing/2014/main" id="{2B35562B-2AD3-4F78-8BE8-2991A870D75E}"/>
+                <a16:creationId xmlns:a16="http://schemas.microsoft.com/office/drawing/2014/main" id="{B440C3A8-1073-41BC-990C-7B3453486EE7}"/>
               </a:ext>
             </a:extLst>
           </p:cNvPr>
@@ -9883,7 +10111,7 @@
           <p:cNvPr id="4" name="">
             <a:extLst xmlns:a="http://schemas.openxmlformats.org/drawingml/2006/main">
               <a:ext uri="{FF2B5EF4-FFF2-40B4-BE49-F238E27FC236}">
-                <a16:creationId xmlns:a16="http://schemas.microsoft.com/office/drawing/2014/main" id="{64270D82-7A3C-41E1-A086-01AA6CDCB981}"/>
+                <a16:creationId xmlns:a16="http://schemas.microsoft.com/office/drawing/2014/main" id="{C5683BF6-EE79-41ED-B19B-E3C09CA5884E}"/>
               </a:ext>
             </a:extLst>
           </p:cNvPr>
@@ -9940,7 +10168,7 @@
           <p:cNvPr id="5" name="">
             <a:extLst xmlns:a="http://schemas.openxmlformats.org/drawingml/2006/main">
               <a:ext uri="{FF2B5EF4-FFF2-40B4-BE49-F238E27FC236}">
-                <a16:creationId xmlns:a16="http://schemas.microsoft.com/office/drawing/2014/main" id="{799F06EB-8418-4470-9335-07C934C541B1}"/>
+                <a16:creationId xmlns:a16="http://schemas.microsoft.com/office/drawing/2014/main" id="{47528BD4-3920-45C8-956A-8496E5AC6D2F}"/>
               </a:ext>
             </a:extLst>
           </p:cNvPr>
@@ -9997,7 +10225,7 @@
           <p:cNvPr id="6" name="">
             <a:extLst xmlns:a="http://schemas.openxmlformats.org/drawingml/2006/main">
               <a:ext uri="{FF2B5EF4-FFF2-40B4-BE49-F238E27FC236}">
-                <a16:creationId xmlns:a16="http://schemas.microsoft.com/office/drawing/2014/main" id="{1C36893F-484B-4E14-821F-C0E0128F51B3}"/>
+                <a16:creationId xmlns:a16="http://schemas.microsoft.com/office/drawing/2014/main" id="{A2940262-4384-44E4-92C5-3A267AD1E032}"/>
               </a:ext>
             </a:extLst>
           </p:cNvPr>
@@ -10054,7 +10282,7 @@
           <p:cNvPr id="7" name="">
             <a:extLst xmlns:a="http://schemas.openxmlformats.org/drawingml/2006/main">
               <a:ext uri="{FF2B5EF4-FFF2-40B4-BE49-F238E27FC236}">
-                <a16:creationId xmlns:a16="http://schemas.microsoft.com/office/drawing/2014/main" id="{FDDE95E7-FAD4-4F59-907F-EAC487792B6B}"/>
+                <a16:creationId xmlns:a16="http://schemas.microsoft.com/office/drawing/2014/main" id="{A2A84FF9-872A-41EB-8D59-F3E7718FDEB8}"/>
               </a:ext>
             </a:extLst>
           </p:cNvPr>
@@ -10111,7 +10339,7 @@
           <p:cNvPr id="8" name="">
             <a:extLst xmlns:a="http://schemas.openxmlformats.org/drawingml/2006/main">
               <a:ext uri="{FF2B5EF4-FFF2-40B4-BE49-F238E27FC236}">
-                <a16:creationId xmlns:a16="http://schemas.microsoft.com/office/drawing/2014/main" id="{5D297D23-48E5-4E43-9E5C-8005A1DA8A0F}"/>
+                <a16:creationId xmlns:a16="http://schemas.microsoft.com/office/drawing/2014/main" id="{E892386A-BD12-4CD8-B619-5A2050C2F4B6}"/>
               </a:ext>
             </a:extLst>
           </p:cNvPr>
@@ -10168,7 +10396,7 @@
           <p:cNvPr id="9" name="">
             <a:extLst xmlns:a="http://schemas.openxmlformats.org/drawingml/2006/main">
               <a:ext uri="{FF2B5EF4-FFF2-40B4-BE49-F238E27FC236}">
-                <a16:creationId xmlns:a16="http://schemas.microsoft.com/office/drawing/2014/main" id="{730D50D4-2F6D-426C-A855-F8C500D00B44}"/>
+                <a16:creationId xmlns:a16="http://schemas.microsoft.com/office/drawing/2014/main" id="{2CCFEDDD-7BCD-4167-A4D1-3B2B87727274}"/>
               </a:ext>
             </a:extLst>
           </p:cNvPr>
@@ -10223,7 +10451,7 @@
     </p:spTree>
     <p:extLst>
       <p:ext uri="{BB962C8B-B14F-4D97-AF65-F5344CB8AC3E}">
-        <p14:creationId xmlns:p14="http://schemas.microsoft.com/office/powerpoint/2010/main" val="7136647"/>
+        <p14:creationId xmlns:p14="http://schemas.microsoft.com/office/powerpoint/2010/main" val="2064497941"/>
       </p:ext>
     </p:extLst>
   </p:cSld>
@@ -10254,7 +10482,7 @@
           <p:cNvPr id="4" name="">
             <a:extLst xmlns:a="http://schemas.openxmlformats.org/drawingml/2006/main">
               <a:ext uri="{FF2B5EF4-FFF2-40B4-BE49-F238E27FC236}">
-                <a16:creationId xmlns:a16="http://schemas.microsoft.com/office/drawing/2014/main" id="{1AA6F52F-33CC-4A8B-B1E5-164FAE2BCE50}"/>
+                <a16:creationId xmlns:a16="http://schemas.microsoft.com/office/drawing/2014/main" id="{91DE7EBB-9626-4156-A941-6F330F01EECD}"/>
               </a:ext>
             </a:extLst>
           </p:cNvPr>
@@ -10704,7 +10932,7 @@
           <p:cNvPr id="3" name="">
             <a:extLst xmlns:a="http://schemas.openxmlformats.org/drawingml/2006/main">
               <a:ext uri="{FF2B5EF4-FFF2-40B4-BE49-F238E27FC236}">
-                <a16:creationId xmlns:a16="http://schemas.microsoft.com/office/drawing/2014/main" id="{A68D5C01-AF9F-489E-B161-22A49432773D}"/>
+                <a16:creationId xmlns:a16="http://schemas.microsoft.com/office/drawing/2014/main" id="{6D9D3C20-E676-4076-8A99-07CE03F228C9}"/>
               </a:ext>
             </a:extLst>
           </p:cNvPr>
@@ -10759,7 +10987,7 @@
     </p:spTree>
     <p:extLst>
       <p:ext uri="{BB962C8B-B14F-4D97-AF65-F5344CB8AC3E}">
-        <p14:creationId xmlns:p14="http://schemas.microsoft.com/office/powerpoint/2010/main" val="2013743376"/>
+        <p14:creationId xmlns:p14="http://schemas.microsoft.com/office/powerpoint/2010/main" val="1074618977"/>
       </p:ext>
     </p:extLst>
   </p:cSld>
@@ -10790,7 +11018,7 @@
           <p:cNvPr id="4" name="">
             <a:extLst xmlns:a="http://schemas.openxmlformats.org/drawingml/2006/main">
               <a:ext uri="{FF2B5EF4-FFF2-40B4-BE49-F238E27FC236}">
-                <a16:creationId xmlns:a16="http://schemas.microsoft.com/office/drawing/2014/main" id="{A6D930AD-E657-48F5-9DE2-DBBF52D407AB}"/>
+                <a16:creationId xmlns:a16="http://schemas.microsoft.com/office/drawing/2014/main" id="{68B0A668-532A-4DD0-A114-3CB945BDE9AF}"/>
               </a:ext>
             </a:extLst>
           </p:cNvPr>
@@ -10950,7 +11178,7 @@
                           <a:ea typeface="Microsoft YaHei"/>
                           <a:cs typeface="Microsoft YaHei"/>
                         </a:rPr>
-                        <a:t>预测</a:t>
+                        <a:t>客单价</a:t>
                       </a:r>
                     </a:p>
                   </a:txBody>
@@ -10974,7 +11202,7 @@
                           <a:ea typeface="Microsoft YaHei"/>
                           <a:cs typeface="Microsoft YaHei"/>
                         </a:rPr>
-                        <a:t>文档公式 → SQL基准 → Excel参数</a:t>
+                        <a:t>文档公式 / SQL销售额与订单数</a:t>
                       </a:r>
                     </a:p>
                   </a:txBody>
@@ -10998,7 +11226,7 @@
                           <a:ea typeface="Microsoft YaHei"/>
                           <a:cs typeface="Microsoft YaHei"/>
                         </a:rPr>
-                        <a:t>年份 / 单位</a:t>
+                        <a:t>来源 / 零分母</a:t>
                       </a:r>
                     </a:p>
                   </a:txBody>
@@ -11024,7 +11252,7 @@
                           <a:ea typeface="Microsoft YaHei"/>
                           <a:cs typeface="Microsoft YaHei"/>
                         </a:rPr>
-                        <a:t>回款</a:t>
+                        <a:t>预测</a:t>
                       </a:r>
                     </a:p>
                   </a:txBody>
@@ -11048,7 +11276,7 @@
                           <a:ea typeface="Microsoft YaHei"/>
                           <a:cs typeface="Microsoft YaHei"/>
                         </a:rPr>
-                        <a:t>SQL金额 → Excel费率</a:t>
+                        <a:t>PDF公式 / SQL基准 / Excel参数</a:t>
                       </a:r>
                     </a:p>
                   </a:txBody>
@@ -11072,7 +11300,7 @@
                           <a:ea typeface="Microsoft YaHei"/>
                           <a:cs typeface="Microsoft YaHei"/>
                         </a:rPr>
-                        <a:t>百分数尺度</a:t>
+                        <a:t>年份 / 单位</a:t>
                       </a:r>
                     </a:p>
                   </a:txBody>
@@ -11098,7 +11326,7 @@
                           <a:ea typeface="Microsoft YaHei"/>
                           <a:cs typeface="Microsoft YaHei"/>
                         </a:rPr>
-                        <a:t>门槛</a:t>
+                        <a:t>地区问数</a:t>
                       </a:r>
                     </a:p>
                   </a:txBody>
@@ -11122,7 +11350,7 @@
                           <a:ea typeface="Microsoft YaHei"/>
                           <a:cs typeface="Microsoft YaHei"/>
                         </a:rPr>
-                        <a:t>SQL指标 → 文档阈值</a:t>
+                        <a:t>Excel地区作为SQL过滤</a:t>
                       </a:r>
                     </a:p>
                   </a:txBody>
@@ -11146,7 +11374,7 @@
                           <a:ea typeface="Microsoft YaHei"/>
                           <a:cs typeface="Microsoft YaHei"/>
                         </a:rPr>
-                        <a:t>原文 / 量纲</a:t>
+                        <a:t>单元格 / 实体</a:t>
                       </a:r>
                     </a:p>
                   </a:txBody>
@@ -11172,7 +11400,7 @@
                           <a:ea typeface="Microsoft YaHei"/>
                           <a:cs typeface="Microsoft YaHei"/>
                         </a:rPr>
-                        <a:t>政策</a:t>
+                        <a:t>冠军经验</a:t>
                       </a:r>
                     </a:p>
                   </a:txBody>
@@ -11196,7 +11424,7 @@
                           <a:ea typeface="Microsoft YaHei"/>
                           <a:cs typeface="Microsoft YaHei"/>
                         </a:rPr>
-                        <a:t>历史条款 → 问题日期</a:t>
+                        <a:t>SQL排名的实体用于文档检索</a:t>
                       </a:r>
                     </a:p>
                   </a:txBody>
@@ -11220,7 +11448,7 @@
                           <a:ea typeface="Microsoft YaHei"/>
                           <a:cs typeface="Microsoft YaHei"/>
                         </a:rPr>
-                        <a:t>生效 / 重叠</a:t>
+                        <a:t>实体 / 引用</a:t>
                       </a:r>
                     </a:p>
                   </a:txBody>
@@ -11246,7 +11474,7 @@
                           <a:ea typeface="Microsoft YaHei"/>
                           <a:cs typeface="Microsoft YaHei"/>
                         </a:rPr>
-                        <a:t>客户口径</a:t>
+                        <a:t>阈值比较</a:t>
                       </a:r>
                     </a:p>
                   </a:txBody>
@@ -11270,7 +11498,7 @@
                           <a:ea typeface="Microsoft YaHei"/>
                           <a:cs typeface="Microsoft YaHei"/>
                         </a:rPr>
-                        <a:t>SQL实体 → 文档说明</a:t>
+                        <a:t>文档事实与Excel阈值</a:t>
                       </a:r>
                     </a:p>
                   </a:txBody>
@@ -11294,7 +11522,7 @@
                           <a:ea typeface="Microsoft YaHei"/>
                           <a:cs typeface="Microsoft YaHei"/>
                         </a:rPr>
-                        <a:t>实体 / 引用</a:t>
+                        <a:t>来源 / 数值</a:t>
                       </a:r>
                     </a:p>
                   </a:txBody>
@@ -11314,7 +11542,7 @@
           <p:cNvPr id="3" name="">
             <a:extLst xmlns:a="http://schemas.openxmlformats.org/drawingml/2006/main">
               <a:ext uri="{FF2B5EF4-FFF2-40B4-BE49-F238E27FC236}">
-                <a16:creationId xmlns:a16="http://schemas.microsoft.com/office/drawing/2014/main" id="{7EE75F10-0116-44DE-9731-8D9CD6B456FD}"/>
+                <a16:creationId xmlns:a16="http://schemas.microsoft.com/office/drawing/2014/main" id="{87E81AC9-D098-42E5-9DB2-313044255DB6}"/>
               </a:ext>
             </a:extLst>
           </p:cNvPr>
@@ -11369,7 +11597,7 @@
     </p:spTree>
     <p:extLst>
       <p:ext uri="{BB962C8B-B14F-4D97-AF65-F5344CB8AC3E}">
-        <p14:creationId xmlns:p14="http://schemas.microsoft.com/office/powerpoint/2010/main" val="402341342"/>
+        <p14:creationId xmlns:p14="http://schemas.microsoft.com/office/powerpoint/2010/main" val="1105125109"/>
       </p:ext>
     </p:extLst>
   </p:cSld>
@@ -11400,7 +11628,7 @@
           <p:cNvPr id="10" name="">
             <a:extLst xmlns:a="http://schemas.openxmlformats.org/drawingml/2006/main">
               <a:ext uri="{FF2B5EF4-FFF2-40B4-BE49-F238E27FC236}">
-                <a16:creationId xmlns:a16="http://schemas.microsoft.com/office/drawing/2014/main" id="{B2A9C00C-8B22-4DD3-8ED3-7D06DAA06BC1}"/>
+                <a16:creationId xmlns:a16="http://schemas.microsoft.com/office/drawing/2014/main" id="{BA39CF1C-5EF3-4877-AD0A-64AE06F0D4B1}"/>
               </a:ext>
             </a:extLst>
           </p:cNvPr>
@@ -11457,7 +11685,7 @@
           <p:cNvPr id="2" name="">
             <a:extLst xmlns:a="http://schemas.openxmlformats.org/drawingml/2006/main">
               <a:ext uri="{FF2B5EF4-FFF2-40B4-BE49-F238E27FC236}">
-                <a16:creationId xmlns:a16="http://schemas.microsoft.com/office/drawing/2014/main" id="{B6F39CB5-74EF-47EC-B7D6-B40FC0DDC5F8}"/>
+                <a16:creationId xmlns:a16="http://schemas.microsoft.com/office/drawing/2014/main" id="{9C9DA2DF-0B3C-4F05-9B8F-EBC871F82EBD}"/>
               </a:ext>
             </a:extLst>
           </p:cNvPr>
@@ -11514,7 +11742,7 @@
           <p:cNvPr id="3" name="">
             <a:extLst xmlns:a="http://schemas.openxmlformats.org/drawingml/2006/main">
               <a:ext uri="{FF2B5EF4-FFF2-40B4-BE49-F238E27FC236}">
-                <a16:creationId xmlns:a16="http://schemas.microsoft.com/office/drawing/2014/main" id="{6FDB227E-3C0E-4253-A52B-8F9A04110E34}"/>
+                <a16:creationId xmlns:a16="http://schemas.microsoft.com/office/drawing/2014/main" id="{F2781A0D-25A7-4E3B-BCF2-26244B93C11B}"/>
               </a:ext>
             </a:extLst>
           </p:cNvPr>
@@ -11571,7 +11799,7 @@
           <p:cNvPr id="4" name="">
             <a:extLst xmlns:a="http://schemas.openxmlformats.org/drawingml/2006/main">
               <a:ext uri="{FF2B5EF4-FFF2-40B4-BE49-F238E27FC236}">
-                <a16:creationId xmlns:a16="http://schemas.microsoft.com/office/drawing/2014/main" id="{010ED4C0-8447-4979-ADE8-C78BC71F3BD7}"/>
+                <a16:creationId xmlns:a16="http://schemas.microsoft.com/office/drawing/2014/main" id="{C671DFA4-3802-42A8-975D-86E1A381F60C}"/>
               </a:ext>
             </a:extLst>
           </p:cNvPr>
@@ -11628,7 +11856,7 @@
           <p:cNvPr id="5" name="">
             <a:extLst xmlns:a="http://schemas.openxmlformats.org/drawingml/2006/main">
               <a:ext uri="{FF2B5EF4-FFF2-40B4-BE49-F238E27FC236}">
-                <a16:creationId xmlns:a16="http://schemas.microsoft.com/office/drawing/2014/main" id="{CC56B6CF-3FBB-4E4B-B7C8-2E6E97A17179}"/>
+                <a16:creationId xmlns:a16="http://schemas.microsoft.com/office/drawing/2014/main" id="{660ACCEF-D34B-49A9-B093-55C978626B03}"/>
               </a:ext>
             </a:extLst>
           </p:cNvPr>
@@ -11675,7 +11903,7 @@
                 <a:ea typeface="Microsoft YaHei"/>
                 <a:cs typeface="Microsoft YaHei"/>
               </a:rPr>
-              <a:t>Chinook 11表，0 few-shot开发验收</a:t>
+              <a:t>Chinook 12/12；差旅新Schema首次6/8修复后8/8</a:t>
             </a:r>
           </a:p>
         </p:txBody>
@@ -11685,7 +11913,7 @@
           <p:cNvPr id="6" name="">
             <a:extLst xmlns:a="http://schemas.openxmlformats.org/drawingml/2006/main">
               <a:ext uri="{FF2B5EF4-FFF2-40B4-BE49-F238E27FC236}">
-                <a16:creationId xmlns:a16="http://schemas.microsoft.com/office/drawing/2014/main" id="{364CEF98-8765-43AE-A530-727E6CDF5B00}"/>
+                <a16:creationId xmlns:a16="http://schemas.microsoft.com/office/drawing/2014/main" id="{F66E2808-A7B6-452F-8FFF-2556EBCB0462}"/>
               </a:ext>
             </a:extLst>
           </p:cNvPr>
@@ -11742,7 +11970,7 @@
           <p:cNvPr id="7" name="">
             <a:extLst xmlns:a="http://schemas.openxmlformats.org/drawingml/2006/main">
               <a:ext uri="{FF2B5EF4-FFF2-40B4-BE49-F238E27FC236}">
-                <a16:creationId xmlns:a16="http://schemas.microsoft.com/office/drawing/2014/main" id="{9A1ADC57-A7E6-469A-A472-69EEB3E6C5D1}"/>
+                <a16:creationId xmlns:a16="http://schemas.microsoft.com/office/drawing/2014/main" id="{411CAD05-F288-4B35-913B-E3E0B6FB3154}"/>
               </a:ext>
             </a:extLst>
           </p:cNvPr>
@@ -11789,7 +12017,7 @@
                 <a:ea typeface="Microsoft YaHei"/>
                 <a:cs typeface="Microsoft YaHei"/>
               </a:rPr>
-              <a:t>指标、值、时间和JOIN候选回填</a:t>
+              <a:t>指标/角色、时间与趋势粒度；刷新后继续追问</a:t>
             </a:r>
           </a:p>
         </p:txBody>
@@ -11799,7 +12027,7 @@
           <p:cNvPr id="8" name="">
             <a:extLst xmlns:a="http://schemas.openxmlformats.org/drawingml/2006/main">
               <a:ext uri="{FF2B5EF4-FFF2-40B4-BE49-F238E27FC236}">
-                <a16:creationId xmlns:a16="http://schemas.microsoft.com/office/drawing/2014/main" id="{E90824DF-B017-443A-94CF-AB0BF340D556}"/>
+                <a16:creationId xmlns:a16="http://schemas.microsoft.com/office/drawing/2014/main" id="{B7B1978E-2BFA-43EA-BE9C-53A195A4387A}"/>
               </a:ext>
             </a:extLst>
           </p:cNvPr>
@@ -11856,7 +12084,7 @@
           <p:cNvPr id="9" name="">
             <a:extLst xmlns:a="http://schemas.openxmlformats.org/drawingml/2006/main">
               <a:ext uri="{FF2B5EF4-FFF2-40B4-BE49-F238E27FC236}">
-                <a16:creationId xmlns:a16="http://schemas.microsoft.com/office/drawing/2014/main" id="{293F5ED4-C689-42D9-A836-21A4884F6ACB}"/>
+                <a16:creationId xmlns:a16="http://schemas.microsoft.com/office/drawing/2014/main" id="{434B9913-218C-45FD-9712-2408A294431C}"/>
               </a:ext>
             </a:extLst>
           </p:cNvPr>
@@ -11911,7 +12139,7 @@
     </p:spTree>
     <p:extLst>
       <p:ext uri="{BB962C8B-B14F-4D97-AF65-F5344CB8AC3E}">
-        <p14:creationId xmlns:p14="http://schemas.microsoft.com/office/powerpoint/2010/main" val="2064615464"/>
+        <p14:creationId xmlns:p14="http://schemas.microsoft.com/office/powerpoint/2010/main" val="1851987166"/>
       </p:ext>
     </p:extLst>
   </p:cSld>

</xml_diff>

<commit_message>
Audit model calls and verify sourced threshold comparisons
</commit_message>
<xml_diff>
--- a/delivery/05-anonymous-defense.pptx
+++ b/delivery/05-anonymous-defense.pptx
@@ -2,28 +2,28 @@
 <file path=ppt/presentation.xml><?xml version="1.0" encoding="utf-8"?>
 <p:presentation xmlns:p="http://schemas.openxmlformats.org/presentationml/2006/main">
   <p:sldMasterIdLst>
-    <p:sldMasterId xmlns:r="http://schemas.openxmlformats.org/officeDocument/2006/relationships" id="2147483648" r:id="Rb3e4cfbd2eeb495d"/>
+    <p:sldMasterId xmlns:r="http://schemas.openxmlformats.org/officeDocument/2006/relationships" id="2147483648" r:id="R3170255b0a8044bd"/>
   </p:sldMasterIdLst>
   <p:notesMasterIdLst>
-    <p:notesMasterId xmlns:r="http://schemas.openxmlformats.org/officeDocument/2006/relationships" r:id="R8381a4412e3548d4"/>
+    <p:notesMasterId xmlns:r="http://schemas.openxmlformats.org/officeDocument/2006/relationships" r:id="Ra208c0df8e4a4f27"/>
   </p:notesMasterIdLst>
   <p:sldIdLst>
-    <p:sldId xmlns:r="http://schemas.openxmlformats.org/officeDocument/2006/relationships" id="256" r:id="R73e98b2e37414b93"/>
-    <p:sldId xmlns:r="http://schemas.openxmlformats.org/officeDocument/2006/relationships" id="257" r:id="R8e062f51b48c4326"/>
-    <p:sldId xmlns:r="http://schemas.openxmlformats.org/officeDocument/2006/relationships" id="258" r:id="R964a5fe2ba484359"/>
-    <p:sldId xmlns:r="http://schemas.openxmlformats.org/officeDocument/2006/relationships" id="259" r:id="Rd1a1ed1bae5642b0"/>
-    <p:sldId xmlns:r="http://schemas.openxmlformats.org/officeDocument/2006/relationships" id="260" r:id="R561e6b9986024375"/>
-    <p:sldId xmlns:r="http://schemas.openxmlformats.org/officeDocument/2006/relationships" id="261" r:id="R6e996001829e4a36"/>
-    <p:sldId xmlns:r="http://schemas.openxmlformats.org/officeDocument/2006/relationships" id="262" r:id="R07660059119b4419"/>
-    <p:sldId xmlns:r="http://schemas.openxmlformats.org/officeDocument/2006/relationships" id="263" r:id="Rc18846d14dfe4560"/>
-    <p:sldId xmlns:r="http://schemas.openxmlformats.org/officeDocument/2006/relationships" id="264" r:id="Rf714aef349c34fc8"/>
-    <p:sldId xmlns:r="http://schemas.openxmlformats.org/officeDocument/2006/relationships" id="265" r:id="R2993407665794f3f"/>
-    <p:sldId xmlns:r="http://schemas.openxmlformats.org/officeDocument/2006/relationships" id="266" r:id="R0f22b0cfa2f84254"/>
-    <p:sldId xmlns:r="http://schemas.openxmlformats.org/officeDocument/2006/relationships" id="267" r:id="R4167a830e3d648e8"/>
-    <p:sldId xmlns:r="http://schemas.openxmlformats.org/officeDocument/2006/relationships" id="268" r:id="Rd8694f3ae236495c"/>
-    <p:sldId xmlns:r="http://schemas.openxmlformats.org/officeDocument/2006/relationships" id="269" r:id="R319d7c690ab44b93"/>
-    <p:sldId xmlns:r="http://schemas.openxmlformats.org/officeDocument/2006/relationships" id="270" r:id="R233ae3101b8240f9"/>
-    <p:sldId xmlns:r="http://schemas.openxmlformats.org/officeDocument/2006/relationships" id="271" r:id="R7a336842c5ba441c"/>
+    <p:sldId xmlns:r="http://schemas.openxmlformats.org/officeDocument/2006/relationships" id="256" r:id="R9166209c700c4f1b"/>
+    <p:sldId xmlns:r="http://schemas.openxmlformats.org/officeDocument/2006/relationships" id="257" r:id="R4538868d85d84591"/>
+    <p:sldId xmlns:r="http://schemas.openxmlformats.org/officeDocument/2006/relationships" id="258" r:id="R592ddaa9114c49d7"/>
+    <p:sldId xmlns:r="http://schemas.openxmlformats.org/officeDocument/2006/relationships" id="259" r:id="R302f0ecbcd2f41ec"/>
+    <p:sldId xmlns:r="http://schemas.openxmlformats.org/officeDocument/2006/relationships" id="260" r:id="Rcaa454024e174d6b"/>
+    <p:sldId xmlns:r="http://schemas.openxmlformats.org/officeDocument/2006/relationships" id="261" r:id="R9374d0339e574167"/>
+    <p:sldId xmlns:r="http://schemas.openxmlformats.org/officeDocument/2006/relationships" id="262" r:id="R459111cf45014a20"/>
+    <p:sldId xmlns:r="http://schemas.openxmlformats.org/officeDocument/2006/relationships" id="263" r:id="Rb33a41ab1dd24d5f"/>
+    <p:sldId xmlns:r="http://schemas.openxmlformats.org/officeDocument/2006/relationships" id="264" r:id="R303cd61ea88d4a0e"/>
+    <p:sldId xmlns:r="http://schemas.openxmlformats.org/officeDocument/2006/relationships" id="265" r:id="Rb764125e4e984c94"/>
+    <p:sldId xmlns:r="http://schemas.openxmlformats.org/officeDocument/2006/relationships" id="266" r:id="Rc6013ee156ed4c10"/>
+    <p:sldId xmlns:r="http://schemas.openxmlformats.org/officeDocument/2006/relationships" id="267" r:id="R0db7be1a74234c0f"/>
+    <p:sldId xmlns:r="http://schemas.openxmlformats.org/officeDocument/2006/relationships" id="268" r:id="R99cd467eaccf490a"/>
+    <p:sldId xmlns:r="http://schemas.openxmlformats.org/officeDocument/2006/relationships" id="269" r:id="R1e239f7a608a4d61"/>
+    <p:sldId xmlns:r="http://schemas.openxmlformats.org/officeDocument/2006/relationships" id="270" r:id="R3cc496c4eb0c463c"/>
+    <p:sldId xmlns:r="http://schemas.openxmlformats.org/officeDocument/2006/relationships" id="271" r:id="Rddd29c7f2c834391"/>
   </p:sldIdLst>
   <p:sldSz cx="12192000" cy="6858000"/>
   <p:notesSz cx="6858000" cy="9144000"/>
@@ -1554,7 +1554,7 @@
           <p:cNvPr id="3" name="Title">
             <a:extLst xmlns:a="http://schemas.openxmlformats.org/drawingml/2006/main">
               <a:ext uri="{FF2B5EF4-FFF2-40B4-BE49-F238E27FC236}">
-                <a16:creationId xmlns:a16="http://schemas.microsoft.com/office/drawing/2014/main" id="{AE0F6B7C-2419-4826-835B-FEBA10F6B0C7}"/>
+                <a16:creationId xmlns:a16="http://schemas.microsoft.com/office/drawing/2014/main" id="{F88DCF8F-5D28-4867-8E9A-735D2434CDFD}"/>
               </a:ext>
             </a:extLst>
           </p:cNvPr>
@@ -1701,7 +1701,7 @@
           <p:cNvPr id="2" name="Subtitle">
             <a:extLst xmlns:a="http://schemas.openxmlformats.org/drawingml/2006/main">
               <a:ext uri="{FF2B5EF4-FFF2-40B4-BE49-F238E27FC236}">
-                <a16:creationId xmlns:a16="http://schemas.microsoft.com/office/drawing/2014/main" id="{56A1051E-BF43-4CCA-A743-999C5E620550}"/>
+                <a16:creationId xmlns:a16="http://schemas.microsoft.com/office/drawing/2014/main" id="{42FBF063-6E4B-4CE9-820B-C9805FA21271}"/>
               </a:ext>
             </a:extLst>
           </p:cNvPr>
@@ -1865,7 +1865,7 @@
           <p:cNvPr id="2" name="Section title">
             <a:extLst xmlns:a="http://schemas.openxmlformats.org/drawingml/2006/main">
               <a:ext uri="{FF2B5EF4-FFF2-40B4-BE49-F238E27FC236}">
-                <a16:creationId xmlns:a16="http://schemas.microsoft.com/office/drawing/2014/main" id="{5EF7ECAB-E85B-47A4-8E3D-FA755BF3B8A1}"/>
+                <a16:creationId xmlns:a16="http://schemas.microsoft.com/office/drawing/2014/main" id="{9A5D5A79-BF29-4B7C-81C8-6FCFE1CB04B3}"/>
               </a:ext>
             </a:extLst>
           </p:cNvPr>
@@ -2029,7 +2029,7 @@
           <p:cNvPr id="3" name="Title">
             <a:extLst xmlns:a="http://schemas.openxmlformats.org/drawingml/2006/main">
               <a:ext uri="{FF2B5EF4-FFF2-40B4-BE49-F238E27FC236}">
-                <a16:creationId xmlns:a16="http://schemas.microsoft.com/office/drawing/2014/main" id="{722865D6-8C0A-45B7-858A-45C523914510}"/>
+                <a16:creationId xmlns:a16="http://schemas.microsoft.com/office/drawing/2014/main" id="{CF6888C3-758E-4321-BD35-2EDC9AA3D29D}"/>
               </a:ext>
             </a:extLst>
           </p:cNvPr>
@@ -2176,7 +2176,7 @@
           <p:cNvPr id="2" name="Body">
             <a:extLst xmlns:a="http://schemas.openxmlformats.org/drawingml/2006/main">
               <a:ext uri="{FF2B5EF4-FFF2-40B4-BE49-F238E27FC236}">
-                <a16:creationId xmlns:a16="http://schemas.microsoft.com/office/drawing/2014/main" id="{C68061A5-F1A1-483F-8B79-30387F247CBE}"/>
+                <a16:creationId xmlns:a16="http://schemas.microsoft.com/office/drawing/2014/main" id="{7B578389-CEE3-48E4-9C28-3EE04FF0C9FB}"/>
               </a:ext>
             </a:extLst>
           </p:cNvPr>
@@ -2340,7 +2340,7 @@
           <p:cNvPr id="4" name="Title">
             <a:extLst xmlns:a="http://schemas.openxmlformats.org/drawingml/2006/main">
               <a:ext uri="{FF2B5EF4-FFF2-40B4-BE49-F238E27FC236}">
-                <a16:creationId xmlns:a16="http://schemas.microsoft.com/office/drawing/2014/main" id="{037BEDA6-EC61-4B72-A776-E880BAB852CE}"/>
+                <a16:creationId xmlns:a16="http://schemas.microsoft.com/office/drawing/2014/main" id="{0B6D7EDD-25CE-4E7C-8ED7-A99B5A253556}"/>
               </a:ext>
             </a:extLst>
           </p:cNvPr>
@@ -2487,7 +2487,7 @@
           <p:cNvPr id="2" name="Left column">
             <a:extLst xmlns:a="http://schemas.openxmlformats.org/drawingml/2006/main">
               <a:ext uri="{FF2B5EF4-FFF2-40B4-BE49-F238E27FC236}">
-                <a16:creationId xmlns:a16="http://schemas.microsoft.com/office/drawing/2014/main" id="{B06C0EDC-61F5-497E-90D3-4311EE71D087}"/>
+                <a16:creationId xmlns:a16="http://schemas.microsoft.com/office/drawing/2014/main" id="{6A5B79E8-E69B-43E1-BABD-F1334C384057}"/>
               </a:ext>
             </a:extLst>
           </p:cNvPr>
@@ -2634,7 +2634,7 @@
           <p:cNvPr id="3" name="Right column">
             <a:extLst xmlns:a="http://schemas.openxmlformats.org/drawingml/2006/main">
               <a:ext uri="{FF2B5EF4-FFF2-40B4-BE49-F238E27FC236}">
-                <a16:creationId xmlns:a16="http://schemas.microsoft.com/office/drawing/2014/main" id="{10AE1147-142E-4A46-B86C-14350FE4C5E0}"/>
+                <a16:creationId xmlns:a16="http://schemas.microsoft.com/office/drawing/2014/main" id="{02DFCF8B-6405-4934-AB02-3FA42828C9C7}"/>
               </a:ext>
             </a:extLst>
           </p:cNvPr>
@@ -2798,7 +2798,7 @@
           <p:cNvPr id="3" name="Title">
             <a:extLst xmlns:a="http://schemas.openxmlformats.org/drawingml/2006/main">
               <a:ext uri="{FF2B5EF4-FFF2-40B4-BE49-F238E27FC236}">
-                <a16:creationId xmlns:a16="http://schemas.microsoft.com/office/drawing/2014/main" id="{A8545B46-E007-4966-BC90-556A4280287D}"/>
+                <a16:creationId xmlns:a16="http://schemas.microsoft.com/office/drawing/2014/main" id="{26C028E2-5B63-4556-B81B-ED577769E6A1}"/>
               </a:ext>
             </a:extLst>
           </p:cNvPr>
@@ -2945,7 +2945,7 @@
           <p:cNvPr id="2" name="Left column">
             <a:extLst xmlns:a="http://schemas.openxmlformats.org/drawingml/2006/main">
               <a:ext uri="{FF2B5EF4-FFF2-40B4-BE49-F238E27FC236}">
-                <a16:creationId xmlns:a16="http://schemas.microsoft.com/office/drawing/2014/main" id="{233F1279-0E6D-4B05-8E4B-FB0DE7E34922}"/>
+                <a16:creationId xmlns:a16="http://schemas.microsoft.com/office/drawing/2014/main" id="{2ADA8DD5-D97D-4AB2-A2A4-3DF538091FEF}"/>
               </a:ext>
             </a:extLst>
           </p:cNvPr>
@@ -3130,12 +3130,12 @@
   </p:cSld>
   <p:clrMap bg1="lt1" tx1="dk1" bg2="lt2" tx2="dk2" accent1="accent1" accent2="accent2" accent3="accent3" accent4="accent4" accent5="accent5" accent6="accent6" hlink="hlink" folHlink="folHlink"/>
   <p:sldLayoutIdLst>
-    <p:sldLayoutId xmlns:r="http://schemas.openxmlformats.org/officeDocument/2006/relationships" id="2147483649" r:id="Rf02375ae7a07427b"/>
-    <p:sldLayoutId xmlns:r="http://schemas.openxmlformats.org/officeDocument/2006/relationships" id="2147483650" r:id="Rae0781bd4fbb43c3"/>
-    <p:sldLayoutId xmlns:r="http://schemas.openxmlformats.org/officeDocument/2006/relationships" id="2147483651" r:id="Rc3416471717d449d"/>
-    <p:sldLayoutId xmlns:r="http://schemas.openxmlformats.org/officeDocument/2006/relationships" id="2147483652" r:id="R5f645ec8d130476b"/>
-    <p:sldLayoutId xmlns:r="http://schemas.openxmlformats.org/officeDocument/2006/relationships" id="2147483653" r:id="R31929f195d73447a"/>
-    <p:sldLayoutId xmlns:r="http://schemas.openxmlformats.org/officeDocument/2006/relationships" id="2147483654" r:id="R8999fcee88e243fc"/>
+    <p:sldLayoutId xmlns:r="http://schemas.openxmlformats.org/officeDocument/2006/relationships" id="2147483649" r:id="R86bf366aaf1c4046"/>
+    <p:sldLayoutId xmlns:r="http://schemas.openxmlformats.org/officeDocument/2006/relationships" id="2147483650" r:id="Rcd4efc20fdda4359"/>
+    <p:sldLayoutId xmlns:r="http://schemas.openxmlformats.org/officeDocument/2006/relationships" id="2147483651" r:id="Ra90fba74eda84970"/>
+    <p:sldLayoutId xmlns:r="http://schemas.openxmlformats.org/officeDocument/2006/relationships" id="2147483652" r:id="Re815614ce9cd45c3"/>
+    <p:sldLayoutId xmlns:r="http://schemas.openxmlformats.org/officeDocument/2006/relationships" id="2147483653" r:id="R87ffdfd9adec4ebe"/>
+    <p:sldLayoutId xmlns:r="http://schemas.openxmlformats.org/officeDocument/2006/relationships" id="2147483654" r:id="R47e0ca5964df4472"/>
   </p:sldLayoutIdLst>
   <p:txStyles>
     <p:titleStyle>
@@ -3847,7 +3847,7 @@
           <p:cNvPr id="4" name="">
             <a:extLst xmlns:a="http://schemas.openxmlformats.org/drawingml/2006/main">
               <a:ext uri="{FF2B5EF4-FFF2-40B4-BE49-F238E27FC236}">
-                <a16:creationId xmlns:a16="http://schemas.microsoft.com/office/drawing/2014/main" id="{9573D581-C1F5-415E-81A3-471B3A84DF3E}"/>
+                <a16:creationId xmlns:a16="http://schemas.microsoft.com/office/drawing/2014/main" id="{A724B90E-A87A-473D-9299-D77868E3C33A}"/>
               </a:ext>
             </a:extLst>
           </p:cNvPr>
@@ -3904,7 +3904,7 @@
           <p:cNvPr id="2" name="">
             <a:extLst xmlns:a="http://schemas.openxmlformats.org/drawingml/2006/main">
               <a:ext uri="{FF2B5EF4-FFF2-40B4-BE49-F238E27FC236}">
-                <a16:creationId xmlns:a16="http://schemas.microsoft.com/office/drawing/2014/main" id="{4BF3EB0D-7BA8-4E57-B52C-02EBF6C68637}"/>
+                <a16:creationId xmlns:a16="http://schemas.microsoft.com/office/drawing/2014/main" id="{AD63A16F-8878-453F-8B8D-191DA8BB3A91}"/>
               </a:ext>
             </a:extLst>
           </p:cNvPr>
@@ -3984,7 +3984,7 @@
           <p:cNvPr id="3" name="">
             <a:extLst xmlns:a="http://schemas.openxmlformats.org/drawingml/2006/main">
               <a:ext uri="{FF2B5EF4-FFF2-40B4-BE49-F238E27FC236}">
-                <a16:creationId xmlns:a16="http://schemas.microsoft.com/office/drawing/2014/main" id="{8D7322A4-F83E-4363-AA70-A9EC2DA44EA4}"/>
+                <a16:creationId xmlns:a16="http://schemas.microsoft.com/office/drawing/2014/main" id="{9799BDDA-7DB2-416E-99D2-5EEA84F94761}"/>
               </a:ext>
             </a:extLst>
           </p:cNvPr>
@@ -4039,7 +4039,7 @@
     </p:spTree>
     <p:extLst>
       <p:ext uri="{BB962C8B-B14F-4D97-AF65-F5344CB8AC3E}">
-        <p14:creationId xmlns:p14="http://schemas.microsoft.com/office/powerpoint/2010/main" val="1566871"/>
+        <p14:creationId xmlns:p14="http://schemas.microsoft.com/office/powerpoint/2010/main" val="1557409547"/>
       </p:ext>
     </p:extLst>
   </p:cSld>
@@ -4070,7 +4070,7 @@
           <p:cNvPr id="10" name="">
             <a:extLst xmlns:a="http://schemas.openxmlformats.org/drawingml/2006/main">
               <a:ext uri="{FF2B5EF4-FFF2-40B4-BE49-F238E27FC236}">
-                <a16:creationId xmlns:a16="http://schemas.microsoft.com/office/drawing/2014/main" id="{F7932547-1ECE-4CA9-A902-8771B7B7139A}"/>
+                <a16:creationId xmlns:a16="http://schemas.microsoft.com/office/drawing/2014/main" id="{66471FB2-0A9F-4E49-A43E-DD03C0346254}"/>
               </a:ext>
             </a:extLst>
           </p:cNvPr>
@@ -4127,7 +4127,7 @@
           <p:cNvPr id="2" name="">
             <a:extLst xmlns:a="http://schemas.openxmlformats.org/drawingml/2006/main">
               <a:ext uri="{FF2B5EF4-FFF2-40B4-BE49-F238E27FC236}">
-                <a16:creationId xmlns:a16="http://schemas.microsoft.com/office/drawing/2014/main" id="{C1FF683A-AD93-41F5-B6E7-E794F15E6811}"/>
+                <a16:creationId xmlns:a16="http://schemas.microsoft.com/office/drawing/2014/main" id="{67228BE2-F5B2-474F-A2D4-B144D6E971B8}"/>
               </a:ext>
             </a:extLst>
           </p:cNvPr>
@@ -4184,7 +4184,7 @@
           <p:cNvPr id="3" name="">
             <a:extLst xmlns:a="http://schemas.openxmlformats.org/drawingml/2006/main">
               <a:ext uri="{FF2B5EF4-FFF2-40B4-BE49-F238E27FC236}">
-                <a16:creationId xmlns:a16="http://schemas.microsoft.com/office/drawing/2014/main" id="{C0F72586-BCC6-421C-A575-37C7BA5E0564}"/>
+                <a16:creationId xmlns:a16="http://schemas.microsoft.com/office/drawing/2014/main" id="{7D090893-F542-402B-900D-DBDF56D504FC}"/>
               </a:ext>
             </a:extLst>
           </p:cNvPr>
@@ -4241,7 +4241,7 @@
           <p:cNvPr id="4" name="">
             <a:extLst xmlns:a="http://schemas.openxmlformats.org/drawingml/2006/main">
               <a:ext uri="{FF2B5EF4-FFF2-40B4-BE49-F238E27FC236}">
-                <a16:creationId xmlns:a16="http://schemas.microsoft.com/office/drawing/2014/main" id="{C4C4C21A-6EAD-4CE8-945E-6711F53D2B7B}"/>
+                <a16:creationId xmlns:a16="http://schemas.microsoft.com/office/drawing/2014/main" id="{B19FE79A-05BF-4257-83CB-1F5864141F31}"/>
               </a:ext>
             </a:extLst>
           </p:cNvPr>
@@ -4298,7 +4298,7 @@
           <p:cNvPr id="5" name="">
             <a:extLst xmlns:a="http://schemas.openxmlformats.org/drawingml/2006/main">
               <a:ext uri="{FF2B5EF4-FFF2-40B4-BE49-F238E27FC236}">
-                <a16:creationId xmlns:a16="http://schemas.microsoft.com/office/drawing/2014/main" id="{A8E54153-9EB5-4DBB-99DA-718DDA6179BC}"/>
+                <a16:creationId xmlns:a16="http://schemas.microsoft.com/office/drawing/2014/main" id="{E70EEFD3-C54B-4CD9-BC12-4D341127FECC}"/>
               </a:ext>
             </a:extLst>
           </p:cNvPr>
@@ -4355,7 +4355,7 @@
           <p:cNvPr id="6" name="">
             <a:extLst xmlns:a="http://schemas.openxmlformats.org/drawingml/2006/main">
               <a:ext uri="{FF2B5EF4-FFF2-40B4-BE49-F238E27FC236}">
-                <a16:creationId xmlns:a16="http://schemas.microsoft.com/office/drawing/2014/main" id="{78123FCF-451A-47A7-A70C-0E5F8EF0A4E9}"/>
+                <a16:creationId xmlns:a16="http://schemas.microsoft.com/office/drawing/2014/main" id="{5F13606C-09DD-4EC1-B9B7-790268344958}"/>
               </a:ext>
             </a:extLst>
           </p:cNvPr>
@@ -4412,7 +4412,7 @@
           <p:cNvPr id="7" name="">
             <a:extLst xmlns:a="http://schemas.openxmlformats.org/drawingml/2006/main">
               <a:ext uri="{FF2B5EF4-FFF2-40B4-BE49-F238E27FC236}">
-                <a16:creationId xmlns:a16="http://schemas.microsoft.com/office/drawing/2014/main" id="{4750DF89-DDA8-4668-834B-936A696BCD4F}"/>
+                <a16:creationId xmlns:a16="http://schemas.microsoft.com/office/drawing/2014/main" id="{C94A5DC1-A8FF-4E65-A5F4-1A96B56439A8}"/>
               </a:ext>
             </a:extLst>
           </p:cNvPr>
@@ -4469,7 +4469,7 @@
           <p:cNvPr id="8" name="">
             <a:extLst xmlns:a="http://schemas.openxmlformats.org/drawingml/2006/main">
               <a:ext uri="{FF2B5EF4-FFF2-40B4-BE49-F238E27FC236}">
-                <a16:creationId xmlns:a16="http://schemas.microsoft.com/office/drawing/2014/main" id="{A4585684-5E0C-4EFB-B282-66EF67715EC8}"/>
+                <a16:creationId xmlns:a16="http://schemas.microsoft.com/office/drawing/2014/main" id="{1DAFF1D3-4F43-4582-B143-38D52F82F6F7}"/>
               </a:ext>
             </a:extLst>
           </p:cNvPr>
@@ -4526,7 +4526,7 @@
           <p:cNvPr id="9" name="">
             <a:extLst xmlns:a="http://schemas.openxmlformats.org/drawingml/2006/main">
               <a:ext uri="{FF2B5EF4-FFF2-40B4-BE49-F238E27FC236}">
-                <a16:creationId xmlns:a16="http://schemas.microsoft.com/office/drawing/2014/main" id="{38CD8600-BE26-437A-9238-995797DEBBE0}"/>
+                <a16:creationId xmlns:a16="http://schemas.microsoft.com/office/drawing/2014/main" id="{F96F4006-4344-4B3B-BE8E-E45239C9BEAC}"/>
               </a:ext>
             </a:extLst>
           </p:cNvPr>
@@ -4581,7 +4581,7 @@
     </p:spTree>
     <p:extLst>
       <p:ext uri="{BB962C8B-B14F-4D97-AF65-F5344CB8AC3E}">
-        <p14:creationId xmlns:p14="http://schemas.microsoft.com/office/powerpoint/2010/main" val="813912126"/>
+        <p14:creationId xmlns:p14="http://schemas.microsoft.com/office/powerpoint/2010/main" val="722889917"/>
       </p:ext>
     </p:extLst>
   </p:cSld>
@@ -4612,7 +4612,7 @@
           <p:cNvPr id="4" name="">
             <a:extLst xmlns:a="http://schemas.openxmlformats.org/drawingml/2006/main">
               <a:ext uri="{FF2B5EF4-FFF2-40B4-BE49-F238E27FC236}">
-                <a16:creationId xmlns:a16="http://schemas.microsoft.com/office/drawing/2014/main" id="{117F83EC-D6A3-4B18-8C1F-3E8811EA0B7F}"/>
+                <a16:creationId xmlns:a16="http://schemas.microsoft.com/office/drawing/2014/main" id="{D3F368A8-75C9-494D-AD21-9AD86182C22E}"/>
               </a:ext>
             </a:extLst>
           </p:cNvPr>
@@ -5136,7 +5136,7 @@
           <p:cNvPr id="3" name="">
             <a:extLst xmlns:a="http://schemas.openxmlformats.org/drawingml/2006/main">
               <a:ext uri="{FF2B5EF4-FFF2-40B4-BE49-F238E27FC236}">
-                <a16:creationId xmlns:a16="http://schemas.microsoft.com/office/drawing/2014/main" id="{29BB685C-5B72-4A92-BB88-15896C007CFD}"/>
+                <a16:creationId xmlns:a16="http://schemas.microsoft.com/office/drawing/2014/main" id="{992FCE9E-1057-43F6-9B26-61BCC6D57B38}"/>
               </a:ext>
             </a:extLst>
           </p:cNvPr>
@@ -5191,7 +5191,7 @@
     </p:spTree>
     <p:extLst>
       <p:ext uri="{BB962C8B-B14F-4D97-AF65-F5344CB8AC3E}">
-        <p14:creationId xmlns:p14="http://schemas.microsoft.com/office/powerpoint/2010/main" val="49570744"/>
+        <p14:creationId xmlns:p14="http://schemas.microsoft.com/office/powerpoint/2010/main" val="1544677620"/>
       </p:ext>
     </p:extLst>
   </p:cSld>
@@ -5222,7 +5222,7 @@
           <p:cNvPr id="4" name="">
             <a:extLst xmlns:a="http://schemas.openxmlformats.org/drawingml/2006/main">
               <a:ext uri="{FF2B5EF4-FFF2-40B4-BE49-F238E27FC236}">
-                <a16:creationId xmlns:a16="http://schemas.microsoft.com/office/drawing/2014/main" id="{F41A84B1-8D2B-41CA-8806-DEC9AB60CE2D}"/>
+                <a16:creationId xmlns:a16="http://schemas.microsoft.com/office/drawing/2014/main" id="{DB310A13-C4B7-4D2C-BBFE-A90CD34D055D}"/>
               </a:ext>
             </a:extLst>
           </p:cNvPr>
@@ -5286,7 +5286,7 @@
         </p:xfrm>
         <a:graphic xmlns:a="http://schemas.openxmlformats.org/drawingml/2006/main">
           <a:graphicData uri="http://schemas.openxmlformats.org/drawingml/2006/chart">
-            <c:chart xmlns:r="http://schemas.openxmlformats.org/officeDocument/2006/relationships" xmlns:c="http://schemas.openxmlformats.org/drawingml/2006/chart" r:id="Rd1234f2219454977"/>
+            <c:chart xmlns:r="http://schemas.openxmlformats.org/officeDocument/2006/relationships" xmlns:c="http://schemas.openxmlformats.org/drawingml/2006/chart" r:id="R8967a727f4044fd6"/>
           </a:graphicData>
         </a:graphic>
       </p:graphicFrame>
@@ -5295,7 +5295,7 @@
           <p:cNvPr id="3" name="">
             <a:extLst xmlns:a="http://schemas.openxmlformats.org/drawingml/2006/main">
               <a:ext uri="{FF2B5EF4-FFF2-40B4-BE49-F238E27FC236}">
-                <a16:creationId xmlns:a16="http://schemas.microsoft.com/office/drawing/2014/main" id="{626B806A-7200-4485-B10B-81C29D35DE65}"/>
+                <a16:creationId xmlns:a16="http://schemas.microsoft.com/office/drawing/2014/main" id="{640735A9-D2FF-41F6-B183-C0BF5F0142EB}"/>
               </a:ext>
             </a:extLst>
           </p:cNvPr>
@@ -5350,7 +5350,7 @@
     </p:spTree>
     <p:extLst>
       <p:ext uri="{BB962C8B-B14F-4D97-AF65-F5344CB8AC3E}">
-        <p14:creationId xmlns:p14="http://schemas.microsoft.com/office/powerpoint/2010/main" val="43592801"/>
+        <p14:creationId xmlns:p14="http://schemas.microsoft.com/office/powerpoint/2010/main" val="1341099121"/>
       </p:ext>
     </p:extLst>
   </p:cSld>
@@ -5381,7 +5381,7 @@
           <p:cNvPr id="5" name="">
             <a:extLst xmlns:a="http://schemas.openxmlformats.org/drawingml/2006/main">
               <a:ext uri="{FF2B5EF4-FFF2-40B4-BE49-F238E27FC236}">
-                <a16:creationId xmlns:a16="http://schemas.microsoft.com/office/drawing/2014/main" id="{F7B44107-A0CA-4BEC-938F-7C4DB905523B}"/>
+                <a16:creationId xmlns:a16="http://schemas.microsoft.com/office/drawing/2014/main" id="{F17FBCB7-46EF-469C-A149-46CAA3DDE996}"/>
               </a:ext>
             </a:extLst>
           </p:cNvPr>
@@ -5854,7 +5854,7 @@
           <p:cNvPr id="3" name="">
             <a:extLst xmlns:a="http://schemas.openxmlformats.org/drawingml/2006/main">
               <a:ext uri="{FF2B5EF4-FFF2-40B4-BE49-F238E27FC236}">
-                <a16:creationId xmlns:a16="http://schemas.microsoft.com/office/drawing/2014/main" id="{9FCA9386-C7CE-4F03-9029-8B7CCA03F82A}"/>
+                <a16:creationId xmlns:a16="http://schemas.microsoft.com/office/drawing/2014/main" id="{73EF230B-869B-46DC-918D-8716F9C87881}"/>
               </a:ext>
             </a:extLst>
           </p:cNvPr>
@@ -5911,7 +5911,7 @@
           <p:cNvPr id="4" name="">
             <a:extLst xmlns:a="http://schemas.openxmlformats.org/drawingml/2006/main">
               <a:ext uri="{FF2B5EF4-FFF2-40B4-BE49-F238E27FC236}">
-                <a16:creationId xmlns:a16="http://schemas.microsoft.com/office/drawing/2014/main" id="{349F24B4-7F1F-4476-8C74-3217C874BE6F}"/>
+                <a16:creationId xmlns:a16="http://schemas.microsoft.com/office/drawing/2014/main" id="{C8759D53-964C-4867-8492-AEA7A8DB8013}"/>
               </a:ext>
             </a:extLst>
           </p:cNvPr>
@@ -5966,7 +5966,7 @@
     </p:spTree>
     <p:extLst>
       <p:ext uri="{BB962C8B-B14F-4D97-AF65-F5344CB8AC3E}">
-        <p14:creationId xmlns:p14="http://schemas.microsoft.com/office/powerpoint/2010/main" val="872316774"/>
+        <p14:creationId xmlns:p14="http://schemas.microsoft.com/office/powerpoint/2010/main" val="1103693219"/>
       </p:ext>
     </p:extLst>
   </p:cSld>
@@ -5997,7 +5997,7 @@
           <p:cNvPr id="10" name="">
             <a:extLst xmlns:a="http://schemas.openxmlformats.org/drawingml/2006/main">
               <a:ext uri="{FF2B5EF4-FFF2-40B4-BE49-F238E27FC236}">
-                <a16:creationId xmlns:a16="http://schemas.microsoft.com/office/drawing/2014/main" id="{DA8330FC-4B9B-4C48-944B-3826ED403B71}"/>
+                <a16:creationId xmlns:a16="http://schemas.microsoft.com/office/drawing/2014/main" id="{D298F44B-DF7F-4E82-B791-02FC47F24F74}"/>
               </a:ext>
             </a:extLst>
           </p:cNvPr>
@@ -6054,7 +6054,7 @@
           <p:cNvPr id="2" name="">
             <a:extLst xmlns:a="http://schemas.openxmlformats.org/drawingml/2006/main">
               <a:ext uri="{FF2B5EF4-FFF2-40B4-BE49-F238E27FC236}">
-                <a16:creationId xmlns:a16="http://schemas.microsoft.com/office/drawing/2014/main" id="{70CCF2EB-A069-4568-A74E-81368BF6A35B}"/>
+                <a16:creationId xmlns:a16="http://schemas.microsoft.com/office/drawing/2014/main" id="{29E47C8C-247C-44E2-A772-9395CCCCA91A}"/>
               </a:ext>
             </a:extLst>
           </p:cNvPr>
@@ -6111,7 +6111,7 @@
           <p:cNvPr id="3" name="">
             <a:extLst xmlns:a="http://schemas.openxmlformats.org/drawingml/2006/main">
               <a:ext uri="{FF2B5EF4-FFF2-40B4-BE49-F238E27FC236}">
-                <a16:creationId xmlns:a16="http://schemas.microsoft.com/office/drawing/2014/main" id="{7856278A-9479-44C5-81AF-93783077E62C}"/>
+                <a16:creationId xmlns:a16="http://schemas.microsoft.com/office/drawing/2014/main" id="{F8FB7A89-914A-4414-A72B-0A8897CBC371}"/>
               </a:ext>
             </a:extLst>
           </p:cNvPr>
@@ -6168,7 +6168,7 @@
           <p:cNvPr id="4" name="">
             <a:extLst xmlns:a="http://schemas.openxmlformats.org/drawingml/2006/main">
               <a:ext uri="{FF2B5EF4-FFF2-40B4-BE49-F238E27FC236}">
-                <a16:creationId xmlns:a16="http://schemas.microsoft.com/office/drawing/2014/main" id="{C7444F94-4167-444C-BDA1-648409EE1E12}"/>
+                <a16:creationId xmlns:a16="http://schemas.microsoft.com/office/drawing/2014/main" id="{3A030B92-E158-48FA-B055-D1C8DE28E212}"/>
               </a:ext>
             </a:extLst>
           </p:cNvPr>
@@ -6225,7 +6225,7 @@
           <p:cNvPr id="5" name="">
             <a:extLst xmlns:a="http://schemas.openxmlformats.org/drawingml/2006/main">
               <a:ext uri="{FF2B5EF4-FFF2-40B4-BE49-F238E27FC236}">
-                <a16:creationId xmlns:a16="http://schemas.microsoft.com/office/drawing/2014/main" id="{FF04AD1D-79DD-4860-B4B8-0200DC0604EF}"/>
+                <a16:creationId xmlns:a16="http://schemas.microsoft.com/office/drawing/2014/main" id="{9A6BA345-8789-40E4-8725-D0F2473C829C}"/>
               </a:ext>
             </a:extLst>
           </p:cNvPr>
@@ -6282,7 +6282,7 @@
           <p:cNvPr id="6" name="">
             <a:extLst xmlns:a="http://schemas.openxmlformats.org/drawingml/2006/main">
               <a:ext uri="{FF2B5EF4-FFF2-40B4-BE49-F238E27FC236}">
-                <a16:creationId xmlns:a16="http://schemas.microsoft.com/office/drawing/2014/main" id="{327403A7-602D-44F1-8EA8-FCB2247D8226}"/>
+                <a16:creationId xmlns:a16="http://schemas.microsoft.com/office/drawing/2014/main" id="{36AB7002-1481-42A2-BB5E-078D71F4FE3D}"/>
               </a:ext>
             </a:extLst>
           </p:cNvPr>
@@ -6339,7 +6339,7 @@
           <p:cNvPr id="7" name="">
             <a:extLst xmlns:a="http://schemas.openxmlformats.org/drawingml/2006/main">
               <a:ext uri="{FF2B5EF4-FFF2-40B4-BE49-F238E27FC236}">
-                <a16:creationId xmlns:a16="http://schemas.microsoft.com/office/drawing/2014/main" id="{49599C2D-D782-416D-BA68-83F1CC19B695}"/>
+                <a16:creationId xmlns:a16="http://schemas.microsoft.com/office/drawing/2014/main" id="{ECF28A60-2F36-497D-A979-0DD75B5793F2}"/>
               </a:ext>
             </a:extLst>
           </p:cNvPr>
@@ -6396,7 +6396,7 @@
           <p:cNvPr id="8" name="">
             <a:extLst xmlns:a="http://schemas.openxmlformats.org/drawingml/2006/main">
               <a:ext uri="{FF2B5EF4-FFF2-40B4-BE49-F238E27FC236}">
-                <a16:creationId xmlns:a16="http://schemas.microsoft.com/office/drawing/2014/main" id="{51690B43-A0FF-4648-9CC3-52000E41BC71}"/>
+                <a16:creationId xmlns:a16="http://schemas.microsoft.com/office/drawing/2014/main" id="{CB7B5BDE-2205-4C2C-8194-76E2E426B563}"/>
               </a:ext>
             </a:extLst>
           </p:cNvPr>
@@ -6453,7 +6453,7 @@
           <p:cNvPr id="9" name="">
             <a:extLst xmlns:a="http://schemas.openxmlformats.org/drawingml/2006/main">
               <a:ext uri="{FF2B5EF4-FFF2-40B4-BE49-F238E27FC236}">
-                <a16:creationId xmlns:a16="http://schemas.microsoft.com/office/drawing/2014/main" id="{B2236128-51A7-4155-8A0E-F91E26833308}"/>
+                <a16:creationId xmlns:a16="http://schemas.microsoft.com/office/drawing/2014/main" id="{0C509167-B465-4228-AE10-A36A96B85B82}"/>
               </a:ext>
             </a:extLst>
           </p:cNvPr>
@@ -6500,7 +6500,7 @@
                 <a:ea typeface="Microsoft YaHei"/>
                 <a:cs typeface="Microsoft YaHei"/>
               </a:rPr>
-              <a:t>468项通过；源文件、缺库、锁定失败均停止后步</a:t>
+              <a:t>524项通过；源文件、缺库、锁定失败均停止后步</a:t>
             </a:r>
           </a:p>
         </p:txBody>
@@ -6508,7 +6508,7 @@
     </p:spTree>
     <p:extLst>
       <p:ext uri="{BB962C8B-B14F-4D97-AF65-F5344CB8AC3E}">
-        <p14:creationId xmlns:p14="http://schemas.microsoft.com/office/powerpoint/2010/main" val="100244585"/>
+        <p14:creationId xmlns:p14="http://schemas.microsoft.com/office/powerpoint/2010/main" val="1591263393"/>
       </p:ext>
     </p:extLst>
   </p:cSld>
@@ -6539,7 +6539,7 @@
           <p:cNvPr id="10" name="">
             <a:extLst xmlns:a="http://schemas.openxmlformats.org/drawingml/2006/main">
               <a:ext uri="{FF2B5EF4-FFF2-40B4-BE49-F238E27FC236}">
-                <a16:creationId xmlns:a16="http://schemas.microsoft.com/office/drawing/2014/main" id="{E0E6573E-8F6E-40F4-8B06-C578FBB9AF6E}"/>
+                <a16:creationId xmlns:a16="http://schemas.microsoft.com/office/drawing/2014/main" id="{280E757F-B1CF-4E68-918A-442F13BF79EA}"/>
               </a:ext>
             </a:extLst>
           </p:cNvPr>
@@ -6596,7 +6596,7 @@
           <p:cNvPr id="2" name="">
             <a:extLst xmlns:a="http://schemas.openxmlformats.org/drawingml/2006/main">
               <a:ext uri="{FF2B5EF4-FFF2-40B4-BE49-F238E27FC236}">
-                <a16:creationId xmlns:a16="http://schemas.microsoft.com/office/drawing/2014/main" id="{0EC1CDD2-BAB1-4F61-8FE1-374645A4D68A}"/>
+                <a16:creationId xmlns:a16="http://schemas.microsoft.com/office/drawing/2014/main" id="{41A2E61F-24BA-422D-A361-41324D125A16}"/>
               </a:ext>
             </a:extLst>
           </p:cNvPr>
@@ -6653,7 +6653,7 @@
           <p:cNvPr id="3" name="">
             <a:extLst xmlns:a="http://schemas.openxmlformats.org/drawingml/2006/main">
               <a:ext uri="{FF2B5EF4-FFF2-40B4-BE49-F238E27FC236}">
-                <a16:creationId xmlns:a16="http://schemas.microsoft.com/office/drawing/2014/main" id="{7F1BE018-1AD1-4BF0-9386-27C6394965E5}"/>
+                <a16:creationId xmlns:a16="http://schemas.microsoft.com/office/drawing/2014/main" id="{B146110D-6B91-46D0-B57C-E8C40BE95C25}"/>
               </a:ext>
             </a:extLst>
           </p:cNvPr>
@@ -6710,7 +6710,7 @@
           <p:cNvPr id="4" name="">
             <a:extLst xmlns:a="http://schemas.openxmlformats.org/drawingml/2006/main">
               <a:ext uri="{FF2B5EF4-FFF2-40B4-BE49-F238E27FC236}">
-                <a16:creationId xmlns:a16="http://schemas.microsoft.com/office/drawing/2014/main" id="{47912D17-25F3-4F35-8066-197E18BBC82F}"/>
+                <a16:creationId xmlns:a16="http://schemas.microsoft.com/office/drawing/2014/main" id="{02229E28-7AE4-4138-A04F-ECDAC67B9161}"/>
               </a:ext>
             </a:extLst>
           </p:cNvPr>
@@ -6767,7 +6767,7 @@
           <p:cNvPr id="5" name="">
             <a:extLst xmlns:a="http://schemas.openxmlformats.org/drawingml/2006/main">
               <a:ext uri="{FF2B5EF4-FFF2-40B4-BE49-F238E27FC236}">
-                <a16:creationId xmlns:a16="http://schemas.microsoft.com/office/drawing/2014/main" id="{2B96649B-B4FC-4344-9003-C686CB45E2EA}"/>
+                <a16:creationId xmlns:a16="http://schemas.microsoft.com/office/drawing/2014/main" id="{6C837C07-0615-45E1-9320-6562A3C8B77C}"/>
               </a:ext>
             </a:extLst>
           </p:cNvPr>
@@ -6824,7 +6824,7 @@
           <p:cNvPr id="6" name="">
             <a:extLst xmlns:a="http://schemas.openxmlformats.org/drawingml/2006/main">
               <a:ext uri="{FF2B5EF4-FFF2-40B4-BE49-F238E27FC236}">
-                <a16:creationId xmlns:a16="http://schemas.microsoft.com/office/drawing/2014/main" id="{B52EE3CB-9EFD-4FC0-B643-61678724334E}"/>
+                <a16:creationId xmlns:a16="http://schemas.microsoft.com/office/drawing/2014/main" id="{8A7888C6-7F1D-4A6F-BAE1-1334C41D0752}"/>
               </a:ext>
             </a:extLst>
           </p:cNvPr>
@@ -6881,7 +6881,7 @@
           <p:cNvPr id="7" name="">
             <a:extLst xmlns:a="http://schemas.openxmlformats.org/drawingml/2006/main">
               <a:ext uri="{FF2B5EF4-FFF2-40B4-BE49-F238E27FC236}">
-                <a16:creationId xmlns:a16="http://schemas.microsoft.com/office/drawing/2014/main" id="{E9DE2135-B082-41C8-A6FA-C7473583E0E4}"/>
+                <a16:creationId xmlns:a16="http://schemas.microsoft.com/office/drawing/2014/main" id="{421E0F9C-7966-4EA9-9C9D-20B44E43C556}"/>
               </a:ext>
             </a:extLst>
           </p:cNvPr>
@@ -6938,7 +6938,7 @@
           <p:cNvPr id="8" name="">
             <a:extLst xmlns:a="http://schemas.openxmlformats.org/drawingml/2006/main">
               <a:ext uri="{FF2B5EF4-FFF2-40B4-BE49-F238E27FC236}">
-                <a16:creationId xmlns:a16="http://schemas.microsoft.com/office/drawing/2014/main" id="{8EB2FB1F-5714-4E7A-8CE1-04F04E4DD9E6}"/>
+                <a16:creationId xmlns:a16="http://schemas.microsoft.com/office/drawing/2014/main" id="{0338B5BA-D7A4-4AE1-AA41-1810BD60AB2B}"/>
               </a:ext>
             </a:extLst>
           </p:cNvPr>
@@ -6995,7 +6995,7 @@
           <p:cNvPr id="9" name="">
             <a:extLst xmlns:a="http://schemas.openxmlformats.org/drawingml/2006/main">
               <a:ext uri="{FF2B5EF4-FFF2-40B4-BE49-F238E27FC236}">
-                <a16:creationId xmlns:a16="http://schemas.microsoft.com/office/drawing/2014/main" id="{82876281-7048-4D05-AF2C-B9B2C8AD5DAC}"/>
+                <a16:creationId xmlns:a16="http://schemas.microsoft.com/office/drawing/2014/main" id="{C5163C35-67FB-43EF-B735-FEB914A9B60C}"/>
               </a:ext>
             </a:extLst>
           </p:cNvPr>
@@ -7050,7 +7050,7 @@
     </p:spTree>
     <p:extLst>
       <p:ext uri="{BB962C8B-B14F-4D97-AF65-F5344CB8AC3E}">
-        <p14:creationId xmlns:p14="http://schemas.microsoft.com/office/powerpoint/2010/main" val="1237987327"/>
+        <p14:creationId xmlns:p14="http://schemas.microsoft.com/office/powerpoint/2010/main" val="1576759941"/>
       </p:ext>
     </p:extLst>
   </p:cSld>
@@ -7081,7 +7081,7 @@
           <p:cNvPr id="10" name="">
             <a:extLst xmlns:a="http://schemas.openxmlformats.org/drawingml/2006/main">
               <a:ext uri="{FF2B5EF4-FFF2-40B4-BE49-F238E27FC236}">
-                <a16:creationId xmlns:a16="http://schemas.microsoft.com/office/drawing/2014/main" id="{06F1653F-24F8-4D96-A27E-6F4F29DBC47E}"/>
+                <a16:creationId xmlns:a16="http://schemas.microsoft.com/office/drawing/2014/main" id="{C0AC0880-5512-49E1-AF51-7F9E04FEB636}"/>
               </a:ext>
             </a:extLst>
           </p:cNvPr>
@@ -7138,7 +7138,7 @@
           <p:cNvPr id="2" name="">
             <a:extLst xmlns:a="http://schemas.openxmlformats.org/drawingml/2006/main">
               <a:ext uri="{FF2B5EF4-FFF2-40B4-BE49-F238E27FC236}">
-                <a16:creationId xmlns:a16="http://schemas.microsoft.com/office/drawing/2014/main" id="{932B69E1-9AC4-4595-B449-47D694D6412F}"/>
+                <a16:creationId xmlns:a16="http://schemas.microsoft.com/office/drawing/2014/main" id="{B9CDC708-A9BB-4328-9A4C-F476027D595B}"/>
               </a:ext>
             </a:extLst>
           </p:cNvPr>
@@ -7195,7 +7195,7 @@
           <p:cNvPr id="3" name="">
             <a:extLst xmlns:a="http://schemas.openxmlformats.org/drawingml/2006/main">
               <a:ext uri="{FF2B5EF4-FFF2-40B4-BE49-F238E27FC236}">
-                <a16:creationId xmlns:a16="http://schemas.microsoft.com/office/drawing/2014/main" id="{7FF78EF6-086E-4C7E-ABE0-244C0C7D1EBA}"/>
+                <a16:creationId xmlns:a16="http://schemas.microsoft.com/office/drawing/2014/main" id="{0C450F97-B32F-486C-AAB0-97A92BAD64D2}"/>
               </a:ext>
             </a:extLst>
           </p:cNvPr>
@@ -7252,7 +7252,7 @@
           <p:cNvPr id="4" name="">
             <a:extLst xmlns:a="http://schemas.openxmlformats.org/drawingml/2006/main">
               <a:ext uri="{FF2B5EF4-FFF2-40B4-BE49-F238E27FC236}">
-                <a16:creationId xmlns:a16="http://schemas.microsoft.com/office/drawing/2014/main" id="{AAA33650-4400-4BC1-BEEE-EDDD31AC001A}"/>
+                <a16:creationId xmlns:a16="http://schemas.microsoft.com/office/drawing/2014/main" id="{F8D82F23-754F-4974-B06B-74B3AEDC57F3}"/>
               </a:ext>
             </a:extLst>
           </p:cNvPr>
@@ -7309,7 +7309,7 @@
           <p:cNvPr id="5" name="">
             <a:extLst xmlns:a="http://schemas.openxmlformats.org/drawingml/2006/main">
               <a:ext uri="{FF2B5EF4-FFF2-40B4-BE49-F238E27FC236}">
-                <a16:creationId xmlns:a16="http://schemas.microsoft.com/office/drawing/2014/main" id="{365D017E-0B2C-411C-AC86-6277C3989B8D}"/>
+                <a16:creationId xmlns:a16="http://schemas.microsoft.com/office/drawing/2014/main" id="{C76C7D06-856F-46C1-AF85-08CD537AD831}"/>
               </a:ext>
             </a:extLst>
           </p:cNvPr>
@@ -7366,7 +7366,7 @@
           <p:cNvPr id="6" name="">
             <a:extLst xmlns:a="http://schemas.openxmlformats.org/drawingml/2006/main">
               <a:ext uri="{FF2B5EF4-FFF2-40B4-BE49-F238E27FC236}">
-                <a16:creationId xmlns:a16="http://schemas.microsoft.com/office/drawing/2014/main" id="{BC4A5092-A080-4327-B859-75C6B1EA8BE4}"/>
+                <a16:creationId xmlns:a16="http://schemas.microsoft.com/office/drawing/2014/main" id="{50AE94F5-8257-44CD-9EA0-823C15B35695}"/>
               </a:ext>
             </a:extLst>
           </p:cNvPr>
@@ -7423,7 +7423,7 @@
           <p:cNvPr id="7" name="">
             <a:extLst xmlns:a="http://schemas.openxmlformats.org/drawingml/2006/main">
               <a:ext uri="{FF2B5EF4-FFF2-40B4-BE49-F238E27FC236}">
-                <a16:creationId xmlns:a16="http://schemas.microsoft.com/office/drawing/2014/main" id="{4331D2CE-4AF4-470D-AF0E-0F9A47AA9E35}"/>
+                <a16:creationId xmlns:a16="http://schemas.microsoft.com/office/drawing/2014/main" id="{46E7764D-2E7F-4494-9146-F461DCB4B7E9}"/>
               </a:ext>
             </a:extLst>
           </p:cNvPr>
@@ -7480,7 +7480,7 @@
           <p:cNvPr id="8" name="">
             <a:extLst xmlns:a="http://schemas.openxmlformats.org/drawingml/2006/main">
               <a:ext uri="{FF2B5EF4-FFF2-40B4-BE49-F238E27FC236}">
-                <a16:creationId xmlns:a16="http://schemas.microsoft.com/office/drawing/2014/main" id="{4BD38A0E-1B51-43B8-AA55-B12FE14BED33}"/>
+                <a16:creationId xmlns:a16="http://schemas.microsoft.com/office/drawing/2014/main" id="{01D4AF4B-41C0-4EBF-B329-11AD7F662327}"/>
               </a:ext>
             </a:extLst>
           </p:cNvPr>
@@ -7537,7 +7537,7 @@
           <p:cNvPr id="9" name="">
             <a:extLst xmlns:a="http://schemas.openxmlformats.org/drawingml/2006/main">
               <a:ext uri="{FF2B5EF4-FFF2-40B4-BE49-F238E27FC236}">
-                <a16:creationId xmlns:a16="http://schemas.microsoft.com/office/drawing/2014/main" id="{4AF5C3C4-E7F3-48DB-AF74-64B58FF135F0}"/>
+                <a16:creationId xmlns:a16="http://schemas.microsoft.com/office/drawing/2014/main" id="{26F15EAE-EF8F-4A05-BF89-57A2DF0A8D79}"/>
               </a:ext>
             </a:extLst>
           </p:cNvPr>
@@ -7592,7 +7592,7 @@
     </p:spTree>
     <p:extLst>
       <p:ext uri="{BB962C8B-B14F-4D97-AF65-F5344CB8AC3E}">
-        <p14:creationId xmlns:p14="http://schemas.microsoft.com/office/powerpoint/2010/main" val="572966016"/>
+        <p14:creationId xmlns:p14="http://schemas.microsoft.com/office/powerpoint/2010/main" val="998100466"/>
       </p:ext>
     </p:extLst>
   </p:cSld>
@@ -7623,7 +7623,7 @@
           <p:cNvPr id="10" name="">
             <a:extLst xmlns:a="http://schemas.openxmlformats.org/drawingml/2006/main">
               <a:ext uri="{FF2B5EF4-FFF2-40B4-BE49-F238E27FC236}">
-                <a16:creationId xmlns:a16="http://schemas.microsoft.com/office/drawing/2014/main" id="{12093F8B-30A9-4E79-9B3B-BD082B316478}"/>
+                <a16:creationId xmlns:a16="http://schemas.microsoft.com/office/drawing/2014/main" id="{F3075ED9-F01C-4567-9FC6-AF8900E4EAC7}"/>
               </a:ext>
             </a:extLst>
           </p:cNvPr>
@@ -7680,7 +7680,7 @@
           <p:cNvPr id="2" name="">
             <a:extLst xmlns:a="http://schemas.openxmlformats.org/drawingml/2006/main">
               <a:ext uri="{FF2B5EF4-FFF2-40B4-BE49-F238E27FC236}">
-                <a16:creationId xmlns:a16="http://schemas.microsoft.com/office/drawing/2014/main" id="{0BFF26CB-00AE-4750-9D14-6448307AB1BC}"/>
+                <a16:creationId xmlns:a16="http://schemas.microsoft.com/office/drawing/2014/main" id="{6F51C093-4097-4B22-97F3-786FCC8B2465}"/>
               </a:ext>
             </a:extLst>
           </p:cNvPr>
@@ -7737,7 +7737,7 @@
           <p:cNvPr id="3" name="">
             <a:extLst xmlns:a="http://schemas.openxmlformats.org/drawingml/2006/main">
               <a:ext uri="{FF2B5EF4-FFF2-40B4-BE49-F238E27FC236}">
-                <a16:creationId xmlns:a16="http://schemas.microsoft.com/office/drawing/2014/main" id="{D50C6B1C-9042-438B-834C-1AF8E3B974D1}"/>
+                <a16:creationId xmlns:a16="http://schemas.microsoft.com/office/drawing/2014/main" id="{A43C007E-F05B-48F8-9F1A-9720EE592E3E}"/>
               </a:ext>
             </a:extLst>
           </p:cNvPr>
@@ -7794,7 +7794,7 @@
           <p:cNvPr id="4" name="">
             <a:extLst xmlns:a="http://schemas.openxmlformats.org/drawingml/2006/main">
               <a:ext uri="{FF2B5EF4-FFF2-40B4-BE49-F238E27FC236}">
-                <a16:creationId xmlns:a16="http://schemas.microsoft.com/office/drawing/2014/main" id="{58993E4A-A4DA-4578-85B0-46C22CFB916F}"/>
+                <a16:creationId xmlns:a16="http://schemas.microsoft.com/office/drawing/2014/main" id="{6B03C761-3C74-46CB-9515-682655F32265}"/>
               </a:ext>
             </a:extLst>
           </p:cNvPr>
@@ -7851,7 +7851,7 @@
           <p:cNvPr id="5" name="">
             <a:extLst xmlns:a="http://schemas.openxmlformats.org/drawingml/2006/main">
               <a:ext uri="{FF2B5EF4-FFF2-40B4-BE49-F238E27FC236}">
-                <a16:creationId xmlns:a16="http://schemas.microsoft.com/office/drawing/2014/main" id="{DC633AE7-9819-4C5A-91A3-3E230E3C6F18}"/>
+                <a16:creationId xmlns:a16="http://schemas.microsoft.com/office/drawing/2014/main" id="{23E1019C-3349-4E62-BC42-3E0549143670}"/>
               </a:ext>
             </a:extLst>
           </p:cNvPr>
@@ -7908,7 +7908,7 @@
           <p:cNvPr id="6" name="">
             <a:extLst xmlns:a="http://schemas.openxmlformats.org/drawingml/2006/main">
               <a:ext uri="{FF2B5EF4-FFF2-40B4-BE49-F238E27FC236}">
-                <a16:creationId xmlns:a16="http://schemas.microsoft.com/office/drawing/2014/main" id="{D98642C1-8663-4D78-B88F-4E27ED7EFA60}"/>
+                <a16:creationId xmlns:a16="http://schemas.microsoft.com/office/drawing/2014/main" id="{27421CC1-C7A0-4ECF-A7F8-E85B4B126C7A}"/>
               </a:ext>
             </a:extLst>
           </p:cNvPr>
@@ -7965,7 +7965,7 @@
           <p:cNvPr id="7" name="">
             <a:extLst xmlns:a="http://schemas.openxmlformats.org/drawingml/2006/main">
               <a:ext uri="{FF2B5EF4-FFF2-40B4-BE49-F238E27FC236}">
-                <a16:creationId xmlns:a16="http://schemas.microsoft.com/office/drawing/2014/main" id="{7E20A79C-C714-4724-9121-CC1DACD7F7F6}"/>
+                <a16:creationId xmlns:a16="http://schemas.microsoft.com/office/drawing/2014/main" id="{3696A9B9-3CBD-4764-8709-ABA33B8DFE3A}"/>
               </a:ext>
             </a:extLst>
           </p:cNvPr>
@@ -8022,7 +8022,7 @@
           <p:cNvPr id="8" name="">
             <a:extLst xmlns:a="http://schemas.openxmlformats.org/drawingml/2006/main">
               <a:ext uri="{FF2B5EF4-FFF2-40B4-BE49-F238E27FC236}">
-                <a16:creationId xmlns:a16="http://schemas.microsoft.com/office/drawing/2014/main" id="{1B21E8AF-B40B-4390-9771-AF36D936B191}"/>
+                <a16:creationId xmlns:a16="http://schemas.microsoft.com/office/drawing/2014/main" id="{DF798409-1D42-40D2-BC7E-F73DD88049F7}"/>
               </a:ext>
             </a:extLst>
           </p:cNvPr>
@@ -8079,7 +8079,7 @@
           <p:cNvPr id="9" name="">
             <a:extLst xmlns:a="http://schemas.openxmlformats.org/drawingml/2006/main">
               <a:ext uri="{FF2B5EF4-FFF2-40B4-BE49-F238E27FC236}">
-                <a16:creationId xmlns:a16="http://schemas.microsoft.com/office/drawing/2014/main" id="{64FA4EF8-EBE0-409E-8D86-1C70D5B73512}"/>
+                <a16:creationId xmlns:a16="http://schemas.microsoft.com/office/drawing/2014/main" id="{6AC2C068-2BD7-4BCA-B9E2-CA2D78825C7B}"/>
               </a:ext>
             </a:extLst>
           </p:cNvPr>
@@ -8134,7 +8134,7 @@
     </p:spTree>
     <p:extLst>
       <p:ext uri="{BB962C8B-B14F-4D97-AF65-F5344CB8AC3E}">
-        <p14:creationId xmlns:p14="http://schemas.microsoft.com/office/powerpoint/2010/main" val="1547659709"/>
+        <p14:creationId xmlns:p14="http://schemas.microsoft.com/office/powerpoint/2010/main" val="499784380"/>
       </p:ext>
     </p:extLst>
   </p:cSld>
@@ -8327,7 +8327,7 @@
           <p:cNvPr id="19" name="">
             <a:extLst xmlns:a="http://schemas.openxmlformats.org/drawingml/2006/main">
               <a:ext uri="{FF2B5EF4-FFF2-40B4-BE49-F238E27FC236}">
-                <a16:creationId xmlns:a16="http://schemas.microsoft.com/office/drawing/2014/main" id="{5D437A50-4A01-4FD8-9486-256535CEA04C}"/>
+                <a16:creationId xmlns:a16="http://schemas.microsoft.com/office/drawing/2014/main" id="{B6E1184D-7CE7-49DD-A2A2-8ACC62DAA069}"/>
               </a:ext>
             </a:extLst>
           </p:cNvPr>
@@ -8384,7 +8384,7 @@
           <p:cNvPr id="2" name="">
             <a:extLst xmlns:a="http://schemas.openxmlformats.org/drawingml/2006/main">
               <a:ext uri="{FF2B5EF4-FFF2-40B4-BE49-F238E27FC236}">
-                <a16:creationId xmlns:a16="http://schemas.microsoft.com/office/drawing/2014/main" id="{9620C640-55B7-4E48-B82F-AAAA944128A7}"/>
+                <a16:creationId xmlns:a16="http://schemas.microsoft.com/office/drawing/2014/main" id="{85B720EC-C3B1-4A3A-9E46-4D542EE27278}"/>
               </a:ext>
             </a:extLst>
           </p:cNvPr>
@@ -8445,7 +8445,7 @@
           <p:cNvPr id="3" name="">
             <a:extLst xmlns:a="http://schemas.openxmlformats.org/drawingml/2006/main">
               <a:ext uri="{FF2B5EF4-FFF2-40B4-BE49-F238E27FC236}">
-                <a16:creationId xmlns:a16="http://schemas.microsoft.com/office/drawing/2014/main" id="{4368CB8D-B4B9-4F9D-82D1-188C2D48B7F2}"/>
+                <a16:creationId xmlns:a16="http://schemas.microsoft.com/office/drawing/2014/main" id="{0A07910D-A96F-4930-BC9B-8171C730DC2E}"/>
               </a:ext>
             </a:extLst>
           </p:cNvPr>
@@ -8552,7 +8552,7 @@
           <p:cNvPr id="4" name="">
             <a:extLst xmlns:a="http://schemas.openxmlformats.org/drawingml/2006/main">
               <a:ext uri="{FF2B5EF4-FFF2-40B4-BE49-F238E27FC236}">
-                <a16:creationId xmlns:a16="http://schemas.microsoft.com/office/drawing/2014/main" id="{B985673E-3218-4524-9017-75FB4FF474B2}"/>
+                <a16:creationId xmlns:a16="http://schemas.microsoft.com/office/drawing/2014/main" id="{83A4CFA2-5306-436E-B4E2-EF43EFF3BDF8}"/>
               </a:ext>
             </a:extLst>
           </p:cNvPr>
@@ -8659,7 +8659,7 @@
           <p:cNvPr id="5" name="">
             <a:extLst xmlns:a="http://schemas.openxmlformats.org/drawingml/2006/main">
               <a:ext uri="{FF2B5EF4-FFF2-40B4-BE49-F238E27FC236}">
-                <a16:creationId xmlns:a16="http://schemas.microsoft.com/office/drawing/2014/main" id="{A971AF27-8D86-42C6-9920-D98A4692CA02}"/>
+                <a16:creationId xmlns:a16="http://schemas.microsoft.com/office/drawing/2014/main" id="{722D4EFF-1E49-4DD7-BC4B-8BAE9C7AA48E}"/>
               </a:ext>
             </a:extLst>
           </p:cNvPr>
@@ -8766,7 +8766,7 @@
           <p:cNvPr id="6" name="">
             <a:extLst xmlns:a="http://schemas.openxmlformats.org/drawingml/2006/main">
               <a:ext uri="{FF2B5EF4-FFF2-40B4-BE49-F238E27FC236}">
-                <a16:creationId xmlns:a16="http://schemas.microsoft.com/office/drawing/2014/main" id="{79AAB113-A70A-4C59-951F-F06455895A42}"/>
+                <a16:creationId xmlns:a16="http://schemas.microsoft.com/office/drawing/2014/main" id="{A237AB5E-EE97-41B9-97DF-5A263B940EBE}"/>
               </a:ext>
             </a:extLst>
           </p:cNvPr>
@@ -8825,7 +8825,7 @@
     </p:spTree>
     <p:extLst>
       <p:ext uri="{BB962C8B-B14F-4D97-AF65-F5344CB8AC3E}">
-        <p14:creationId xmlns:p14="http://schemas.microsoft.com/office/powerpoint/2010/main" val="2074214734"/>
+        <p14:creationId xmlns:p14="http://schemas.microsoft.com/office/powerpoint/2010/main" val="1442626601"/>
       </p:ext>
     </p:extLst>
   </p:cSld>
@@ -8856,7 +8856,7 @@
           <p:cNvPr id="10" name="">
             <a:extLst xmlns:a="http://schemas.openxmlformats.org/drawingml/2006/main">
               <a:ext uri="{FF2B5EF4-FFF2-40B4-BE49-F238E27FC236}">
-                <a16:creationId xmlns:a16="http://schemas.microsoft.com/office/drawing/2014/main" id="{4395C172-2731-4B66-900F-B1F4395381EA}"/>
+                <a16:creationId xmlns:a16="http://schemas.microsoft.com/office/drawing/2014/main" id="{78F260E0-4297-4753-9D22-BDD3CC72641F}"/>
               </a:ext>
             </a:extLst>
           </p:cNvPr>
@@ -8913,7 +8913,7 @@
           <p:cNvPr id="2" name="">
             <a:extLst xmlns:a="http://schemas.openxmlformats.org/drawingml/2006/main">
               <a:ext uri="{FF2B5EF4-FFF2-40B4-BE49-F238E27FC236}">
-                <a16:creationId xmlns:a16="http://schemas.microsoft.com/office/drawing/2014/main" id="{62461F44-080E-4E2C-B0D1-004A33BAEEBE}"/>
+                <a16:creationId xmlns:a16="http://schemas.microsoft.com/office/drawing/2014/main" id="{E1D3A295-1C29-42D7-ACE9-0A2E9C6042A2}"/>
               </a:ext>
             </a:extLst>
           </p:cNvPr>
@@ -8970,7 +8970,7 @@
           <p:cNvPr id="3" name="">
             <a:extLst xmlns:a="http://schemas.openxmlformats.org/drawingml/2006/main">
               <a:ext uri="{FF2B5EF4-FFF2-40B4-BE49-F238E27FC236}">
-                <a16:creationId xmlns:a16="http://schemas.microsoft.com/office/drawing/2014/main" id="{595EA3AD-A3D3-4658-AEB5-29164B3E67AD}"/>
+                <a16:creationId xmlns:a16="http://schemas.microsoft.com/office/drawing/2014/main" id="{50E0E20B-1925-45AF-A3C8-95E50E741823}"/>
               </a:ext>
             </a:extLst>
           </p:cNvPr>
@@ -9027,7 +9027,7 @@
           <p:cNvPr id="4" name="">
             <a:extLst xmlns:a="http://schemas.openxmlformats.org/drawingml/2006/main">
               <a:ext uri="{FF2B5EF4-FFF2-40B4-BE49-F238E27FC236}">
-                <a16:creationId xmlns:a16="http://schemas.microsoft.com/office/drawing/2014/main" id="{F8A68E33-372D-4AC6-857A-C2594458178A}"/>
+                <a16:creationId xmlns:a16="http://schemas.microsoft.com/office/drawing/2014/main" id="{20BAAC2B-82E1-4D6E-94E2-9F7E15AA1279}"/>
               </a:ext>
             </a:extLst>
           </p:cNvPr>
@@ -9084,7 +9084,7 @@
           <p:cNvPr id="5" name="">
             <a:extLst xmlns:a="http://schemas.openxmlformats.org/drawingml/2006/main">
               <a:ext uri="{FF2B5EF4-FFF2-40B4-BE49-F238E27FC236}">
-                <a16:creationId xmlns:a16="http://schemas.microsoft.com/office/drawing/2014/main" id="{FE345AB0-F0FB-4C0E-89D1-35974786FE80}"/>
+                <a16:creationId xmlns:a16="http://schemas.microsoft.com/office/drawing/2014/main" id="{4D89132C-2A12-41DA-8058-63AF488CCA35}"/>
               </a:ext>
             </a:extLst>
           </p:cNvPr>
@@ -9141,7 +9141,7 @@
           <p:cNvPr id="6" name="">
             <a:extLst xmlns:a="http://schemas.openxmlformats.org/drawingml/2006/main">
               <a:ext uri="{FF2B5EF4-FFF2-40B4-BE49-F238E27FC236}">
-                <a16:creationId xmlns:a16="http://schemas.microsoft.com/office/drawing/2014/main" id="{E86F120C-2034-461A-BE74-296C06FF34F9}"/>
+                <a16:creationId xmlns:a16="http://schemas.microsoft.com/office/drawing/2014/main" id="{B908C976-7F92-4EB7-8BED-1709153DC72D}"/>
               </a:ext>
             </a:extLst>
           </p:cNvPr>
@@ -9198,7 +9198,7 @@
           <p:cNvPr id="7" name="">
             <a:extLst xmlns:a="http://schemas.openxmlformats.org/drawingml/2006/main">
               <a:ext uri="{FF2B5EF4-FFF2-40B4-BE49-F238E27FC236}">
-                <a16:creationId xmlns:a16="http://schemas.microsoft.com/office/drawing/2014/main" id="{0F713359-61C3-4DA7-AF0A-D03C922D03BE}"/>
+                <a16:creationId xmlns:a16="http://schemas.microsoft.com/office/drawing/2014/main" id="{9A56D4BF-BD7B-4BE8-8D8F-2706F188EFEA}"/>
               </a:ext>
             </a:extLst>
           </p:cNvPr>
@@ -9255,7 +9255,7 @@
           <p:cNvPr id="8" name="">
             <a:extLst xmlns:a="http://schemas.openxmlformats.org/drawingml/2006/main">
               <a:ext uri="{FF2B5EF4-FFF2-40B4-BE49-F238E27FC236}">
-                <a16:creationId xmlns:a16="http://schemas.microsoft.com/office/drawing/2014/main" id="{059E49EC-4FEA-4388-9CFF-BFDF097563CE}"/>
+                <a16:creationId xmlns:a16="http://schemas.microsoft.com/office/drawing/2014/main" id="{6369BA61-8594-4EC1-831B-05F5BB4FEB62}"/>
               </a:ext>
             </a:extLst>
           </p:cNvPr>
@@ -9312,7 +9312,7 @@
           <p:cNvPr id="9" name="">
             <a:extLst xmlns:a="http://schemas.openxmlformats.org/drawingml/2006/main">
               <a:ext uri="{FF2B5EF4-FFF2-40B4-BE49-F238E27FC236}">
-                <a16:creationId xmlns:a16="http://schemas.microsoft.com/office/drawing/2014/main" id="{E43A515D-2226-413B-9B4D-C4D24B802E49}"/>
+                <a16:creationId xmlns:a16="http://schemas.microsoft.com/office/drawing/2014/main" id="{C540C561-8C43-4147-A049-E2BB48E36F5A}"/>
               </a:ext>
             </a:extLst>
           </p:cNvPr>
@@ -9367,7 +9367,7 @@
     </p:spTree>
     <p:extLst>
       <p:ext uri="{BB962C8B-B14F-4D97-AF65-F5344CB8AC3E}">
-        <p14:creationId xmlns:p14="http://schemas.microsoft.com/office/powerpoint/2010/main" val="2049076154"/>
+        <p14:creationId xmlns:p14="http://schemas.microsoft.com/office/powerpoint/2010/main" val="1716813915"/>
       </p:ext>
     </p:extLst>
   </p:cSld>
@@ -9398,7 +9398,7 @@
           <p:cNvPr id="10" name="">
             <a:extLst xmlns:a="http://schemas.openxmlformats.org/drawingml/2006/main">
               <a:ext uri="{FF2B5EF4-FFF2-40B4-BE49-F238E27FC236}">
-                <a16:creationId xmlns:a16="http://schemas.microsoft.com/office/drawing/2014/main" id="{2E8AD7BA-CA47-442F-AEB3-23945FD53646}"/>
+                <a16:creationId xmlns:a16="http://schemas.microsoft.com/office/drawing/2014/main" id="{087CD31D-BD36-4435-B0FA-B05326C11D49}"/>
               </a:ext>
             </a:extLst>
           </p:cNvPr>
@@ -9455,7 +9455,7 @@
           <p:cNvPr id="2" name="">
             <a:extLst xmlns:a="http://schemas.openxmlformats.org/drawingml/2006/main">
               <a:ext uri="{FF2B5EF4-FFF2-40B4-BE49-F238E27FC236}">
-                <a16:creationId xmlns:a16="http://schemas.microsoft.com/office/drawing/2014/main" id="{0A09AECF-0DC5-4450-B49F-4DF7E5ACBA99}"/>
+                <a16:creationId xmlns:a16="http://schemas.microsoft.com/office/drawing/2014/main" id="{41BD3690-D4A5-4381-A07E-B17131CA0C47}"/>
               </a:ext>
             </a:extLst>
           </p:cNvPr>
@@ -9512,7 +9512,7 @@
           <p:cNvPr id="3" name="">
             <a:extLst xmlns:a="http://schemas.openxmlformats.org/drawingml/2006/main">
               <a:ext uri="{FF2B5EF4-FFF2-40B4-BE49-F238E27FC236}">
-                <a16:creationId xmlns:a16="http://schemas.microsoft.com/office/drawing/2014/main" id="{5621C4E9-9CD1-469D-BE8C-E7BC00A90936}"/>
+                <a16:creationId xmlns:a16="http://schemas.microsoft.com/office/drawing/2014/main" id="{5BCEB3D9-4532-423D-9632-A80490D694F3}"/>
               </a:ext>
             </a:extLst>
           </p:cNvPr>
@@ -9569,7 +9569,7 @@
           <p:cNvPr id="4" name="">
             <a:extLst xmlns:a="http://schemas.openxmlformats.org/drawingml/2006/main">
               <a:ext uri="{FF2B5EF4-FFF2-40B4-BE49-F238E27FC236}">
-                <a16:creationId xmlns:a16="http://schemas.microsoft.com/office/drawing/2014/main" id="{AF471492-DBC3-4A32-8A48-899B2F11E9C9}"/>
+                <a16:creationId xmlns:a16="http://schemas.microsoft.com/office/drawing/2014/main" id="{3DE2EA90-5D86-459D-9E2F-543A1D29CEA8}"/>
               </a:ext>
             </a:extLst>
           </p:cNvPr>
@@ -9626,7 +9626,7 @@
           <p:cNvPr id="5" name="">
             <a:extLst xmlns:a="http://schemas.openxmlformats.org/drawingml/2006/main">
               <a:ext uri="{FF2B5EF4-FFF2-40B4-BE49-F238E27FC236}">
-                <a16:creationId xmlns:a16="http://schemas.microsoft.com/office/drawing/2014/main" id="{021CE93C-EC7A-426A-95B2-DD9DBF925C4E}"/>
+                <a16:creationId xmlns:a16="http://schemas.microsoft.com/office/drawing/2014/main" id="{0BF61B28-858B-46B7-A8F3-BDA514C5B884}"/>
               </a:ext>
             </a:extLst>
           </p:cNvPr>
@@ -9683,7 +9683,7 @@
           <p:cNvPr id="6" name="">
             <a:extLst xmlns:a="http://schemas.openxmlformats.org/drawingml/2006/main">
               <a:ext uri="{FF2B5EF4-FFF2-40B4-BE49-F238E27FC236}">
-                <a16:creationId xmlns:a16="http://schemas.microsoft.com/office/drawing/2014/main" id="{4D5BBD28-D314-435B-B7EA-A7B83993490E}"/>
+                <a16:creationId xmlns:a16="http://schemas.microsoft.com/office/drawing/2014/main" id="{5F0AF413-B3B3-47B6-8D6B-E11FA619F916}"/>
               </a:ext>
             </a:extLst>
           </p:cNvPr>
@@ -9740,7 +9740,7 @@
           <p:cNvPr id="7" name="">
             <a:extLst xmlns:a="http://schemas.openxmlformats.org/drawingml/2006/main">
               <a:ext uri="{FF2B5EF4-FFF2-40B4-BE49-F238E27FC236}">
-                <a16:creationId xmlns:a16="http://schemas.microsoft.com/office/drawing/2014/main" id="{592097ED-B4C6-427E-AE7E-EAC7E243ABA8}"/>
+                <a16:creationId xmlns:a16="http://schemas.microsoft.com/office/drawing/2014/main" id="{7EEE7DB0-962C-4BEE-A35E-EAA647C1ABFD}"/>
               </a:ext>
             </a:extLst>
           </p:cNvPr>
@@ -9797,7 +9797,7 @@
           <p:cNvPr id="8" name="">
             <a:extLst xmlns:a="http://schemas.openxmlformats.org/drawingml/2006/main">
               <a:ext uri="{FF2B5EF4-FFF2-40B4-BE49-F238E27FC236}">
-                <a16:creationId xmlns:a16="http://schemas.microsoft.com/office/drawing/2014/main" id="{F748C8A8-9D9B-48A9-91D3-E0208BD2BDD0}"/>
+                <a16:creationId xmlns:a16="http://schemas.microsoft.com/office/drawing/2014/main" id="{6B0B7801-0377-423C-B9DD-43F6231E3F33}"/>
               </a:ext>
             </a:extLst>
           </p:cNvPr>
@@ -9854,7 +9854,7 @@
           <p:cNvPr id="9" name="">
             <a:extLst xmlns:a="http://schemas.openxmlformats.org/drawingml/2006/main">
               <a:ext uri="{FF2B5EF4-FFF2-40B4-BE49-F238E27FC236}">
-                <a16:creationId xmlns:a16="http://schemas.microsoft.com/office/drawing/2014/main" id="{A7C1E800-21CE-4C25-8024-EAD393F0EE0B}"/>
+                <a16:creationId xmlns:a16="http://schemas.microsoft.com/office/drawing/2014/main" id="{AAF4EF69-84B0-42A1-B801-F300467956DE}"/>
               </a:ext>
             </a:extLst>
           </p:cNvPr>
@@ -9909,7 +9909,7 @@
     </p:spTree>
     <p:extLst>
       <p:ext uri="{BB962C8B-B14F-4D97-AF65-F5344CB8AC3E}">
-        <p14:creationId xmlns:p14="http://schemas.microsoft.com/office/powerpoint/2010/main" val="168612631"/>
+        <p14:creationId xmlns:p14="http://schemas.microsoft.com/office/powerpoint/2010/main" val="295440452"/>
       </p:ext>
     </p:extLst>
   </p:cSld>
@@ -9940,7 +9940,7 @@
           <p:cNvPr id="10" name="">
             <a:extLst xmlns:a="http://schemas.openxmlformats.org/drawingml/2006/main">
               <a:ext uri="{FF2B5EF4-FFF2-40B4-BE49-F238E27FC236}">
-                <a16:creationId xmlns:a16="http://schemas.microsoft.com/office/drawing/2014/main" id="{EE265891-B2AD-4231-BCDD-02DD5908A9E6}"/>
+                <a16:creationId xmlns:a16="http://schemas.microsoft.com/office/drawing/2014/main" id="{56AFD112-F82E-4AB4-B55C-6F6B567C8D21}"/>
               </a:ext>
             </a:extLst>
           </p:cNvPr>
@@ -9997,7 +9997,7 @@
           <p:cNvPr id="2" name="">
             <a:extLst xmlns:a="http://schemas.openxmlformats.org/drawingml/2006/main">
               <a:ext uri="{FF2B5EF4-FFF2-40B4-BE49-F238E27FC236}">
-                <a16:creationId xmlns:a16="http://schemas.microsoft.com/office/drawing/2014/main" id="{998D7705-B844-44C6-9B37-A3F3C696E13C}"/>
+                <a16:creationId xmlns:a16="http://schemas.microsoft.com/office/drawing/2014/main" id="{B3DC1C84-409B-4E4C-8843-3546A02D6658}"/>
               </a:ext>
             </a:extLst>
           </p:cNvPr>
@@ -10054,7 +10054,7 @@
           <p:cNvPr id="3" name="">
             <a:extLst xmlns:a="http://schemas.openxmlformats.org/drawingml/2006/main">
               <a:ext uri="{FF2B5EF4-FFF2-40B4-BE49-F238E27FC236}">
-                <a16:creationId xmlns:a16="http://schemas.microsoft.com/office/drawing/2014/main" id="{B440C3A8-1073-41BC-990C-7B3453486EE7}"/>
+                <a16:creationId xmlns:a16="http://schemas.microsoft.com/office/drawing/2014/main" id="{D95B11B5-C7E4-444F-85E0-C490AB4E58A7}"/>
               </a:ext>
             </a:extLst>
           </p:cNvPr>
@@ -10111,7 +10111,7 @@
           <p:cNvPr id="4" name="">
             <a:extLst xmlns:a="http://schemas.openxmlformats.org/drawingml/2006/main">
               <a:ext uri="{FF2B5EF4-FFF2-40B4-BE49-F238E27FC236}">
-                <a16:creationId xmlns:a16="http://schemas.microsoft.com/office/drawing/2014/main" id="{C5683BF6-EE79-41ED-B19B-E3C09CA5884E}"/>
+                <a16:creationId xmlns:a16="http://schemas.microsoft.com/office/drawing/2014/main" id="{2E0DCC32-218E-429E-B1DC-DD097E03F0FF}"/>
               </a:ext>
             </a:extLst>
           </p:cNvPr>
@@ -10168,7 +10168,7 @@
           <p:cNvPr id="5" name="">
             <a:extLst xmlns:a="http://schemas.openxmlformats.org/drawingml/2006/main">
               <a:ext uri="{FF2B5EF4-FFF2-40B4-BE49-F238E27FC236}">
-                <a16:creationId xmlns:a16="http://schemas.microsoft.com/office/drawing/2014/main" id="{47528BD4-3920-45C8-956A-8496E5AC6D2F}"/>
+                <a16:creationId xmlns:a16="http://schemas.microsoft.com/office/drawing/2014/main" id="{0A23B572-5970-4C1C-B1BA-D84ECD8EF285}"/>
               </a:ext>
             </a:extLst>
           </p:cNvPr>
@@ -10225,7 +10225,7 @@
           <p:cNvPr id="6" name="">
             <a:extLst xmlns:a="http://schemas.openxmlformats.org/drawingml/2006/main">
               <a:ext uri="{FF2B5EF4-FFF2-40B4-BE49-F238E27FC236}">
-                <a16:creationId xmlns:a16="http://schemas.microsoft.com/office/drawing/2014/main" id="{A2940262-4384-44E4-92C5-3A267AD1E032}"/>
+                <a16:creationId xmlns:a16="http://schemas.microsoft.com/office/drawing/2014/main" id="{849FD2A5-C01E-4E74-AD21-DBDEFA5F4B7A}"/>
               </a:ext>
             </a:extLst>
           </p:cNvPr>
@@ -10282,7 +10282,7 @@
           <p:cNvPr id="7" name="">
             <a:extLst xmlns:a="http://schemas.openxmlformats.org/drawingml/2006/main">
               <a:ext uri="{FF2B5EF4-FFF2-40B4-BE49-F238E27FC236}">
-                <a16:creationId xmlns:a16="http://schemas.microsoft.com/office/drawing/2014/main" id="{A2A84FF9-872A-41EB-8D59-F3E7718FDEB8}"/>
+                <a16:creationId xmlns:a16="http://schemas.microsoft.com/office/drawing/2014/main" id="{91BB9CAC-943D-44A3-BB8E-1F714BB96A2D}"/>
               </a:ext>
             </a:extLst>
           </p:cNvPr>
@@ -10339,7 +10339,7 @@
           <p:cNvPr id="8" name="">
             <a:extLst xmlns:a="http://schemas.openxmlformats.org/drawingml/2006/main">
               <a:ext uri="{FF2B5EF4-FFF2-40B4-BE49-F238E27FC236}">
-                <a16:creationId xmlns:a16="http://schemas.microsoft.com/office/drawing/2014/main" id="{E892386A-BD12-4CD8-B619-5A2050C2F4B6}"/>
+                <a16:creationId xmlns:a16="http://schemas.microsoft.com/office/drawing/2014/main" id="{BD1A5F1E-C822-4D5B-A9ED-526C921871C3}"/>
               </a:ext>
             </a:extLst>
           </p:cNvPr>
@@ -10396,7 +10396,7 @@
           <p:cNvPr id="9" name="">
             <a:extLst xmlns:a="http://schemas.openxmlformats.org/drawingml/2006/main">
               <a:ext uri="{FF2B5EF4-FFF2-40B4-BE49-F238E27FC236}">
-                <a16:creationId xmlns:a16="http://schemas.microsoft.com/office/drawing/2014/main" id="{2CCFEDDD-7BCD-4167-A4D1-3B2B87727274}"/>
+                <a16:creationId xmlns:a16="http://schemas.microsoft.com/office/drawing/2014/main" id="{F578C4E4-934F-4CC9-9B90-1593FD218357}"/>
               </a:ext>
             </a:extLst>
           </p:cNvPr>
@@ -10451,7 +10451,7 @@
     </p:spTree>
     <p:extLst>
       <p:ext uri="{BB962C8B-B14F-4D97-AF65-F5344CB8AC3E}">
-        <p14:creationId xmlns:p14="http://schemas.microsoft.com/office/powerpoint/2010/main" val="2064497941"/>
+        <p14:creationId xmlns:p14="http://schemas.microsoft.com/office/powerpoint/2010/main" val="29286636"/>
       </p:ext>
     </p:extLst>
   </p:cSld>
@@ -10482,7 +10482,7 @@
           <p:cNvPr id="4" name="">
             <a:extLst xmlns:a="http://schemas.openxmlformats.org/drawingml/2006/main">
               <a:ext uri="{FF2B5EF4-FFF2-40B4-BE49-F238E27FC236}">
-                <a16:creationId xmlns:a16="http://schemas.microsoft.com/office/drawing/2014/main" id="{91DE7EBB-9626-4156-A941-6F330F01EECD}"/>
+                <a16:creationId xmlns:a16="http://schemas.microsoft.com/office/drawing/2014/main" id="{380F2812-B5A3-4062-942E-487D0DE6DAC0}"/>
               </a:ext>
             </a:extLst>
           </p:cNvPr>
@@ -10932,7 +10932,7 @@
           <p:cNvPr id="3" name="">
             <a:extLst xmlns:a="http://schemas.openxmlformats.org/drawingml/2006/main">
               <a:ext uri="{FF2B5EF4-FFF2-40B4-BE49-F238E27FC236}">
-                <a16:creationId xmlns:a16="http://schemas.microsoft.com/office/drawing/2014/main" id="{6D9D3C20-E676-4076-8A99-07CE03F228C9}"/>
+                <a16:creationId xmlns:a16="http://schemas.microsoft.com/office/drawing/2014/main" id="{71BCCFD3-E3EA-4330-BD18-5DC95A5D3BB7}"/>
               </a:ext>
             </a:extLst>
           </p:cNvPr>
@@ -10987,7 +10987,7 @@
     </p:spTree>
     <p:extLst>
       <p:ext uri="{BB962C8B-B14F-4D97-AF65-F5344CB8AC3E}">
-        <p14:creationId xmlns:p14="http://schemas.microsoft.com/office/powerpoint/2010/main" val="1074618977"/>
+        <p14:creationId xmlns:p14="http://schemas.microsoft.com/office/powerpoint/2010/main" val="76215337"/>
       </p:ext>
     </p:extLst>
   </p:cSld>
@@ -11018,7 +11018,7 @@
           <p:cNvPr id="4" name="">
             <a:extLst xmlns:a="http://schemas.openxmlformats.org/drawingml/2006/main">
               <a:ext uri="{FF2B5EF4-FFF2-40B4-BE49-F238E27FC236}">
-                <a16:creationId xmlns:a16="http://schemas.microsoft.com/office/drawing/2014/main" id="{68B0A668-532A-4DD0-A114-3CB945BDE9AF}"/>
+                <a16:creationId xmlns:a16="http://schemas.microsoft.com/office/drawing/2014/main" id="{4AD6B304-64FC-4E21-9B44-3046ED30FC8A}"/>
               </a:ext>
             </a:extLst>
           </p:cNvPr>
@@ -11498,7 +11498,7 @@
                           <a:ea typeface="Microsoft YaHei"/>
                           <a:cs typeface="Microsoft YaHei"/>
                         </a:rPr>
-                        <a:t>文档事实与Excel阈值</a:t>
+                        <a:t>检索 / 来源事实 / Excel / le比较</a:t>
                       </a:r>
                     </a:p>
                   </a:txBody>
@@ -11522,7 +11522,7 @@
                           <a:ea typeface="Microsoft YaHei"/>
                           <a:cs typeface="Microsoft YaHei"/>
                         </a:rPr>
-                        <a:t>来源 / 数值</a:t>
+                        <a:t>原文 / 单位</a:t>
                       </a:r>
                     </a:p>
                   </a:txBody>
@@ -11542,7 +11542,7 @@
           <p:cNvPr id="3" name="">
             <a:extLst xmlns:a="http://schemas.openxmlformats.org/drawingml/2006/main">
               <a:ext uri="{FF2B5EF4-FFF2-40B4-BE49-F238E27FC236}">
-                <a16:creationId xmlns:a16="http://schemas.microsoft.com/office/drawing/2014/main" id="{87E81AC9-D098-42E5-9DB2-313044255DB6}"/>
+                <a16:creationId xmlns:a16="http://schemas.microsoft.com/office/drawing/2014/main" id="{0EA183B4-1562-419D-8205-FC29EA51AB00}"/>
               </a:ext>
             </a:extLst>
           </p:cNvPr>
@@ -11597,7 +11597,7 @@
     </p:spTree>
     <p:extLst>
       <p:ext uri="{BB962C8B-B14F-4D97-AF65-F5344CB8AC3E}">
-        <p14:creationId xmlns:p14="http://schemas.microsoft.com/office/powerpoint/2010/main" val="1105125109"/>
+        <p14:creationId xmlns:p14="http://schemas.microsoft.com/office/powerpoint/2010/main" val="2014492921"/>
       </p:ext>
     </p:extLst>
   </p:cSld>
@@ -11628,7 +11628,7 @@
           <p:cNvPr id="10" name="">
             <a:extLst xmlns:a="http://schemas.openxmlformats.org/drawingml/2006/main">
               <a:ext uri="{FF2B5EF4-FFF2-40B4-BE49-F238E27FC236}">
-                <a16:creationId xmlns:a16="http://schemas.microsoft.com/office/drawing/2014/main" id="{BA39CF1C-5EF3-4877-AD0A-64AE06F0D4B1}"/>
+                <a16:creationId xmlns:a16="http://schemas.microsoft.com/office/drawing/2014/main" id="{1DD04E45-F031-4874-8BD1-0482C9D2E028}"/>
               </a:ext>
             </a:extLst>
           </p:cNvPr>
@@ -11685,7 +11685,7 @@
           <p:cNvPr id="2" name="">
             <a:extLst xmlns:a="http://schemas.openxmlformats.org/drawingml/2006/main">
               <a:ext uri="{FF2B5EF4-FFF2-40B4-BE49-F238E27FC236}">
-                <a16:creationId xmlns:a16="http://schemas.microsoft.com/office/drawing/2014/main" id="{9C9DA2DF-0B3C-4F05-9B8F-EBC871F82EBD}"/>
+                <a16:creationId xmlns:a16="http://schemas.microsoft.com/office/drawing/2014/main" id="{2D405A94-13B2-4127-9E9B-0FC8CD1A7C60}"/>
               </a:ext>
             </a:extLst>
           </p:cNvPr>
@@ -11742,7 +11742,7 @@
           <p:cNvPr id="3" name="">
             <a:extLst xmlns:a="http://schemas.openxmlformats.org/drawingml/2006/main">
               <a:ext uri="{FF2B5EF4-FFF2-40B4-BE49-F238E27FC236}">
-                <a16:creationId xmlns:a16="http://schemas.microsoft.com/office/drawing/2014/main" id="{F2781A0D-25A7-4E3B-BCF2-26244B93C11B}"/>
+                <a16:creationId xmlns:a16="http://schemas.microsoft.com/office/drawing/2014/main" id="{E19AA240-0DB2-4041-AB94-18FB9F173363}"/>
               </a:ext>
             </a:extLst>
           </p:cNvPr>
@@ -11799,7 +11799,7 @@
           <p:cNvPr id="4" name="">
             <a:extLst xmlns:a="http://schemas.openxmlformats.org/drawingml/2006/main">
               <a:ext uri="{FF2B5EF4-FFF2-40B4-BE49-F238E27FC236}">
-                <a16:creationId xmlns:a16="http://schemas.microsoft.com/office/drawing/2014/main" id="{C671DFA4-3802-42A8-975D-86E1A381F60C}"/>
+                <a16:creationId xmlns:a16="http://schemas.microsoft.com/office/drawing/2014/main" id="{54EE12BB-0EA8-49CA-8A48-3FCDB4076D41}"/>
               </a:ext>
             </a:extLst>
           </p:cNvPr>
@@ -11856,7 +11856,7 @@
           <p:cNvPr id="5" name="">
             <a:extLst xmlns:a="http://schemas.openxmlformats.org/drawingml/2006/main">
               <a:ext uri="{FF2B5EF4-FFF2-40B4-BE49-F238E27FC236}">
-                <a16:creationId xmlns:a16="http://schemas.microsoft.com/office/drawing/2014/main" id="{660ACCEF-D34B-49A9-B093-55C978626B03}"/>
+                <a16:creationId xmlns:a16="http://schemas.microsoft.com/office/drawing/2014/main" id="{BD48A23B-5BFE-4D54-A8F1-4718FAA6A16F}"/>
               </a:ext>
             </a:extLst>
           </p:cNvPr>
@@ -11913,7 +11913,7 @@
           <p:cNvPr id="6" name="">
             <a:extLst xmlns:a="http://schemas.openxmlformats.org/drawingml/2006/main">
               <a:ext uri="{FF2B5EF4-FFF2-40B4-BE49-F238E27FC236}">
-                <a16:creationId xmlns:a16="http://schemas.microsoft.com/office/drawing/2014/main" id="{F66E2808-A7B6-452F-8FFF-2556EBCB0462}"/>
+                <a16:creationId xmlns:a16="http://schemas.microsoft.com/office/drawing/2014/main" id="{8DFDFAAC-FCA4-46DD-8D34-F61CD82531C9}"/>
               </a:ext>
             </a:extLst>
           </p:cNvPr>
@@ -11970,7 +11970,7 @@
           <p:cNvPr id="7" name="">
             <a:extLst xmlns:a="http://schemas.openxmlformats.org/drawingml/2006/main">
               <a:ext uri="{FF2B5EF4-FFF2-40B4-BE49-F238E27FC236}">
-                <a16:creationId xmlns:a16="http://schemas.microsoft.com/office/drawing/2014/main" id="{411CAD05-F288-4B35-913B-E3E0B6FB3154}"/>
+                <a16:creationId xmlns:a16="http://schemas.microsoft.com/office/drawing/2014/main" id="{C24A18E9-1CDD-48FC-8D9D-D3C69C8696EE}"/>
               </a:ext>
             </a:extLst>
           </p:cNvPr>
@@ -12027,7 +12027,7 @@
           <p:cNvPr id="8" name="">
             <a:extLst xmlns:a="http://schemas.openxmlformats.org/drawingml/2006/main">
               <a:ext uri="{FF2B5EF4-FFF2-40B4-BE49-F238E27FC236}">
-                <a16:creationId xmlns:a16="http://schemas.microsoft.com/office/drawing/2014/main" id="{B7B1978E-2BFA-43EA-BE9C-53A195A4387A}"/>
+                <a16:creationId xmlns:a16="http://schemas.microsoft.com/office/drawing/2014/main" id="{2C3674AE-D771-48F9-BF8D-1CCFFC39396B}"/>
               </a:ext>
             </a:extLst>
           </p:cNvPr>
@@ -12084,7 +12084,7 @@
           <p:cNvPr id="9" name="">
             <a:extLst xmlns:a="http://schemas.openxmlformats.org/drawingml/2006/main">
               <a:ext uri="{FF2B5EF4-FFF2-40B4-BE49-F238E27FC236}">
-                <a16:creationId xmlns:a16="http://schemas.microsoft.com/office/drawing/2014/main" id="{434B9913-218C-45FD-9712-2408A294431C}"/>
+                <a16:creationId xmlns:a16="http://schemas.microsoft.com/office/drawing/2014/main" id="{03050D33-11C6-45FC-AC8D-BADC21D34BFA}"/>
               </a:ext>
             </a:extLst>
           </p:cNvPr>
@@ -12139,7 +12139,7 @@
     </p:spTree>
     <p:extLst>
       <p:ext uri="{BB962C8B-B14F-4D97-AF65-F5344CB8AC3E}">
-        <p14:creationId xmlns:p14="http://schemas.microsoft.com/office/powerpoint/2010/main" val="1851987166"/>
+        <p14:creationId xmlns:p14="http://schemas.microsoft.com/office/powerpoint/2010/main" val="230033378"/>
       </p:ext>
     </p:extLst>
   </p:cSld>

</xml_diff>